<commit_message>
Adds power point stuff
</commit_message>
<xml_diff>
--- a/Python/CONTROL FLOW STRUCTURES (lessons #7 - )/Lesson +#7 - Making decisions (CFGs).pptx
+++ b/Python/CONTROL FLOW STRUCTURES (lessons #7 - )/Lesson +#7 - Making decisions (CFGs).pptx
@@ -9,12 +9,14 @@
     <p:sldId id="263" r:id="rId3"/>
     <p:sldId id="267" r:id="rId4"/>
     <p:sldId id="256" r:id="rId5"/>
-    <p:sldId id="264" r:id="rId6"/>
-    <p:sldId id="262" r:id="rId7"/>
-    <p:sldId id="265" r:id="rId8"/>
-    <p:sldId id="266" r:id="rId9"/>
-    <p:sldId id="260" r:id="rId10"/>
-    <p:sldId id="261" r:id="rId11"/>
+    <p:sldId id="268" r:id="rId6"/>
+    <p:sldId id="269" r:id="rId7"/>
+    <p:sldId id="264" r:id="rId8"/>
+    <p:sldId id="262" r:id="rId9"/>
+    <p:sldId id="265" r:id="rId10"/>
+    <p:sldId id="266" r:id="rId11"/>
+    <p:sldId id="260" r:id="rId12"/>
+    <p:sldId id="261" r:id="rId13"/>
   </p:sldIdLst>
   <p:sldSz cx="12192000" cy="6858000"/>
   <p:notesSz cx="6858000" cy="9144000"/>
@@ -3547,7 +3549,7 @@
           <p:cNvPr id="2" name="Título 1">
             <a:extLst>
               <a:ext uri="{FF2B5EF4-FFF2-40B4-BE49-F238E27FC236}">
-                <a16:creationId xmlns:a16="http://schemas.microsoft.com/office/drawing/2014/main" id="{B0CB5DFC-30DB-1EBB-370A-153992193F6A}"/>
+                <a16:creationId xmlns:a16="http://schemas.microsoft.com/office/drawing/2014/main" id="{D124B94B-EA6C-22DA-E37D-4574F40ABF16}"/>
               </a:ext>
             </a:extLst>
           </p:cNvPr>
@@ -3564,11 +3566,112 @@
           <a:lstStyle/>
           <a:p>
             <a:r>
+              <a:rPr lang="en-US" dirty="0"/>
+              <a:t>It’s very easy to </a:t>
+            </a:r>
+            <a:r>
+              <a:rPr lang="en-US" b="1" i="1" dirty="0">
+                <a:solidFill>
+                  <a:srgbClr val="C00000"/>
+                </a:solidFill>
+              </a:rPr>
+              <a:t>get lost</a:t>
+            </a:r>
+            <a:r>
+              <a:rPr lang="en-US" dirty="0"/>
+              <a:t>… right?</a:t>
+            </a:r>
+          </a:p>
+        </p:txBody>
+      </p:sp>
+      <p:sp>
+        <p:nvSpPr>
+          <p:cNvPr id="3" name="Marcador de contenido 2">
+            <a:extLst>
+              <a:ext uri="{FF2B5EF4-FFF2-40B4-BE49-F238E27FC236}">
+                <a16:creationId xmlns:a16="http://schemas.microsoft.com/office/drawing/2014/main" id="{51B2091F-F58B-2073-ED14-0B909D8B1E24}"/>
+              </a:ext>
+            </a:extLst>
+          </p:cNvPr>
+          <p:cNvSpPr>
+            <a:spLocks noGrp="1"/>
+          </p:cNvSpPr>
+          <p:nvPr>
+            <p:ph idx="1"/>
+          </p:nvPr>
+        </p:nvSpPr>
+        <p:spPr/>
+        <p:txBody>
+          <a:bodyPr/>
+          <a:lstStyle/>
+          <a:p>
+            <a:pPr marL="0" indent="0">
+              <a:buNone/>
+            </a:pPr>
+            <a:r>
+              <a:rPr lang="en-US" dirty="0"/>
+              <a:t>If you get lost when coding, do your own drawings on pen and paper!</a:t>
+            </a:r>
+          </a:p>
+        </p:txBody>
+      </p:sp>
+    </p:spTree>
+    <p:extLst>
+      <p:ext uri="{BB962C8B-B14F-4D97-AF65-F5344CB8AC3E}">
+        <p14:creationId xmlns:p14="http://schemas.microsoft.com/office/powerpoint/2010/main" val="202441297"/>
+      </p:ext>
+    </p:extLst>
+  </p:cSld>
+  <p:clrMapOvr>
+    <a:masterClrMapping/>
+  </p:clrMapOvr>
+</p:sld>
+</file>
+
+<file path=ppt/slides/slide11.xml><?xml version="1.0" encoding="utf-8"?>
+<p:sld xmlns:a="http://schemas.openxmlformats.org/drawingml/2006/main" xmlns:r="http://schemas.openxmlformats.org/officeDocument/2006/relationships" xmlns:p="http://schemas.openxmlformats.org/presentationml/2006/main">
+  <p:cSld>
+    <p:spTree>
+      <p:nvGrpSpPr>
+        <p:cNvPr id="1" name=""/>
+        <p:cNvGrpSpPr/>
+        <p:nvPr/>
+      </p:nvGrpSpPr>
+      <p:grpSpPr>
+        <a:xfrm>
+          <a:off x="0" y="0"/>
+          <a:ext cx="0" cy="0"/>
+          <a:chOff x="0" y="0"/>
+          <a:chExt cx="0" cy="0"/>
+        </a:xfrm>
+      </p:grpSpPr>
+      <p:sp>
+        <p:nvSpPr>
+          <p:cNvPr id="2" name="Título 1">
+            <a:extLst>
+              <a:ext uri="{FF2B5EF4-FFF2-40B4-BE49-F238E27FC236}">
+                <a16:creationId xmlns:a16="http://schemas.microsoft.com/office/drawing/2014/main" id="{BAAA4A2C-E2FF-62C5-40E9-8254794D89C9}"/>
+              </a:ext>
+            </a:extLst>
+          </p:cNvPr>
+          <p:cNvSpPr>
+            <a:spLocks noGrp="1"/>
+          </p:cNvSpPr>
+          <p:nvPr>
+            <p:ph type="title"/>
+          </p:nvPr>
+        </p:nvSpPr>
+        <p:spPr/>
+        <p:txBody>
+          <a:bodyPr/>
+          <a:lstStyle/>
+          <a:p>
+            <a:r>
               <a:rPr lang="es-AR" b="1" dirty="0" err="1">
                 <a:latin typeface="Consolas" panose="020B0609020204030204" pitchFamily="49" charset="0"/>
                 <a:cs typeface="Cascadia Code SemiBold" panose="020B0609020000020004" pitchFamily="49" charset="0"/>
               </a:rPr>
-              <a:t>For</a:t>
+              <a:t>While</a:t>
             </a:r>
             <a:br>
               <a:rPr lang="es-AR" dirty="0"/>
@@ -3603,11 +3706,1492 @@
               </a:rPr>
               <a:t>)</a:t>
             </a:r>
+            <a:endParaRPr lang="en-US" dirty="0"/>
+          </a:p>
+        </p:txBody>
+      </p:sp>
+      <p:sp>
+        <p:nvSpPr>
+          <p:cNvPr id="4" name="Forma libre: forma 3">
+            <a:extLst>
+              <a:ext uri="{FF2B5EF4-FFF2-40B4-BE49-F238E27FC236}">
+                <a16:creationId xmlns:a16="http://schemas.microsoft.com/office/drawing/2014/main" id="{89AFC35C-0164-5A16-A2B1-84D916E242D9}"/>
+              </a:ext>
+            </a:extLst>
+          </p:cNvPr>
+          <p:cNvSpPr/>
+          <p:nvPr/>
+        </p:nvSpPr>
+        <p:spPr>
+          <a:xfrm>
+            <a:off x="838200" y="2756079"/>
+            <a:ext cx="1177254" cy="2786130"/>
+          </a:xfrm>
+          <a:custGeom>
+            <a:avLst/>
+            <a:gdLst>
+              <a:gd name="connsiteX0" fmla="*/ 1268696 w 1907325"/>
+              <a:gd name="connsiteY0" fmla="*/ 0 h 4513942"/>
+              <a:gd name="connsiteX1" fmla="*/ 1544467 w 1907325"/>
+              <a:gd name="connsiteY1" fmla="*/ 348342 h 4513942"/>
+              <a:gd name="connsiteX2" fmla="*/ 1762181 w 1907325"/>
+              <a:gd name="connsiteY2" fmla="*/ 914400 h 4513942"/>
+              <a:gd name="connsiteX3" fmla="*/ 1776696 w 1907325"/>
+              <a:gd name="connsiteY3" fmla="*/ 1524000 h 4513942"/>
+              <a:gd name="connsiteX4" fmla="*/ 1500924 w 1907325"/>
+              <a:gd name="connsiteY4" fmla="*/ 2206171 h 4513942"/>
+              <a:gd name="connsiteX5" fmla="*/ 1297724 w 1907325"/>
+              <a:gd name="connsiteY5" fmla="*/ 2496457 h 4513942"/>
+              <a:gd name="connsiteX6" fmla="*/ 572010 w 1907325"/>
+              <a:gd name="connsiteY6" fmla="*/ 2772228 h 4513942"/>
+              <a:gd name="connsiteX7" fmla="*/ 281724 w 1907325"/>
+              <a:gd name="connsiteY7" fmla="*/ 2714171 h 4513942"/>
+              <a:gd name="connsiteX8" fmla="*/ 5953 w 1907325"/>
+              <a:gd name="connsiteY8" fmla="*/ 2119085 h 4513942"/>
+              <a:gd name="connsiteX9" fmla="*/ 20467 w 1907325"/>
+              <a:gd name="connsiteY9" fmla="*/ 1640114 h 4513942"/>
+              <a:gd name="connsiteX10" fmla="*/ 194638 w 1907325"/>
+              <a:gd name="connsiteY10" fmla="*/ 1364342 h 4513942"/>
+              <a:gd name="connsiteX11" fmla="*/ 891324 w 1907325"/>
+              <a:gd name="connsiteY11" fmla="*/ 1088571 h 4513942"/>
+              <a:gd name="connsiteX12" fmla="*/ 1181610 w 1907325"/>
+              <a:gd name="connsiteY12" fmla="*/ 1059542 h 4513942"/>
+              <a:gd name="connsiteX13" fmla="*/ 1370296 w 1907325"/>
+              <a:gd name="connsiteY13" fmla="*/ 1103085 h 4513942"/>
+              <a:gd name="connsiteX14" fmla="*/ 1646067 w 1907325"/>
+              <a:gd name="connsiteY14" fmla="*/ 1320800 h 4513942"/>
+              <a:gd name="connsiteX15" fmla="*/ 1747667 w 1907325"/>
+              <a:gd name="connsiteY15" fmla="*/ 1640114 h 4513942"/>
+              <a:gd name="connsiteX16" fmla="*/ 1892810 w 1907325"/>
+              <a:gd name="connsiteY16" fmla="*/ 2249714 h 4513942"/>
+              <a:gd name="connsiteX17" fmla="*/ 1805724 w 1907325"/>
+              <a:gd name="connsiteY17" fmla="*/ 3135085 h 4513942"/>
+              <a:gd name="connsiteX18" fmla="*/ 1660581 w 1907325"/>
+              <a:gd name="connsiteY18" fmla="*/ 3614057 h 4513942"/>
+              <a:gd name="connsiteX19" fmla="*/ 1399324 w 1907325"/>
+              <a:gd name="connsiteY19" fmla="*/ 3947885 h 4513942"/>
+              <a:gd name="connsiteX20" fmla="*/ 1283210 w 1907325"/>
+              <a:gd name="connsiteY20" fmla="*/ 4122057 h 4513942"/>
+              <a:gd name="connsiteX21" fmla="*/ 1196124 w 1907325"/>
+              <a:gd name="connsiteY21" fmla="*/ 4397828 h 4513942"/>
+              <a:gd name="connsiteX22" fmla="*/ 1152581 w 1907325"/>
+              <a:gd name="connsiteY22" fmla="*/ 4513942 h 4513942"/>
+            </a:gdLst>
+            <a:ahLst/>
+            <a:cxnLst>
+              <a:cxn ang="0">
+                <a:pos x="connsiteX0" y="connsiteY0"/>
+              </a:cxn>
+              <a:cxn ang="0">
+                <a:pos x="connsiteX1" y="connsiteY1"/>
+              </a:cxn>
+              <a:cxn ang="0">
+                <a:pos x="connsiteX2" y="connsiteY2"/>
+              </a:cxn>
+              <a:cxn ang="0">
+                <a:pos x="connsiteX3" y="connsiteY3"/>
+              </a:cxn>
+              <a:cxn ang="0">
+                <a:pos x="connsiteX4" y="connsiteY4"/>
+              </a:cxn>
+              <a:cxn ang="0">
+                <a:pos x="connsiteX5" y="connsiteY5"/>
+              </a:cxn>
+              <a:cxn ang="0">
+                <a:pos x="connsiteX6" y="connsiteY6"/>
+              </a:cxn>
+              <a:cxn ang="0">
+                <a:pos x="connsiteX7" y="connsiteY7"/>
+              </a:cxn>
+              <a:cxn ang="0">
+                <a:pos x="connsiteX8" y="connsiteY8"/>
+              </a:cxn>
+              <a:cxn ang="0">
+                <a:pos x="connsiteX9" y="connsiteY9"/>
+              </a:cxn>
+              <a:cxn ang="0">
+                <a:pos x="connsiteX10" y="connsiteY10"/>
+              </a:cxn>
+              <a:cxn ang="0">
+                <a:pos x="connsiteX11" y="connsiteY11"/>
+              </a:cxn>
+              <a:cxn ang="0">
+                <a:pos x="connsiteX12" y="connsiteY12"/>
+              </a:cxn>
+              <a:cxn ang="0">
+                <a:pos x="connsiteX13" y="connsiteY13"/>
+              </a:cxn>
+              <a:cxn ang="0">
+                <a:pos x="connsiteX14" y="connsiteY14"/>
+              </a:cxn>
+              <a:cxn ang="0">
+                <a:pos x="connsiteX15" y="connsiteY15"/>
+              </a:cxn>
+              <a:cxn ang="0">
+                <a:pos x="connsiteX16" y="connsiteY16"/>
+              </a:cxn>
+              <a:cxn ang="0">
+                <a:pos x="connsiteX17" y="connsiteY17"/>
+              </a:cxn>
+              <a:cxn ang="0">
+                <a:pos x="connsiteX18" y="connsiteY18"/>
+              </a:cxn>
+              <a:cxn ang="0">
+                <a:pos x="connsiteX19" y="connsiteY19"/>
+              </a:cxn>
+              <a:cxn ang="0">
+                <a:pos x="connsiteX20" y="connsiteY20"/>
+              </a:cxn>
+              <a:cxn ang="0">
+                <a:pos x="connsiteX21" y="connsiteY21"/>
+              </a:cxn>
+              <a:cxn ang="0">
+                <a:pos x="connsiteX22" y="connsiteY22"/>
+              </a:cxn>
+            </a:cxnLst>
+            <a:rect l="l" t="t" r="r" b="b"/>
+            <a:pathLst>
+              <a:path w="1907325" h="4513942">
+                <a:moveTo>
+                  <a:pt x="1268696" y="0"/>
+                </a:moveTo>
+                <a:cubicBezTo>
+                  <a:pt x="1442773" y="124340"/>
+                  <a:pt x="1389854" y="67227"/>
+                  <a:pt x="1544467" y="348342"/>
+                </a:cubicBezTo>
+                <a:cubicBezTo>
+                  <a:pt x="1699367" y="629979"/>
+                  <a:pt x="1682866" y="628863"/>
+                  <a:pt x="1762181" y="914400"/>
+                </a:cubicBezTo>
+                <a:cubicBezTo>
+                  <a:pt x="1776471" y="1078734"/>
+                  <a:pt x="1815799" y="1351947"/>
+                  <a:pt x="1776696" y="1524000"/>
+                </a:cubicBezTo>
+                <a:cubicBezTo>
+                  <a:pt x="1747705" y="1651561"/>
+                  <a:pt x="1570804" y="2083882"/>
+                  <a:pt x="1500924" y="2206171"/>
+                </a:cubicBezTo>
+                <a:cubicBezTo>
+                  <a:pt x="1442324" y="2308722"/>
+                  <a:pt x="1384895" y="2416758"/>
+                  <a:pt x="1297724" y="2496457"/>
+                </a:cubicBezTo>
+                <a:cubicBezTo>
+                  <a:pt x="1086760" y="2689339"/>
+                  <a:pt x="836364" y="2708418"/>
+                  <a:pt x="572010" y="2772228"/>
+                </a:cubicBezTo>
+                <a:cubicBezTo>
+                  <a:pt x="475248" y="2752876"/>
+                  <a:pt x="368793" y="2760608"/>
+                  <a:pt x="281724" y="2714171"/>
+                </a:cubicBezTo>
+                <a:cubicBezTo>
+                  <a:pt x="101836" y="2618231"/>
+                  <a:pt x="43703" y="2240724"/>
+                  <a:pt x="5953" y="2119085"/>
+                </a:cubicBezTo>
+                <a:cubicBezTo>
+                  <a:pt x="10791" y="1959428"/>
+                  <a:pt x="-18273" y="1795075"/>
+                  <a:pt x="20467" y="1640114"/>
+                </a:cubicBezTo>
+                <a:cubicBezTo>
+                  <a:pt x="46836" y="1534637"/>
+                  <a:pt x="119120" y="1442557"/>
+                  <a:pt x="194638" y="1364342"/>
+                </a:cubicBezTo>
+                <a:cubicBezTo>
+                  <a:pt x="353037" y="1200286"/>
+                  <a:pt x="709339" y="1127068"/>
+                  <a:pt x="891324" y="1088571"/>
+                </a:cubicBezTo>
+                <a:cubicBezTo>
+                  <a:pt x="986463" y="1068445"/>
+                  <a:pt x="1084848" y="1069218"/>
+                  <a:pt x="1181610" y="1059542"/>
+                </a:cubicBezTo>
+                <a:cubicBezTo>
+                  <a:pt x="1244505" y="1074056"/>
+                  <a:pt x="1310554" y="1078645"/>
+                  <a:pt x="1370296" y="1103085"/>
+                </a:cubicBezTo>
+                <a:cubicBezTo>
+                  <a:pt x="1458125" y="1139015"/>
+                  <a:pt x="1582620" y="1263698"/>
+                  <a:pt x="1646067" y="1320800"/>
+                </a:cubicBezTo>
+                <a:cubicBezTo>
+                  <a:pt x="1679934" y="1427238"/>
+                  <a:pt x="1718992" y="1532161"/>
+                  <a:pt x="1747667" y="1640114"/>
+                </a:cubicBezTo>
+                <a:cubicBezTo>
+                  <a:pt x="1801291" y="1841994"/>
+                  <a:pt x="1892810" y="2249714"/>
+                  <a:pt x="1892810" y="2249714"/>
+                </a:cubicBezTo>
+                <a:cubicBezTo>
+                  <a:pt x="1912101" y="2693420"/>
+                  <a:pt x="1933113" y="2603050"/>
+                  <a:pt x="1805724" y="3135085"/>
+                </a:cubicBezTo>
+                <a:cubicBezTo>
+                  <a:pt x="1766878" y="3297326"/>
+                  <a:pt x="1735188" y="3464843"/>
+                  <a:pt x="1660581" y="3614057"/>
+                </a:cubicBezTo>
+                <a:cubicBezTo>
+                  <a:pt x="1597389" y="3740441"/>
+                  <a:pt x="1483586" y="3834456"/>
+                  <a:pt x="1399324" y="3947885"/>
+                </a:cubicBezTo>
+                <a:cubicBezTo>
+                  <a:pt x="1357715" y="4003897"/>
+                  <a:pt x="1321915" y="4064000"/>
+                  <a:pt x="1283210" y="4122057"/>
+                </a:cubicBezTo>
+                <a:cubicBezTo>
+                  <a:pt x="1254181" y="4213981"/>
+                  <a:pt x="1226608" y="4306377"/>
+                  <a:pt x="1196124" y="4397828"/>
+                </a:cubicBezTo>
+                <a:cubicBezTo>
+                  <a:pt x="1183052" y="4437043"/>
+                  <a:pt x="1152581" y="4513942"/>
+                  <a:pt x="1152581" y="4513942"/>
+                </a:cubicBezTo>
+              </a:path>
+            </a:pathLst>
+          </a:custGeom>
+          <a:noFill/>
+          <a:ln w="76200"/>
+        </p:spPr>
+        <p:style>
+          <a:lnRef idx="2">
+            <a:schemeClr val="accent1">
+              <a:shade val="15000"/>
+            </a:schemeClr>
+          </a:lnRef>
+          <a:fillRef idx="1">
+            <a:schemeClr val="accent1"/>
+          </a:fillRef>
+          <a:effectRef idx="0">
+            <a:schemeClr val="accent1"/>
+          </a:effectRef>
+          <a:fontRef idx="minor">
+            <a:schemeClr val="lt1"/>
+          </a:fontRef>
+        </p:style>
+        <p:txBody>
+          <a:bodyPr rtlCol="0" anchor="ctr"/>
+          <a:lstStyle/>
+          <a:p>
+            <a:pPr algn="ctr"/>
+            <a:endParaRPr lang="en-US"/>
+          </a:p>
+        </p:txBody>
+      </p:sp>
+      <p:sp>
+        <p:nvSpPr>
+          <p:cNvPr id="3" name="Elipse 2">
+            <a:extLst>
+              <a:ext uri="{FF2B5EF4-FFF2-40B4-BE49-F238E27FC236}">
+                <a16:creationId xmlns:a16="http://schemas.microsoft.com/office/drawing/2014/main" id="{2CB7D4F2-4E66-01F3-BFC8-F9BE215440BD}"/>
+              </a:ext>
+            </a:extLst>
+          </p:cNvPr>
+          <p:cNvSpPr/>
+          <p:nvPr/>
+        </p:nvSpPr>
+        <p:spPr>
+          <a:xfrm>
+            <a:off x="6270542" y="991441"/>
+            <a:ext cx="2743200" cy="958383"/>
+          </a:xfrm>
+          <a:prstGeom prst="ellipse">
+            <a:avLst/>
+          </a:prstGeom>
+          <a:solidFill>
+            <a:srgbClr val="CAD7EE"/>
+          </a:solidFill>
+          <a:ln w="38100"/>
+        </p:spPr>
+        <p:style>
+          <a:lnRef idx="2">
+            <a:schemeClr val="accent1">
+              <a:shade val="15000"/>
+            </a:schemeClr>
+          </a:lnRef>
+          <a:fillRef idx="1">
+            <a:schemeClr val="accent1"/>
+          </a:fillRef>
+          <a:effectRef idx="0">
+            <a:schemeClr val="accent1"/>
+          </a:effectRef>
+          <a:fontRef idx="minor">
+            <a:schemeClr val="lt1"/>
+          </a:fontRef>
+        </p:style>
+        <p:txBody>
+          <a:bodyPr rtlCol="0" anchor="ctr"/>
+          <a:lstStyle/>
+          <a:p>
+            <a:pPr algn="ctr"/>
+            <a:endParaRPr lang="en-US"/>
+          </a:p>
+        </p:txBody>
+      </p:sp>
+      <p:sp>
+        <p:nvSpPr>
+          <p:cNvPr id="5" name="CuadroTexto 4">
+            <a:extLst>
+              <a:ext uri="{FF2B5EF4-FFF2-40B4-BE49-F238E27FC236}">
+                <a16:creationId xmlns:a16="http://schemas.microsoft.com/office/drawing/2014/main" id="{B116FCBB-538F-8DE6-B01C-A838AF459EA0}"/>
+              </a:ext>
+            </a:extLst>
+          </p:cNvPr>
+          <p:cNvSpPr txBox="1"/>
+          <p:nvPr/>
+        </p:nvSpPr>
+        <p:spPr>
+          <a:xfrm>
+            <a:off x="6505866" y="1285966"/>
+            <a:ext cx="2541494" cy="369332"/>
+          </a:xfrm>
+          <a:prstGeom prst="rect">
+            <a:avLst/>
+          </a:prstGeom>
+          <a:noFill/>
+        </p:spPr>
+        <p:txBody>
+          <a:bodyPr wrap="square" rtlCol="0">
+            <a:spAutoFit/>
+          </a:bodyPr>
+          <a:lstStyle/>
+          <a:p>
+            <a:r>
+              <a:rPr lang="en-US" dirty="0" err="1"/>
+              <a:t>kettle_temperature</a:t>
+            </a:r>
+            <a:r>
+              <a:rPr lang="en-US" dirty="0"/>
+              <a:t> = 20</a:t>
+            </a:r>
+          </a:p>
+        </p:txBody>
+      </p:sp>
+      <p:sp>
+        <p:nvSpPr>
+          <p:cNvPr id="6" name="CuadroTexto 5">
+            <a:extLst>
+              <a:ext uri="{FF2B5EF4-FFF2-40B4-BE49-F238E27FC236}">
+                <a16:creationId xmlns:a16="http://schemas.microsoft.com/office/drawing/2014/main" id="{727A149B-8F39-91A3-4658-71157F1B301B}"/>
+              </a:ext>
+            </a:extLst>
+          </p:cNvPr>
+          <p:cNvSpPr txBox="1"/>
+          <p:nvPr/>
+        </p:nvSpPr>
+        <p:spPr>
+          <a:xfrm>
+            <a:off x="6304160" y="5034795"/>
+            <a:ext cx="847164" cy="369332"/>
+          </a:xfrm>
+          <a:prstGeom prst="rect">
+            <a:avLst/>
+          </a:prstGeom>
+          <a:noFill/>
+        </p:spPr>
+        <p:txBody>
+          <a:bodyPr wrap="square" rtlCol="0">
+            <a:spAutoFit/>
+          </a:bodyPr>
+          <a:lstStyle/>
+          <a:p>
+            <a:r>
+              <a:rPr lang="en-US" dirty="0"/>
+              <a:t>Ln 5</a:t>
+            </a:r>
+          </a:p>
+        </p:txBody>
+      </p:sp>
+      <p:sp>
+        <p:nvSpPr>
+          <p:cNvPr id="8" name="Elipse 7">
+            <a:extLst>
+              <a:ext uri="{FF2B5EF4-FFF2-40B4-BE49-F238E27FC236}">
+                <a16:creationId xmlns:a16="http://schemas.microsoft.com/office/drawing/2014/main" id="{801AEFAF-9B02-65FD-F0C5-D0F38EF5323A}"/>
+              </a:ext>
+            </a:extLst>
+          </p:cNvPr>
+          <p:cNvSpPr/>
+          <p:nvPr/>
+        </p:nvSpPr>
+        <p:spPr>
+          <a:xfrm>
+            <a:off x="6304160" y="5256864"/>
+            <a:ext cx="2743200" cy="958383"/>
+          </a:xfrm>
+          <a:prstGeom prst="ellipse">
+            <a:avLst/>
+          </a:prstGeom>
+          <a:solidFill>
+            <a:srgbClr val="CAD7EE"/>
+          </a:solidFill>
+          <a:ln w="38100"/>
+        </p:spPr>
+        <p:style>
+          <a:lnRef idx="2">
+            <a:schemeClr val="accent1">
+              <a:shade val="15000"/>
+            </a:schemeClr>
+          </a:lnRef>
+          <a:fillRef idx="1">
+            <a:schemeClr val="accent1"/>
+          </a:fillRef>
+          <a:effectRef idx="0">
+            <a:schemeClr val="accent1"/>
+          </a:effectRef>
+          <a:fontRef idx="minor">
+            <a:schemeClr val="lt1"/>
+          </a:fontRef>
+        </p:style>
+        <p:txBody>
+          <a:bodyPr rtlCol="0" anchor="ctr"/>
+          <a:lstStyle/>
+          <a:p>
+            <a:pPr algn="ctr"/>
+            <a:endParaRPr lang="en-US"/>
+          </a:p>
+        </p:txBody>
+      </p:sp>
+      <p:sp>
+        <p:nvSpPr>
+          <p:cNvPr id="9" name="CuadroTexto 8">
+            <a:extLst>
+              <a:ext uri="{FF2B5EF4-FFF2-40B4-BE49-F238E27FC236}">
+                <a16:creationId xmlns:a16="http://schemas.microsoft.com/office/drawing/2014/main" id="{083836FA-90FE-BF93-1E0B-E57B0C09EF0C}"/>
+              </a:ext>
+            </a:extLst>
+          </p:cNvPr>
+          <p:cNvSpPr txBox="1"/>
+          <p:nvPr/>
+        </p:nvSpPr>
+        <p:spPr>
+          <a:xfrm>
+            <a:off x="6402173" y="5551389"/>
+            <a:ext cx="2743200" cy="369332"/>
+          </a:xfrm>
+          <a:prstGeom prst="rect">
+            <a:avLst/>
+          </a:prstGeom>
+          <a:noFill/>
+        </p:spPr>
+        <p:txBody>
+          <a:bodyPr wrap="square" rtlCol="0">
+            <a:spAutoFit/>
+          </a:bodyPr>
+          <a:lstStyle/>
+          <a:p>
+            <a:r>
+              <a:rPr lang="en-US" dirty="0"/>
+              <a:t>print(</a:t>
+            </a:r>
+            <a:r>
+              <a:rPr lang="en-US" dirty="0" err="1"/>
+              <a:t>kettle_temperature</a:t>
+            </a:r>
+            <a:r>
+              <a:rPr lang="en-US" dirty="0"/>
+              <a:t>)</a:t>
+            </a:r>
+          </a:p>
+        </p:txBody>
+      </p:sp>
+      <p:sp>
+        <p:nvSpPr>
+          <p:cNvPr id="10" name="CuadroTexto 9">
+            <a:extLst>
+              <a:ext uri="{FF2B5EF4-FFF2-40B4-BE49-F238E27FC236}">
+                <a16:creationId xmlns:a16="http://schemas.microsoft.com/office/drawing/2014/main" id="{998573A2-FFCB-389C-E7DF-612C8F651851}"/>
+              </a:ext>
+            </a:extLst>
+          </p:cNvPr>
+          <p:cNvSpPr txBox="1"/>
+          <p:nvPr/>
+        </p:nvSpPr>
+        <p:spPr>
+          <a:xfrm>
+            <a:off x="6505866" y="695741"/>
+            <a:ext cx="847164" cy="369332"/>
+          </a:xfrm>
+          <a:prstGeom prst="rect">
+            <a:avLst/>
+          </a:prstGeom>
+          <a:noFill/>
+        </p:spPr>
+        <p:txBody>
+          <a:bodyPr wrap="square" rtlCol="0">
+            <a:spAutoFit/>
+          </a:bodyPr>
+          <a:lstStyle/>
+          <a:p>
+            <a:r>
+              <a:rPr lang="en-US" dirty="0"/>
+              <a:t>Ln 1</a:t>
+            </a:r>
+          </a:p>
+        </p:txBody>
+      </p:sp>
+      <p:grpSp>
+        <p:nvGrpSpPr>
+          <p:cNvPr id="16" name="Grupo 15">
+            <a:extLst>
+              <a:ext uri="{FF2B5EF4-FFF2-40B4-BE49-F238E27FC236}">
+                <a16:creationId xmlns:a16="http://schemas.microsoft.com/office/drawing/2014/main" id="{4637E389-9877-9299-CFE1-F60ADCAA8740}"/>
+              </a:ext>
+            </a:extLst>
+          </p:cNvPr>
+          <p:cNvGrpSpPr/>
+          <p:nvPr/>
+        </p:nvGrpSpPr>
+        <p:grpSpPr>
+          <a:xfrm rot="1017173">
+            <a:off x="3970303" y="1016763"/>
+            <a:ext cx="2337358" cy="2009082"/>
+            <a:chOff x="4312494" y="1478756"/>
+            <a:chExt cx="2564824" cy="2204602"/>
+          </a:xfrm>
+        </p:grpSpPr>
+        <p:sp>
+          <p:nvSpPr>
+            <p:cNvPr id="11" name="Forma libre: forma 10">
+              <a:extLst>
+                <a:ext uri="{FF2B5EF4-FFF2-40B4-BE49-F238E27FC236}">
+                  <a16:creationId xmlns:a16="http://schemas.microsoft.com/office/drawing/2014/main" id="{93EFBE91-D05C-C766-B686-79B2C6386D37}"/>
+                </a:ext>
+              </a:extLst>
+            </p:cNvPr>
+            <p:cNvSpPr/>
+            <p:nvPr/>
+          </p:nvSpPr>
+          <p:spPr>
+            <a:xfrm>
+              <a:off x="4312494" y="1532583"/>
+              <a:ext cx="2564824" cy="2150775"/>
+            </a:xfrm>
+            <a:custGeom>
+              <a:avLst/>
+              <a:gdLst>
+                <a:gd name="connsiteX0" fmla="*/ 2564824 w 2564824"/>
+                <a:gd name="connsiteY0" fmla="*/ 631068 h 2150775"/>
+                <a:gd name="connsiteX1" fmla="*/ 2126943 w 2564824"/>
+                <a:gd name="connsiteY1" fmla="*/ 1661378 h 2150775"/>
+                <a:gd name="connsiteX2" fmla="*/ 1882244 w 2564824"/>
+                <a:gd name="connsiteY2" fmla="*/ 1841682 h 2150775"/>
+                <a:gd name="connsiteX3" fmla="*/ 1624667 w 2564824"/>
+                <a:gd name="connsiteY3" fmla="*/ 1957592 h 2150775"/>
+                <a:gd name="connsiteX4" fmla="*/ 787540 w 2564824"/>
+                <a:gd name="connsiteY4" fmla="*/ 2150775 h 2150775"/>
+                <a:gd name="connsiteX5" fmla="*/ 607236 w 2564824"/>
+                <a:gd name="connsiteY5" fmla="*/ 2137896 h 2150775"/>
+                <a:gd name="connsiteX6" fmla="*/ 414052 w 2564824"/>
+                <a:gd name="connsiteY6" fmla="*/ 2021986 h 2150775"/>
+                <a:gd name="connsiteX7" fmla="*/ 27686 w 2564824"/>
+                <a:gd name="connsiteY7" fmla="*/ 1390921 h 2150775"/>
+                <a:gd name="connsiteX8" fmla="*/ 53444 w 2564824"/>
+                <a:gd name="connsiteY8" fmla="*/ 901524 h 2150775"/>
+                <a:gd name="connsiteX9" fmla="*/ 594357 w 2564824"/>
+                <a:gd name="connsiteY9" fmla="*/ 437885 h 2150775"/>
+                <a:gd name="connsiteX10" fmla="*/ 736024 w 2564824"/>
+                <a:gd name="connsiteY10" fmla="*/ 347732 h 2150775"/>
+                <a:gd name="connsiteX11" fmla="*/ 877692 w 2564824"/>
+                <a:gd name="connsiteY11" fmla="*/ 270459 h 2150775"/>
+                <a:gd name="connsiteX12" fmla="*/ 1238300 w 2564824"/>
+                <a:gd name="connsiteY12" fmla="*/ 128792 h 2150775"/>
+                <a:gd name="connsiteX13" fmla="*/ 1367089 w 2564824"/>
+                <a:gd name="connsiteY13" fmla="*/ 25761 h 2150775"/>
+                <a:gd name="connsiteX14" fmla="*/ 1444362 w 2564824"/>
+                <a:gd name="connsiteY14" fmla="*/ 12882 h 2150775"/>
+                <a:gd name="connsiteX15" fmla="*/ 1663303 w 2564824"/>
+                <a:gd name="connsiteY15" fmla="*/ 3 h 2150775"/>
+              </a:gdLst>
+              <a:ahLst/>
+              <a:cxnLst>
+                <a:cxn ang="0">
+                  <a:pos x="connsiteX0" y="connsiteY0"/>
+                </a:cxn>
+                <a:cxn ang="0">
+                  <a:pos x="connsiteX1" y="connsiteY1"/>
+                </a:cxn>
+                <a:cxn ang="0">
+                  <a:pos x="connsiteX2" y="connsiteY2"/>
+                </a:cxn>
+                <a:cxn ang="0">
+                  <a:pos x="connsiteX3" y="connsiteY3"/>
+                </a:cxn>
+                <a:cxn ang="0">
+                  <a:pos x="connsiteX4" y="connsiteY4"/>
+                </a:cxn>
+                <a:cxn ang="0">
+                  <a:pos x="connsiteX5" y="connsiteY5"/>
+                </a:cxn>
+                <a:cxn ang="0">
+                  <a:pos x="connsiteX6" y="connsiteY6"/>
+                </a:cxn>
+                <a:cxn ang="0">
+                  <a:pos x="connsiteX7" y="connsiteY7"/>
+                </a:cxn>
+                <a:cxn ang="0">
+                  <a:pos x="connsiteX8" y="connsiteY8"/>
+                </a:cxn>
+                <a:cxn ang="0">
+                  <a:pos x="connsiteX9" y="connsiteY9"/>
+                </a:cxn>
+                <a:cxn ang="0">
+                  <a:pos x="connsiteX10" y="connsiteY10"/>
+                </a:cxn>
+                <a:cxn ang="0">
+                  <a:pos x="connsiteX11" y="connsiteY11"/>
+                </a:cxn>
+                <a:cxn ang="0">
+                  <a:pos x="connsiteX12" y="connsiteY12"/>
+                </a:cxn>
+                <a:cxn ang="0">
+                  <a:pos x="connsiteX13" y="connsiteY13"/>
+                </a:cxn>
+                <a:cxn ang="0">
+                  <a:pos x="connsiteX14" y="connsiteY14"/>
+                </a:cxn>
+                <a:cxn ang="0">
+                  <a:pos x="connsiteX15" y="connsiteY15"/>
+                </a:cxn>
+              </a:cxnLst>
+              <a:rect l="l" t="t" r="r" b="b"/>
+              <a:pathLst>
+                <a:path w="2564824" h="2150775">
+                  <a:moveTo>
+                    <a:pt x="2564824" y="631068"/>
+                  </a:moveTo>
+                  <a:cubicBezTo>
+                    <a:pt x="2417431" y="1114191"/>
+                    <a:pt x="2443202" y="1345119"/>
+                    <a:pt x="2126943" y="1661378"/>
+                  </a:cubicBezTo>
+                  <a:cubicBezTo>
+                    <a:pt x="2055301" y="1733020"/>
+                    <a:pt x="1969515" y="1790214"/>
+                    <a:pt x="1882244" y="1841682"/>
+                  </a:cubicBezTo>
+                  <a:cubicBezTo>
+                    <a:pt x="1801145" y="1889510"/>
+                    <a:pt x="1715276" y="1932008"/>
+                    <a:pt x="1624667" y="1957592"/>
+                  </a:cubicBezTo>
+                  <a:cubicBezTo>
+                    <a:pt x="1349066" y="2035409"/>
+                    <a:pt x="787540" y="2150775"/>
+                    <a:pt x="787540" y="2150775"/>
+                  </a:cubicBezTo>
+                  <a:cubicBezTo>
+                    <a:pt x="727439" y="2146482"/>
+                    <a:pt x="664199" y="2157538"/>
+                    <a:pt x="607236" y="2137896"/>
+                  </a:cubicBezTo>
+                  <a:cubicBezTo>
+                    <a:pt x="536242" y="2113415"/>
+                    <a:pt x="466378" y="2075851"/>
+                    <a:pt x="414052" y="2021986"/>
+                  </a:cubicBezTo>
+                  <a:cubicBezTo>
+                    <a:pt x="203552" y="1805295"/>
+                    <a:pt x="150799" y="1648339"/>
+                    <a:pt x="27686" y="1390921"/>
+                  </a:cubicBezTo>
+                  <a:cubicBezTo>
+                    <a:pt x="11956" y="1257210"/>
+                    <a:pt x="-37734" y="1023895"/>
+                    <a:pt x="53444" y="901524"/>
+                  </a:cubicBezTo>
+                  <a:cubicBezTo>
+                    <a:pt x="77699" y="868972"/>
+                    <a:pt x="433922" y="547657"/>
+                    <a:pt x="594357" y="437885"/>
+                  </a:cubicBezTo>
+                  <a:cubicBezTo>
+                    <a:pt x="640552" y="406278"/>
+                    <a:pt x="687835" y="376207"/>
+                    <a:pt x="736024" y="347732"/>
+                  </a:cubicBezTo>
+                  <a:cubicBezTo>
+                    <a:pt x="782334" y="320367"/>
+                    <a:pt x="828382" y="291953"/>
+                    <a:pt x="877692" y="270459"/>
+                  </a:cubicBezTo>
+                  <a:cubicBezTo>
+                    <a:pt x="996079" y="218854"/>
+                    <a:pt x="1238300" y="128792"/>
+                    <a:pt x="1238300" y="128792"/>
+                  </a:cubicBezTo>
+                  <a:cubicBezTo>
+                    <a:pt x="1281230" y="94448"/>
+                    <a:pt x="1319173" y="52714"/>
+                    <a:pt x="1367089" y="25761"/>
+                  </a:cubicBezTo>
+                  <a:cubicBezTo>
+                    <a:pt x="1389848" y="12959"/>
+                    <a:pt x="1418367" y="15358"/>
+                    <a:pt x="1444362" y="12882"/>
+                  </a:cubicBezTo>
+                  <a:cubicBezTo>
+                    <a:pt x="1585587" y="-568"/>
+                    <a:pt x="1581060" y="3"/>
+                    <a:pt x="1663303" y="3"/>
+                  </a:cubicBezTo>
+                </a:path>
+              </a:pathLst>
+            </a:custGeom>
+            <a:noFill/>
+            <a:ln w="38100">
+              <a:solidFill>
+                <a:srgbClr val="791179"/>
+              </a:solidFill>
+            </a:ln>
+          </p:spPr>
+          <p:style>
+            <a:lnRef idx="2">
+              <a:schemeClr val="accent1">
+                <a:shade val="15000"/>
+              </a:schemeClr>
+            </a:lnRef>
+            <a:fillRef idx="1">
+              <a:schemeClr val="accent1"/>
+            </a:fillRef>
+            <a:effectRef idx="0">
+              <a:schemeClr val="accent1"/>
+            </a:effectRef>
+            <a:fontRef idx="minor">
+              <a:schemeClr val="lt1"/>
+            </a:fontRef>
+          </p:style>
+          <p:txBody>
+            <a:bodyPr rtlCol="0" anchor="ctr"/>
+            <a:lstStyle/>
+            <a:p>
+              <a:pPr algn="ctr"/>
+              <a:endParaRPr lang="en-US"/>
+            </a:p>
+          </p:txBody>
+        </p:sp>
+        <p:sp>
+          <p:nvSpPr>
+            <p:cNvPr id="12" name="Forma libre: forma 11">
+              <a:extLst>
+                <a:ext uri="{FF2B5EF4-FFF2-40B4-BE49-F238E27FC236}">
+                  <a16:creationId xmlns:a16="http://schemas.microsoft.com/office/drawing/2014/main" id="{D6721B3E-B356-995B-F1B4-09A6E562C7C3}"/>
+                </a:ext>
+              </a:extLst>
+            </p:cNvPr>
+            <p:cNvSpPr/>
+            <p:nvPr/>
+          </p:nvSpPr>
+          <p:spPr>
+            <a:xfrm>
+              <a:off x="5798344" y="1478756"/>
+              <a:ext cx="188119" cy="211932"/>
+            </a:xfrm>
+            <a:custGeom>
+              <a:avLst/>
+              <a:gdLst>
+                <a:gd name="connsiteX0" fmla="*/ 0 w 188119"/>
+                <a:gd name="connsiteY0" fmla="*/ 0 h 211932"/>
+                <a:gd name="connsiteX1" fmla="*/ 109537 w 188119"/>
+                <a:gd name="connsiteY1" fmla="*/ 26194 h 211932"/>
+                <a:gd name="connsiteX2" fmla="*/ 133350 w 188119"/>
+                <a:gd name="connsiteY2" fmla="*/ 38100 h 211932"/>
+                <a:gd name="connsiteX3" fmla="*/ 159544 w 188119"/>
+                <a:gd name="connsiteY3" fmla="*/ 50007 h 211932"/>
+                <a:gd name="connsiteX4" fmla="*/ 180975 w 188119"/>
+                <a:gd name="connsiteY4" fmla="*/ 54769 h 211932"/>
+                <a:gd name="connsiteX5" fmla="*/ 188119 w 188119"/>
+                <a:gd name="connsiteY5" fmla="*/ 57150 h 211932"/>
+                <a:gd name="connsiteX6" fmla="*/ 140494 w 188119"/>
+                <a:gd name="connsiteY6" fmla="*/ 121444 h 211932"/>
+                <a:gd name="connsiteX7" fmla="*/ 123825 w 188119"/>
+                <a:gd name="connsiteY7" fmla="*/ 140494 h 211932"/>
+                <a:gd name="connsiteX8" fmla="*/ 102394 w 188119"/>
+                <a:gd name="connsiteY8" fmla="*/ 150019 h 211932"/>
+                <a:gd name="connsiteX9" fmla="*/ 80962 w 188119"/>
+                <a:gd name="connsiteY9" fmla="*/ 173832 h 211932"/>
+                <a:gd name="connsiteX10" fmla="*/ 73819 w 188119"/>
+                <a:gd name="connsiteY10" fmla="*/ 180975 h 211932"/>
+                <a:gd name="connsiteX11" fmla="*/ 69056 w 188119"/>
+                <a:gd name="connsiteY11" fmla="*/ 190500 h 211932"/>
+                <a:gd name="connsiteX12" fmla="*/ 61912 w 188119"/>
+                <a:gd name="connsiteY12" fmla="*/ 202407 h 211932"/>
+                <a:gd name="connsiteX13" fmla="*/ 52387 w 188119"/>
+                <a:gd name="connsiteY13" fmla="*/ 211932 h 211932"/>
+              </a:gdLst>
+              <a:ahLst/>
+              <a:cxnLst>
+                <a:cxn ang="0">
+                  <a:pos x="connsiteX0" y="connsiteY0"/>
+                </a:cxn>
+                <a:cxn ang="0">
+                  <a:pos x="connsiteX1" y="connsiteY1"/>
+                </a:cxn>
+                <a:cxn ang="0">
+                  <a:pos x="connsiteX2" y="connsiteY2"/>
+                </a:cxn>
+                <a:cxn ang="0">
+                  <a:pos x="connsiteX3" y="connsiteY3"/>
+                </a:cxn>
+                <a:cxn ang="0">
+                  <a:pos x="connsiteX4" y="connsiteY4"/>
+                </a:cxn>
+                <a:cxn ang="0">
+                  <a:pos x="connsiteX5" y="connsiteY5"/>
+                </a:cxn>
+                <a:cxn ang="0">
+                  <a:pos x="connsiteX6" y="connsiteY6"/>
+                </a:cxn>
+                <a:cxn ang="0">
+                  <a:pos x="connsiteX7" y="connsiteY7"/>
+                </a:cxn>
+                <a:cxn ang="0">
+                  <a:pos x="connsiteX8" y="connsiteY8"/>
+                </a:cxn>
+                <a:cxn ang="0">
+                  <a:pos x="connsiteX9" y="connsiteY9"/>
+                </a:cxn>
+                <a:cxn ang="0">
+                  <a:pos x="connsiteX10" y="connsiteY10"/>
+                </a:cxn>
+                <a:cxn ang="0">
+                  <a:pos x="connsiteX11" y="connsiteY11"/>
+                </a:cxn>
+                <a:cxn ang="0">
+                  <a:pos x="connsiteX12" y="connsiteY12"/>
+                </a:cxn>
+                <a:cxn ang="0">
+                  <a:pos x="connsiteX13" y="connsiteY13"/>
+                </a:cxn>
+              </a:cxnLst>
+              <a:rect l="l" t="t" r="r" b="b"/>
+              <a:pathLst>
+                <a:path w="188119" h="211932">
+                  <a:moveTo>
+                    <a:pt x="0" y="0"/>
+                  </a:moveTo>
+                  <a:cubicBezTo>
+                    <a:pt x="59974" y="11996"/>
+                    <a:pt x="54255" y="9184"/>
+                    <a:pt x="109537" y="26194"/>
+                  </a:cubicBezTo>
+                  <a:cubicBezTo>
+                    <a:pt x="125437" y="31086"/>
+                    <a:pt x="118108" y="30479"/>
+                    <a:pt x="133350" y="38100"/>
+                  </a:cubicBezTo>
+                  <a:cubicBezTo>
+                    <a:pt x="141929" y="42389"/>
+                    <a:pt x="150639" y="46445"/>
+                    <a:pt x="159544" y="50007"/>
+                  </a:cubicBezTo>
+                  <a:cubicBezTo>
+                    <a:pt x="163616" y="51636"/>
+                    <a:pt x="177459" y="53890"/>
+                    <a:pt x="180975" y="54769"/>
+                  </a:cubicBezTo>
+                  <a:cubicBezTo>
+                    <a:pt x="183410" y="55378"/>
+                    <a:pt x="185738" y="56356"/>
+                    <a:pt x="188119" y="57150"/>
+                  </a:cubicBezTo>
+                  <a:cubicBezTo>
+                    <a:pt x="187294" y="58275"/>
+                    <a:pt x="144649" y="116696"/>
+                    <a:pt x="140494" y="121444"/>
+                  </a:cubicBezTo>
+                  <a:cubicBezTo>
+                    <a:pt x="134938" y="127794"/>
+                    <a:pt x="130575" y="135431"/>
+                    <a:pt x="123825" y="140494"/>
+                  </a:cubicBezTo>
+                  <a:cubicBezTo>
+                    <a:pt x="117571" y="145184"/>
+                    <a:pt x="109538" y="146844"/>
+                    <a:pt x="102394" y="150019"/>
+                  </a:cubicBezTo>
+                  <a:cubicBezTo>
+                    <a:pt x="76108" y="176303"/>
+                    <a:pt x="103760" y="147776"/>
+                    <a:pt x="80962" y="173832"/>
+                  </a:cubicBezTo>
+                  <a:cubicBezTo>
+                    <a:pt x="78745" y="176366"/>
+                    <a:pt x="75776" y="178235"/>
+                    <a:pt x="73819" y="180975"/>
+                  </a:cubicBezTo>
+                  <a:cubicBezTo>
+                    <a:pt x="71756" y="183864"/>
+                    <a:pt x="70780" y="187397"/>
+                    <a:pt x="69056" y="190500"/>
+                  </a:cubicBezTo>
+                  <a:cubicBezTo>
+                    <a:pt x="66808" y="194546"/>
+                    <a:pt x="64689" y="198704"/>
+                    <a:pt x="61912" y="202407"/>
+                  </a:cubicBezTo>
+                  <a:cubicBezTo>
+                    <a:pt x="59218" y="205999"/>
+                    <a:pt x="55562" y="208757"/>
+                    <a:pt x="52387" y="211932"/>
+                  </a:cubicBezTo>
+                </a:path>
+              </a:pathLst>
+            </a:custGeom>
+            <a:noFill/>
+            <a:ln w="38100">
+              <a:solidFill>
+                <a:srgbClr val="8A008A"/>
+              </a:solidFill>
+            </a:ln>
+          </p:spPr>
+          <p:style>
+            <a:lnRef idx="2">
+              <a:schemeClr val="accent1">
+                <a:shade val="15000"/>
+              </a:schemeClr>
+            </a:lnRef>
+            <a:fillRef idx="1">
+              <a:schemeClr val="accent1"/>
+            </a:fillRef>
+            <a:effectRef idx="0">
+              <a:schemeClr val="accent1"/>
+            </a:effectRef>
+            <a:fontRef idx="minor">
+              <a:schemeClr val="lt1"/>
+            </a:fontRef>
+          </p:style>
+          <p:txBody>
+            <a:bodyPr rtlCol="0" anchor="ctr"/>
+            <a:lstStyle/>
+            <a:p>
+              <a:pPr algn="ctr"/>
+              <a:endParaRPr lang="en-US"/>
+            </a:p>
+          </p:txBody>
+        </p:sp>
+      </p:grpSp>
+      <p:sp>
+        <p:nvSpPr>
+          <p:cNvPr id="13" name="CuadroTexto 12">
+            <a:extLst>
+              <a:ext uri="{FF2B5EF4-FFF2-40B4-BE49-F238E27FC236}">
+                <a16:creationId xmlns:a16="http://schemas.microsoft.com/office/drawing/2014/main" id="{45EC1769-58C5-19F6-ED4E-81D0E2650381}"/>
+              </a:ext>
+            </a:extLst>
+          </p:cNvPr>
+          <p:cNvSpPr txBox="1"/>
+          <p:nvPr/>
+        </p:nvSpPr>
+        <p:spPr>
+          <a:xfrm>
+            <a:off x="5592375" y="2662913"/>
+            <a:ext cx="361682" cy="769441"/>
+          </a:xfrm>
+          <a:prstGeom prst="rect">
+            <a:avLst/>
+          </a:prstGeom>
+          <a:noFill/>
+        </p:spPr>
+        <p:txBody>
+          <a:bodyPr wrap="square" rtlCol="0">
+            <a:spAutoFit/>
+          </a:bodyPr>
+          <a:lstStyle/>
+          <a:p>
+            <a:r>
+              <a:rPr lang="en-US" sz="4400" b="1" dirty="0">
+                <a:solidFill>
+                  <a:srgbClr val="00B050"/>
+                </a:solidFill>
+              </a:rPr>
+              <a:t>T</a:t>
+            </a:r>
+          </a:p>
+        </p:txBody>
+      </p:sp>
+      <p:sp>
+        <p:nvSpPr>
+          <p:cNvPr id="14" name="CuadroTexto 13">
+            <a:extLst>
+              <a:ext uri="{FF2B5EF4-FFF2-40B4-BE49-F238E27FC236}">
+                <a16:creationId xmlns:a16="http://schemas.microsoft.com/office/drawing/2014/main" id="{E6A8207D-903B-F223-FC1C-645B209A93B3}"/>
+              </a:ext>
+            </a:extLst>
+          </p:cNvPr>
+          <p:cNvSpPr txBox="1"/>
+          <p:nvPr/>
+        </p:nvSpPr>
+        <p:spPr>
+          <a:xfrm>
+            <a:off x="9331684" y="2553521"/>
+            <a:ext cx="583841" cy="769441"/>
+          </a:xfrm>
+          <a:prstGeom prst="rect">
+            <a:avLst/>
+          </a:prstGeom>
+          <a:noFill/>
+        </p:spPr>
+        <p:txBody>
+          <a:bodyPr wrap="square" rtlCol="0">
+            <a:spAutoFit/>
+          </a:bodyPr>
+          <a:lstStyle/>
+          <a:p>
+            <a:r>
+              <a:rPr lang="en-US" sz="4400" b="1" dirty="0">
+                <a:solidFill>
+                  <a:srgbClr val="FF0000"/>
+                </a:solidFill>
+              </a:rPr>
+              <a:t>F</a:t>
+            </a:r>
+          </a:p>
+        </p:txBody>
+      </p:sp>
+      <p:sp>
+        <p:nvSpPr>
+          <p:cNvPr id="15" name="CuadroTexto 14">
+            <a:extLst>
+              <a:ext uri="{FF2B5EF4-FFF2-40B4-BE49-F238E27FC236}">
+                <a16:creationId xmlns:a16="http://schemas.microsoft.com/office/drawing/2014/main" id="{4B4F8199-CCFA-42D1-8ED2-649051600151}"/>
+              </a:ext>
+            </a:extLst>
+          </p:cNvPr>
+          <p:cNvSpPr txBox="1"/>
+          <p:nvPr/>
+        </p:nvSpPr>
+        <p:spPr>
+          <a:xfrm>
+            <a:off x="6302239" y="2262593"/>
+            <a:ext cx="2943068" cy="369332"/>
+          </a:xfrm>
+          <a:prstGeom prst="rect">
+            <a:avLst/>
+          </a:prstGeom>
+          <a:noFill/>
+        </p:spPr>
+        <p:txBody>
+          <a:bodyPr wrap="square" rtlCol="0">
+            <a:spAutoFit/>
+          </a:bodyPr>
+          <a:lstStyle/>
+          <a:p>
+            <a:r>
+              <a:rPr lang="en-US" dirty="0"/>
+              <a:t>is </a:t>
+            </a:r>
+            <a:r>
+              <a:rPr lang="en-US" dirty="0" err="1"/>
+              <a:t>kettle_temperature</a:t>
+            </a:r>
+            <a:r>
+              <a:rPr lang="en-US" dirty="0"/>
+              <a:t> &lt; 100?</a:t>
+            </a:r>
+          </a:p>
+        </p:txBody>
+      </p:sp>
+    </p:spTree>
+    <p:extLst>
+      <p:ext uri="{BB962C8B-B14F-4D97-AF65-F5344CB8AC3E}">
+        <p14:creationId xmlns:p14="http://schemas.microsoft.com/office/powerpoint/2010/main" val="1858723434"/>
+      </p:ext>
+    </p:extLst>
+  </p:cSld>
+  <p:clrMapOvr>
+    <a:masterClrMapping/>
+  </p:clrMapOvr>
+</p:sld>
+</file>
+
+<file path=ppt/slides/slide12.xml><?xml version="1.0" encoding="utf-8"?>
+<p:sld xmlns:a="http://schemas.openxmlformats.org/drawingml/2006/main" xmlns:r="http://schemas.openxmlformats.org/officeDocument/2006/relationships" xmlns:p="http://schemas.openxmlformats.org/presentationml/2006/main">
+  <p:cSld>
+    <p:spTree>
+      <p:nvGrpSpPr>
+        <p:cNvPr id="1" name=""/>
+        <p:cNvGrpSpPr/>
+        <p:nvPr/>
+      </p:nvGrpSpPr>
+      <p:grpSpPr>
+        <a:xfrm>
+          <a:off x="0" y="0"/>
+          <a:ext cx="0" cy="0"/>
+          <a:chOff x="0" y="0"/>
+          <a:chExt cx="0" cy="0"/>
+        </a:xfrm>
+      </p:grpSpPr>
+      <p:sp>
+        <p:nvSpPr>
+          <p:cNvPr id="2" name="Título 1">
+            <a:extLst>
+              <a:ext uri="{FF2B5EF4-FFF2-40B4-BE49-F238E27FC236}">
+                <a16:creationId xmlns:a16="http://schemas.microsoft.com/office/drawing/2014/main" id="{B0CB5DFC-30DB-1EBB-370A-153992193F6A}"/>
+              </a:ext>
+            </a:extLst>
+          </p:cNvPr>
+          <p:cNvSpPr>
+            <a:spLocks noGrp="1"/>
+          </p:cNvSpPr>
+          <p:nvPr>
+            <p:ph type="title"/>
+          </p:nvPr>
+        </p:nvSpPr>
+        <p:spPr/>
+        <p:txBody>
+          <a:bodyPr/>
+          <a:lstStyle/>
+          <a:p>
+            <a:r>
+              <a:rPr lang="es-AR" b="1" dirty="0" err="1">
+                <a:latin typeface="Consolas" panose="020B0609020204030204" pitchFamily="49" charset="0"/>
+                <a:cs typeface="Cascadia Code SemiBold" panose="020B0609020000020004" pitchFamily="49" charset="0"/>
+              </a:rPr>
+              <a:t>For</a:t>
+            </a:r>
+            <a:br>
+              <a:rPr lang="es-AR" dirty="0"/>
+            </a:br>
+            <a:r>
+              <a:rPr lang="es-AR" i="1" dirty="0">
+                <a:solidFill>
+                  <a:schemeClr val="bg2">
+                    <a:lumMod val="50000"/>
+                  </a:schemeClr>
+                </a:solidFill>
+              </a:rPr>
+              <a:t>(</a:t>
+            </a:r>
+            <a:r>
+              <a:rPr lang="es-AR" i="1" dirty="0" err="1">
+                <a:solidFill>
+                  <a:schemeClr val="bg2">
+                    <a:lumMod val="50000"/>
+                  </a:schemeClr>
+                </a:solidFill>
+              </a:rPr>
+              <a:t>loop</a:t>
+            </a:r>
+            <a:r>
+              <a:rPr lang="es-AR" i="1" dirty="0">
+                <a:solidFill>
+                  <a:schemeClr val="bg2">
+                    <a:lumMod val="50000"/>
+                  </a:schemeClr>
+                </a:solidFill>
+              </a:rPr>
+              <a:t>)</a:t>
+            </a:r>
             <a:r>
               <a:rPr lang="es-AR" dirty="0"/>
               <a:t> </a:t>
             </a:r>
             <a:endParaRPr lang="en-US" dirty="0"/>
+          </a:p>
+        </p:txBody>
+      </p:sp>
+      <p:sp>
+        <p:nvSpPr>
+          <p:cNvPr id="4" name="Forma libre: forma 3">
+            <a:extLst>
+              <a:ext uri="{FF2B5EF4-FFF2-40B4-BE49-F238E27FC236}">
+                <a16:creationId xmlns:a16="http://schemas.microsoft.com/office/drawing/2014/main" id="{8C7EDE2A-91C1-CA2D-5566-DA3F39B2C87D}"/>
+              </a:ext>
+            </a:extLst>
+          </p:cNvPr>
+          <p:cNvSpPr/>
+          <p:nvPr/>
+        </p:nvSpPr>
+        <p:spPr>
+          <a:xfrm>
+            <a:off x="838200" y="2756079"/>
+            <a:ext cx="1177254" cy="2786130"/>
+          </a:xfrm>
+          <a:custGeom>
+            <a:avLst/>
+            <a:gdLst>
+              <a:gd name="connsiteX0" fmla="*/ 1268696 w 1907325"/>
+              <a:gd name="connsiteY0" fmla="*/ 0 h 4513942"/>
+              <a:gd name="connsiteX1" fmla="*/ 1544467 w 1907325"/>
+              <a:gd name="connsiteY1" fmla="*/ 348342 h 4513942"/>
+              <a:gd name="connsiteX2" fmla="*/ 1762181 w 1907325"/>
+              <a:gd name="connsiteY2" fmla="*/ 914400 h 4513942"/>
+              <a:gd name="connsiteX3" fmla="*/ 1776696 w 1907325"/>
+              <a:gd name="connsiteY3" fmla="*/ 1524000 h 4513942"/>
+              <a:gd name="connsiteX4" fmla="*/ 1500924 w 1907325"/>
+              <a:gd name="connsiteY4" fmla="*/ 2206171 h 4513942"/>
+              <a:gd name="connsiteX5" fmla="*/ 1297724 w 1907325"/>
+              <a:gd name="connsiteY5" fmla="*/ 2496457 h 4513942"/>
+              <a:gd name="connsiteX6" fmla="*/ 572010 w 1907325"/>
+              <a:gd name="connsiteY6" fmla="*/ 2772228 h 4513942"/>
+              <a:gd name="connsiteX7" fmla="*/ 281724 w 1907325"/>
+              <a:gd name="connsiteY7" fmla="*/ 2714171 h 4513942"/>
+              <a:gd name="connsiteX8" fmla="*/ 5953 w 1907325"/>
+              <a:gd name="connsiteY8" fmla="*/ 2119085 h 4513942"/>
+              <a:gd name="connsiteX9" fmla="*/ 20467 w 1907325"/>
+              <a:gd name="connsiteY9" fmla="*/ 1640114 h 4513942"/>
+              <a:gd name="connsiteX10" fmla="*/ 194638 w 1907325"/>
+              <a:gd name="connsiteY10" fmla="*/ 1364342 h 4513942"/>
+              <a:gd name="connsiteX11" fmla="*/ 891324 w 1907325"/>
+              <a:gd name="connsiteY11" fmla="*/ 1088571 h 4513942"/>
+              <a:gd name="connsiteX12" fmla="*/ 1181610 w 1907325"/>
+              <a:gd name="connsiteY12" fmla="*/ 1059542 h 4513942"/>
+              <a:gd name="connsiteX13" fmla="*/ 1370296 w 1907325"/>
+              <a:gd name="connsiteY13" fmla="*/ 1103085 h 4513942"/>
+              <a:gd name="connsiteX14" fmla="*/ 1646067 w 1907325"/>
+              <a:gd name="connsiteY14" fmla="*/ 1320800 h 4513942"/>
+              <a:gd name="connsiteX15" fmla="*/ 1747667 w 1907325"/>
+              <a:gd name="connsiteY15" fmla="*/ 1640114 h 4513942"/>
+              <a:gd name="connsiteX16" fmla="*/ 1892810 w 1907325"/>
+              <a:gd name="connsiteY16" fmla="*/ 2249714 h 4513942"/>
+              <a:gd name="connsiteX17" fmla="*/ 1805724 w 1907325"/>
+              <a:gd name="connsiteY17" fmla="*/ 3135085 h 4513942"/>
+              <a:gd name="connsiteX18" fmla="*/ 1660581 w 1907325"/>
+              <a:gd name="connsiteY18" fmla="*/ 3614057 h 4513942"/>
+              <a:gd name="connsiteX19" fmla="*/ 1399324 w 1907325"/>
+              <a:gd name="connsiteY19" fmla="*/ 3947885 h 4513942"/>
+              <a:gd name="connsiteX20" fmla="*/ 1283210 w 1907325"/>
+              <a:gd name="connsiteY20" fmla="*/ 4122057 h 4513942"/>
+              <a:gd name="connsiteX21" fmla="*/ 1196124 w 1907325"/>
+              <a:gd name="connsiteY21" fmla="*/ 4397828 h 4513942"/>
+              <a:gd name="connsiteX22" fmla="*/ 1152581 w 1907325"/>
+              <a:gd name="connsiteY22" fmla="*/ 4513942 h 4513942"/>
+            </a:gdLst>
+            <a:ahLst/>
+            <a:cxnLst>
+              <a:cxn ang="0">
+                <a:pos x="connsiteX0" y="connsiteY0"/>
+              </a:cxn>
+              <a:cxn ang="0">
+                <a:pos x="connsiteX1" y="connsiteY1"/>
+              </a:cxn>
+              <a:cxn ang="0">
+                <a:pos x="connsiteX2" y="connsiteY2"/>
+              </a:cxn>
+              <a:cxn ang="0">
+                <a:pos x="connsiteX3" y="connsiteY3"/>
+              </a:cxn>
+              <a:cxn ang="0">
+                <a:pos x="connsiteX4" y="connsiteY4"/>
+              </a:cxn>
+              <a:cxn ang="0">
+                <a:pos x="connsiteX5" y="connsiteY5"/>
+              </a:cxn>
+              <a:cxn ang="0">
+                <a:pos x="connsiteX6" y="connsiteY6"/>
+              </a:cxn>
+              <a:cxn ang="0">
+                <a:pos x="connsiteX7" y="connsiteY7"/>
+              </a:cxn>
+              <a:cxn ang="0">
+                <a:pos x="connsiteX8" y="connsiteY8"/>
+              </a:cxn>
+              <a:cxn ang="0">
+                <a:pos x="connsiteX9" y="connsiteY9"/>
+              </a:cxn>
+              <a:cxn ang="0">
+                <a:pos x="connsiteX10" y="connsiteY10"/>
+              </a:cxn>
+              <a:cxn ang="0">
+                <a:pos x="connsiteX11" y="connsiteY11"/>
+              </a:cxn>
+              <a:cxn ang="0">
+                <a:pos x="connsiteX12" y="connsiteY12"/>
+              </a:cxn>
+              <a:cxn ang="0">
+                <a:pos x="connsiteX13" y="connsiteY13"/>
+              </a:cxn>
+              <a:cxn ang="0">
+                <a:pos x="connsiteX14" y="connsiteY14"/>
+              </a:cxn>
+              <a:cxn ang="0">
+                <a:pos x="connsiteX15" y="connsiteY15"/>
+              </a:cxn>
+              <a:cxn ang="0">
+                <a:pos x="connsiteX16" y="connsiteY16"/>
+              </a:cxn>
+              <a:cxn ang="0">
+                <a:pos x="connsiteX17" y="connsiteY17"/>
+              </a:cxn>
+              <a:cxn ang="0">
+                <a:pos x="connsiteX18" y="connsiteY18"/>
+              </a:cxn>
+              <a:cxn ang="0">
+                <a:pos x="connsiteX19" y="connsiteY19"/>
+              </a:cxn>
+              <a:cxn ang="0">
+                <a:pos x="connsiteX20" y="connsiteY20"/>
+              </a:cxn>
+              <a:cxn ang="0">
+                <a:pos x="connsiteX21" y="connsiteY21"/>
+              </a:cxn>
+              <a:cxn ang="0">
+                <a:pos x="connsiteX22" y="connsiteY22"/>
+              </a:cxn>
+            </a:cxnLst>
+            <a:rect l="l" t="t" r="r" b="b"/>
+            <a:pathLst>
+              <a:path w="1907325" h="4513942">
+                <a:moveTo>
+                  <a:pt x="1268696" y="0"/>
+                </a:moveTo>
+                <a:cubicBezTo>
+                  <a:pt x="1442773" y="124340"/>
+                  <a:pt x="1389854" y="67227"/>
+                  <a:pt x="1544467" y="348342"/>
+                </a:cubicBezTo>
+                <a:cubicBezTo>
+                  <a:pt x="1699367" y="629979"/>
+                  <a:pt x="1682866" y="628863"/>
+                  <a:pt x="1762181" y="914400"/>
+                </a:cubicBezTo>
+                <a:cubicBezTo>
+                  <a:pt x="1776471" y="1078734"/>
+                  <a:pt x="1815799" y="1351947"/>
+                  <a:pt x="1776696" y="1524000"/>
+                </a:cubicBezTo>
+                <a:cubicBezTo>
+                  <a:pt x="1747705" y="1651561"/>
+                  <a:pt x="1570804" y="2083882"/>
+                  <a:pt x="1500924" y="2206171"/>
+                </a:cubicBezTo>
+                <a:cubicBezTo>
+                  <a:pt x="1442324" y="2308722"/>
+                  <a:pt x="1384895" y="2416758"/>
+                  <a:pt x="1297724" y="2496457"/>
+                </a:cubicBezTo>
+                <a:cubicBezTo>
+                  <a:pt x="1086760" y="2689339"/>
+                  <a:pt x="836364" y="2708418"/>
+                  <a:pt x="572010" y="2772228"/>
+                </a:cubicBezTo>
+                <a:cubicBezTo>
+                  <a:pt x="475248" y="2752876"/>
+                  <a:pt x="368793" y="2760608"/>
+                  <a:pt x="281724" y="2714171"/>
+                </a:cubicBezTo>
+                <a:cubicBezTo>
+                  <a:pt x="101836" y="2618231"/>
+                  <a:pt x="43703" y="2240724"/>
+                  <a:pt x="5953" y="2119085"/>
+                </a:cubicBezTo>
+                <a:cubicBezTo>
+                  <a:pt x="10791" y="1959428"/>
+                  <a:pt x="-18273" y="1795075"/>
+                  <a:pt x="20467" y="1640114"/>
+                </a:cubicBezTo>
+                <a:cubicBezTo>
+                  <a:pt x="46836" y="1534637"/>
+                  <a:pt x="119120" y="1442557"/>
+                  <a:pt x="194638" y="1364342"/>
+                </a:cubicBezTo>
+                <a:cubicBezTo>
+                  <a:pt x="353037" y="1200286"/>
+                  <a:pt x="709339" y="1127068"/>
+                  <a:pt x="891324" y="1088571"/>
+                </a:cubicBezTo>
+                <a:cubicBezTo>
+                  <a:pt x="986463" y="1068445"/>
+                  <a:pt x="1084848" y="1069218"/>
+                  <a:pt x="1181610" y="1059542"/>
+                </a:cubicBezTo>
+                <a:cubicBezTo>
+                  <a:pt x="1244505" y="1074056"/>
+                  <a:pt x="1310554" y="1078645"/>
+                  <a:pt x="1370296" y="1103085"/>
+                </a:cubicBezTo>
+                <a:cubicBezTo>
+                  <a:pt x="1458125" y="1139015"/>
+                  <a:pt x="1582620" y="1263698"/>
+                  <a:pt x="1646067" y="1320800"/>
+                </a:cubicBezTo>
+                <a:cubicBezTo>
+                  <a:pt x="1679934" y="1427238"/>
+                  <a:pt x="1718992" y="1532161"/>
+                  <a:pt x="1747667" y="1640114"/>
+                </a:cubicBezTo>
+                <a:cubicBezTo>
+                  <a:pt x="1801291" y="1841994"/>
+                  <a:pt x="1892810" y="2249714"/>
+                  <a:pt x="1892810" y="2249714"/>
+                </a:cubicBezTo>
+                <a:cubicBezTo>
+                  <a:pt x="1912101" y="2693420"/>
+                  <a:pt x="1933113" y="2603050"/>
+                  <a:pt x="1805724" y="3135085"/>
+                </a:cubicBezTo>
+                <a:cubicBezTo>
+                  <a:pt x="1766878" y="3297326"/>
+                  <a:pt x="1735188" y="3464843"/>
+                  <a:pt x="1660581" y="3614057"/>
+                </a:cubicBezTo>
+                <a:cubicBezTo>
+                  <a:pt x="1597389" y="3740441"/>
+                  <a:pt x="1483586" y="3834456"/>
+                  <a:pt x="1399324" y="3947885"/>
+                </a:cubicBezTo>
+                <a:cubicBezTo>
+                  <a:pt x="1357715" y="4003897"/>
+                  <a:pt x="1321915" y="4064000"/>
+                  <a:pt x="1283210" y="4122057"/>
+                </a:cubicBezTo>
+                <a:cubicBezTo>
+                  <a:pt x="1254181" y="4213981"/>
+                  <a:pt x="1226608" y="4306377"/>
+                  <a:pt x="1196124" y="4397828"/>
+                </a:cubicBezTo>
+                <a:cubicBezTo>
+                  <a:pt x="1183052" y="4437043"/>
+                  <a:pt x="1152581" y="4513942"/>
+                  <a:pt x="1152581" y="4513942"/>
+                </a:cubicBezTo>
+              </a:path>
+            </a:pathLst>
+          </a:custGeom>
+          <a:noFill/>
+          <a:ln w="76200"/>
+        </p:spPr>
+        <p:style>
+          <a:lnRef idx="2">
+            <a:schemeClr val="accent1">
+              <a:shade val="15000"/>
+            </a:schemeClr>
+          </a:lnRef>
+          <a:fillRef idx="1">
+            <a:schemeClr val="accent1"/>
+          </a:fillRef>
+          <a:effectRef idx="0">
+            <a:schemeClr val="accent1"/>
+          </a:effectRef>
+          <a:fontRef idx="minor">
+            <a:schemeClr val="lt1"/>
+          </a:fontRef>
+        </p:style>
+        <p:txBody>
+          <a:bodyPr rtlCol="0" anchor="ctr"/>
+          <a:lstStyle/>
+          <a:p>
+            <a:pPr algn="ctr"/>
+            <a:endParaRPr lang="en-US"/>
           </a:p>
         </p:txBody>
       </p:sp>
@@ -5217,8 +6801,8 @@
         </p:blipFill>
         <p:spPr>
           <a:xfrm>
-            <a:off x="90311" y="50800"/>
-            <a:ext cx="12011378" cy="6756400"/>
+            <a:off x="0" y="0"/>
+            <a:ext cx="12192000" cy="6858000"/>
           </a:xfrm>
           <a:prstGeom prst="rect">
             <a:avLst/>
@@ -5239,6 +6823,199 @@
 </file>
 
 <file path=ppt/slides/slide5.xml><?xml version="1.0" encoding="utf-8"?>
+<p:sld xmlns:a="http://schemas.openxmlformats.org/drawingml/2006/main" xmlns:r="http://schemas.openxmlformats.org/officeDocument/2006/relationships" xmlns:p="http://schemas.openxmlformats.org/presentationml/2006/main">
+  <p:cSld>
+    <p:spTree>
+      <p:nvGrpSpPr>
+        <p:cNvPr id="1" name="">
+          <a:extLst>
+            <a:ext uri="{FF2B5EF4-FFF2-40B4-BE49-F238E27FC236}">
+              <a16:creationId xmlns:a16="http://schemas.microsoft.com/office/drawing/2014/main" id="{39575494-AD2F-57F9-25C9-7AA8310419C9}"/>
+            </a:ext>
+          </a:extLst>
+        </p:cNvPr>
+        <p:cNvGrpSpPr/>
+        <p:nvPr/>
+      </p:nvGrpSpPr>
+      <p:grpSpPr>
+        <a:xfrm>
+          <a:off x="0" y="0"/>
+          <a:ext cx="0" cy="0"/>
+          <a:chOff x="0" y="0"/>
+          <a:chExt cx="0" cy="0"/>
+        </a:xfrm>
+      </p:grpSpPr>
+      <p:pic>
+        <p:nvPicPr>
+          <p:cNvPr id="3" name="Imagen 2">
+            <a:extLst>
+              <a:ext uri="{FF2B5EF4-FFF2-40B4-BE49-F238E27FC236}">
+                <a16:creationId xmlns:a16="http://schemas.microsoft.com/office/drawing/2014/main" id="{DF96B5C3-EC5C-C995-9520-747D679593C5}"/>
+              </a:ext>
+            </a:extLst>
+          </p:cNvPr>
+          <p:cNvPicPr>
+            <a:picLocks noChangeAspect="1"/>
+          </p:cNvPicPr>
+          <p:nvPr/>
+        </p:nvPicPr>
+        <p:blipFill>
+          <a:blip r:embed="rId2"/>
+          <a:stretch>
+            <a:fillRect/>
+          </a:stretch>
+        </p:blipFill>
+        <p:spPr>
+          <a:xfrm>
+            <a:off x="0" y="0"/>
+            <a:ext cx="12192000" cy="6858000"/>
+          </a:xfrm>
+          <a:prstGeom prst="rect">
+            <a:avLst/>
+          </a:prstGeom>
+        </p:spPr>
+      </p:pic>
+    </p:spTree>
+    <p:extLst>
+      <p:ext uri="{BB962C8B-B14F-4D97-AF65-F5344CB8AC3E}">
+        <p14:creationId xmlns:p14="http://schemas.microsoft.com/office/powerpoint/2010/main" val="2696400198"/>
+      </p:ext>
+    </p:extLst>
+  </p:cSld>
+  <p:clrMapOvr>
+    <a:masterClrMapping/>
+  </p:clrMapOvr>
+  <mc:AlternateContent xmlns:mc="http://schemas.openxmlformats.org/markup-compatibility/2006">
+    <mc:Choice xmlns:p14="http://schemas.microsoft.com/office/powerpoint/2010/main" Requires="p14">
+      <p:transition spd="med" p14:dur="700">
+        <p:fade/>
+      </p:transition>
+    </mc:Choice>
+    <mc:Fallback>
+      <p:transition spd="med">
+        <p:fade/>
+      </p:transition>
+    </mc:Fallback>
+  </mc:AlternateContent>
+</p:sld>
+</file>
+
+<file path=ppt/slides/slide6.xml><?xml version="1.0" encoding="utf-8"?>
+<p:sld xmlns:a="http://schemas.openxmlformats.org/drawingml/2006/main" xmlns:r="http://schemas.openxmlformats.org/officeDocument/2006/relationships" xmlns:p="http://schemas.openxmlformats.org/presentationml/2006/main">
+  <p:cSld>
+    <p:spTree>
+      <p:nvGrpSpPr>
+        <p:cNvPr id="1" name="">
+          <a:extLst>
+            <a:ext uri="{FF2B5EF4-FFF2-40B4-BE49-F238E27FC236}">
+              <a16:creationId xmlns:a16="http://schemas.microsoft.com/office/drawing/2014/main" id="{31B3DEF8-4B71-B242-1A4E-E965829480D6}"/>
+            </a:ext>
+          </a:extLst>
+        </p:cNvPr>
+        <p:cNvGrpSpPr/>
+        <p:nvPr/>
+      </p:nvGrpSpPr>
+      <p:grpSpPr>
+        <a:xfrm>
+          <a:off x="0" y="0"/>
+          <a:ext cx="0" cy="0"/>
+          <a:chOff x="0" y="0"/>
+          <a:chExt cx="0" cy="0"/>
+        </a:xfrm>
+      </p:grpSpPr>
+      <p:pic>
+        <p:nvPicPr>
+          <p:cNvPr id="4" name="Imagen 3">
+            <a:extLst>
+              <a:ext uri="{FF2B5EF4-FFF2-40B4-BE49-F238E27FC236}">
+                <a16:creationId xmlns:a16="http://schemas.microsoft.com/office/drawing/2014/main" id="{170DE254-D729-5D6C-6C50-48E8F8F30B7B}"/>
+              </a:ext>
+            </a:extLst>
+          </p:cNvPr>
+          <p:cNvPicPr>
+            <a:picLocks noChangeAspect="1"/>
+          </p:cNvPicPr>
+          <p:nvPr/>
+        </p:nvPicPr>
+        <p:blipFill>
+          <a:blip r:embed="rId2"/>
+          <a:srcRect t="35619"/>
+          <a:stretch>
+            <a:fillRect/>
+          </a:stretch>
+        </p:blipFill>
+        <p:spPr>
+          <a:xfrm>
+            <a:off x="5348130" y="2215166"/>
+            <a:ext cx="6106377" cy="3704419"/>
+          </a:xfrm>
+          <a:prstGeom prst="rect">
+            <a:avLst/>
+          </a:prstGeom>
+          <a:ln w="38100">
+            <a:solidFill>
+              <a:srgbClr val="8A008A"/>
+            </a:solidFill>
+            <a:prstDash val="dash"/>
+          </a:ln>
+        </p:spPr>
+      </p:pic>
+      <p:pic>
+        <p:nvPicPr>
+          <p:cNvPr id="6" name="Imagen 5">
+            <a:extLst>
+              <a:ext uri="{FF2B5EF4-FFF2-40B4-BE49-F238E27FC236}">
+                <a16:creationId xmlns:a16="http://schemas.microsoft.com/office/drawing/2014/main" id="{1109225D-AB0C-BB9A-9011-2A2D3E6C6B37}"/>
+              </a:ext>
+            </a:extLst>
+          </p:cNvPr>
+          <p:cNvPicPr>
+            <a:picLocks noChangeAspect="1"/>
+          </p:cNvPicPr>
+          <p:nvPr/>
+        </p:nvPicPr>
+        <p:blipFill>
+          <a:blip r:embed="rId3"/>
+          <a:stretch>
+            <a:fillRect/>
+          </a:stretch>
+        </p:blipFill>
+        <p:spPr>
+          <a:xfrm>
+            <a:off x="8307027" y="230077"/>
+            <a:ext cx="3562847" cy="1343212"/>
+          </a:xfrm>
+          <a:prstGeom prst="rect">
+            <a:avLst/>
+          </a:prstGeom>
+        </p:spPr>
+      </p:pic>
+    </p:spTree>
+    <p:extLst>
+      <p:ext uri="{BB962C8B-B14F-4D97-AF65-F5344CB8AC3E}">
+        <p14:creationId xmlns:p14="http://schemas.microsoft.com/office/powerpoint/2010/main" val="4182237466"/>
+      </p:ext>
+    </p:extLst>
+  </p:cSld>
+  <p:clrMapOvr>
+    <a:masterClrMapping/>
+  </p:clrMapOvr>
+  <mc:AlternateContent xmlns:mc="http://schemas.openxmlformats.org/markup-compatibility/2006">
+    <mc:Choice xmlns:p159="http://schemas.microsoft.com/office/powerpoint/2015/09/main" Requires="p159">
+      <p:transition xmlns:p14="http://schemas.microsoft.com/office/powerpoint/2010/main" spd="slow" p14:dur="2000">
+        <p159:morph option="byObject"/>
+      </p:transition>
+    </mc:Choice>
+    <mc:Fallback>
+      <p:transition spd="slow">
+        <p:fade/>
+      </p:transition>
+    </mc:Fallback>
+  </mc:AlternateContent>
+</p:sld>
+</file>
+
+<file path=ppt/slides/slide7.xml><?xml version="1.0" encoding="utf-8"?>
 <p:sld xmlns:a="http://schemas.openxmlformats.org/drawingml/2006/main" xmlns:r="http://schemas.openxmlformats.org/officeDocument/2006/relationships" xmlns:p="http://schemas.openxmlformats.org/presentationml/2006/main">
   <p:cSld>
     <p:spTree>
@@ -6182,7 +7959,7 @@
 </p:sld>
 </file>
 
-<file path=ppt/slides/slide6.xml><?xml version="1.0" encoding="utf-8"?>
+<file path=ppt/slides/slide8.xml><?xml version="1.0" encoding="utf-8"?>
 <p:sld xmlns:a="http://schemas.openxmlformats.org/drawingml/2006/main" xmlns:r="http://schemas.openxmlformats.org/officeDocument/2006/relationships" xmlns:p="http://schemas.openxmlformats.org/presentationml/2006/main">
   <p:cSld>
     <p:spTree>
@@ -6352,981 +8129,6 @@
     <p:extLst>
       <p:ext uri="{BB962C8B-B14F-4D97-AF65-F5344CB8AC3E}">
         <p14:creationId xmlns:p14="http://schemas.microsoft.com/office/powerpoint/2010/main" val="2739628271"/>
-      </p:ext>
-    </p:extLst>
-  </p:cSld>
-  <p:clrMapOvr>
-    <a:masterClrMapping/>
-  </p:clrMapOvr>
-</p:sld>
-</file>
-
-<file path=ppt/slides/slide7.xml><?xml version="1.0" encoding="utf-8"?>
-<p:sld xmlns:a="http://schemas.openxmlformats.org/drawingml/2006/main" xmlns:r="http://schemas.openxmlformats.org/officeDocument/2006/relationships" xmlns:p="http://schemas.openxmlformats.org/presentationml/2006/main">
-  <p:cSld>
-    <p:spTree>
-      <p:nvGrpSpPr>
-        <p:cNvPr id="1" name=""/>
-        <p:cNvGrpSpPr/>
-        <p:nvPr/>
-      </p:nvGrpSpPr>
-      <p:grpSpPr>
-        <a:xfrm>
-          <a:off x="0" y="0"/>
-          <a:ext cx="0" cy="0"/>
-          <a:chOff x="0" y="0"/>
-          <a:chExt cx="0" cy="0"/>
-        </a:xfrm>
-      </p:grpSpPr>
-      <p:sp>
-        <p:nvSpPr>
-          <p:cNvPr id="2" name="Título 1">
-            <a:extLst>
-              <a:ext uri="{FF2B5EF4-FFF2-40B4-BE49-F238E27FC236}">
-                <a16:creationId xmlns:a16="http://schemas.microsoft.com/office/drawing/2014/main" id="{C2C1A36E-6995-86A7-BF67-E4CD22FAA9A1}"/>
-              </a:ext>
-            </a:extLst>
-          </p:cNvPr>
-          <p:cNvSpPr>
-            <a:spLocks noGrp="1"/>
-          </p:cNvSpPr>
-          <p:nvPr>
-            <p:ph type="title"/>
-          </p:nvPr>
-        </p:nvSpPr>
-        <p:spPr/>
-        <p:txBody>
-          <a:bodyPr/>
-          <a:lstStyle/>
-          <a:p>
-            <a:r>
-              <a:rPr lang="en-US" dirty="0"/>
-              <a:t>If </a:t>
-            </a:r>
-            <a:r>
-              <a:rPr lang="en-US" dirty="0" err="1"/>
-              <a:t>elif</a:t>
-            </a:r>
-            <a:r>
-              <a:rPr lang="en-US" dirty="0"/>
-              <a:t> </a:t>
-            </a:r>
-            <a:r>
-              <a:rPr lang="en-US" dirty="0" err="1"/>
-              <a:t>elif</a:t>
-            </a:r>
-            <a:r>
-              <a:rPr lang="en-US" dirty="0"/>
-              <a:t> </a:t>
-            </a:r>
-            <a:r>
-              <a:rPr lang="en-US" dirty="0" err="1"/>
-              <a:t>elif</a:t>
-            </a:r>
-            <a:r>
-              <a:rPr lang="en-US" dirty="0"/>
-              <a:t> </a:t>
-            </a:r>
-            <a:r>
-              <a:rPr lang="en-US" dirty="0" err="1"/>
-              <a:t>elif</a:t>
-            </a:r>
-            <a:r>
-              <a:rPr lang="en-US" dirty="0"/>
-              <a:t>… else</a:t>
-            </a:r>
-          </a:p>
-        </p:txBody>
-      </p:sp>
-      <p:sp>
-        <p:nvSpPr>
-          <p:cNvPr id="4" name="Elipse 3">
-            <a:extLst>
-              <a:ext uri="{FF2B5EF4-FFF2-40B4-BE49-F238E27FC236}">
-                <a16:creationId xmlns:a16="http://schemas.microsoft.com/office/drawing/2014/main" id="{74FA6E06-181C-FD4D-1578-B066BD26D278}"/>
-              </a:ext>
-            </a:extLst>
-          </p:cNvPr>
-          <p:cNvSpPr/>
-          <p:nvPr/>
-        </p:nvSpPr>
-        <p:spPr>
-          <a:xfrm>
-            <a:off x="4477871" y="2205318"/>
-            <a:ext cx="1371600" cy="510988"/>
-          </a:xfrm>
-          <a:prstGeom prst="ellipse">
-            <a:avLst/>
-          </a:prstGeom>
-          <a:solidFill>
-            <a:srgbClr val="CAD7EE"/>
-          </a:solidFill>
-          <a:ln w="38100"/>
-        </p:spPr>
-        <p:style>
-          <a:lnRef idx="2">
-            <a:schemeClr val="accent1">
-              <a:shade val="15000"/>
-            </a:schemeClr>
-          </a:lnRef>
-          <a:fillRef idx="1">
-            <a:schemeClr val="accent1"/>
-          </a:fillRef>
-          <a:effectRef idx="0">
-            <a:schemeClr val="accent1"/>
-          </a:effectRef>
-          <a:fontRef idx="minor">
-            <a:schemeClr val="lt1"/>
-          </a:fontRef>
-        </p:style>
-        <p:txBody>
-          <a:bodyPr rtlCol="0" anchor="ctr"/>
-          <a:lstStyle/>
-          <a:p>
-            <a:pPr algn="ctr"/>
-            <a:endParaRPr lang="en-US"/>
-          </a:p>
-        </p:txBody>
-      </p:sp>
-      <p:sp>
-        <p:nvSpPr>
-          <p:cNvPr id="5" name="Elipse 4">
-            <a:extLst>
-              <a:ext uri="{FF2B5EF4-FFF2-40B4-BE49-F238E27FC236}">
-                <a16:creationId xmlns:a16="http://schemas.microsoft.com/office/drawing/2014/main" id="{9CA15D1E-56B3-9AF2-4BFC-193F9C87DE52}"/>
-              </a:ext>
-            </a:extLst>
-          </p:cNvPr>
-          <p:cNvSpPr/>
-          <p:nvPr/>
-        </p:nvSpPr>
-        <p:spPr>
-          <a:xfrm>
-            <a:off x="3581401" y="3429000"/>
-            <a:ext cx="1371600" cy="510988"/>
-          </a:xfrm>
-          <a:prstGeom prst="ellipse">
-            <a:avLst/>
-          </a:prstGeom>
-          <a:solidFill>
-            <a:srgbClr val="CAD7EE"/>
-          </a:solidFill>
-          <a:ln w="38100"/>
-        </p:spPr>
-        <p:style>
-          <a:lnRef idx="2">
-            <a:schemeClr val="accent1">
-              <a:shade val="15000"/>
-            </a:schemeClr>
-          </a:lnRef>
-          <a:fillRef idx="1">
-            <a:schemeClr val="accent1"/>
-          </a:fillRef>
-          <a:effectRef idx="0">
-            <a:schemeClr val="accent1"/>
-          </a:effectRef>
-          <a:fontRef idx="minor">
-            <a:schemeClr val="lt1"/>
-          </a:fontRef>
-        </p:style>
-        <p:txBody>
-          <a:bodyPr rtlCol="0" anchor="ctr"/>
-          <a:lstStyle/>
-          <a:p>
-            <a:pPr algn="ctr"/>
-            <a:endParaRPr lang="en-US"/>
-          </a:p>
-        </p:txBody>
-      </p:sp>
-      <p:sp>
-        <p:nvSpPr>
-          <p:cNvPr id="6" name="Elipse 5">
-            <a:extLst>
-              <a:ext uri="{FF2B5EF4-FFF2-40B4-BE49-F238E27FC236}">
-                <a16:creationId xmlns:a16="http://schemas.microsoft.com/office/drawing/2014/main" id="{49B89C6F-F762-CAEF-1D31-F598E09F8D1F}"/>
-              </a:ext>
-            </a:extLst>
-          </p:cNvPr>
-          <p:cNvSpPr/>
-          <p:nvPr/>
-        </p:nvSpPr>
-        <p:spPr>
-          <a:xfrm>
-            <a:off x="5867401" y="3429000"/>
-            <a:ext cx="1371600" cy="510988"/>
-          </a:xfrm>
-          <a:prstGeom prst="ellipse">
-            <a:avLst/>
-          </a:prstGeom>
-          <a:solidFill>
-            <a:srgbClr val="CAD7EE"/>
-          </a:solidFill>
-          <a:ln w="38100"/>
-        </p:spPr>
-        <p:style>
-          <a:lnRef idx="2">
-            <a:schemeClr val="accent1">
-              <a:shade val="15000"/>
-            </a:schemeClr>
-          </a:lnRef>
-          <a:fillRef idx="1">
-            <a:schemeClr val="accent1"/>
-          </a:fillRef>
-          <a:effectRef idx="0">
-            <a:schemeClr val="accent1"/>
-          </a:effectRef>
-          <a:fontRef idx="minor">
-            <a:schemeClr val="lt1"/>
-          </a:fontRef>
-        </p:style>
-        <p:txBody>
-          <a:bodyPr rtlCol="0" anchor="ctr"/>
-          <a:lstStyle/>
-          <a:p>
-            <a:pPr algn="ctr"/>
-            <a:endParaRPr lang="en-US"/>
-          </a:p>
-        </p:txBody>
-      </p:sp>
-      <p:sp>
-        <p:nvSpPr>
-          <p:cNvPr id="7" name="Elipse 6">
-            <a:extLst>
-              <a:ext uri="{FF2B5EF4-FFF2-40B4-BE49-F238E27FC236}">
-                <a16:creationId xmlns:a16="http://schemas.microsoft.com/office/drawing/2014/main" id="{BEE1E460-A4AC-2787-2999-4A2395CD7562}"/>
-              </a:ext>
-            </a:extLst>
-          </p:cNvPr>
-          <p:cNvSpPr/>
-          <p:nvPr/>
-        </p:nvSpPr>
-        <p:spPr>
-          <a:xfrm>
-            <a:off x="5553637" y="4454618"/>
-            <a:ext cx="896468" cy="333978"/>
-          </a:xfrm>
-          <a:prstGeom prst="ellipse">
-            <a:avLst/>
-          </a:prstGeom>
-          <a:solidFill>
-            <a:srgbClr val="CAD7EE"/>
-          </a:solidFill>
-          <a:ln w="38100"/>
-        </p:spPr>
-        <p:style>
-          <a:lnRef idx="2">
-            <a:schemeClr val="accent1">
-              <a:shade val="15000"/>
-            </a:schemeClr>
-          </a:lnRef>
-          <a:fillRef idx="1">
-            <a:schemeClr val="accent1"/>
-          </a:fillRef>
-          <a:effectRef idx="0">
-            <a:schemeClr val="accent1"/>
-          </a:effectRef>
-          <a:fontRef idx="minor">
-            <a:schemeClr val="lt1"/>
-          </a:fontRef>
-        </p:style>
-        <p:txBody>
-          <a:bodyPr rtlCol="0" anchor="ctr"/>
-          <a:lstStyle/>
-          <a:p>
-            <a:pPr algn="ctr"/>
-            <a:endParaRPr lang="en-US"/>
-          </a:p>
-        </p:txBody>
-      </p:sp>
-      <p:sp>
-        <p:nvSpPr>
-          <p:cNvPr id="8" name="Elipse 7">
-            <a:extLst>
-              <a:ext uri="{FF2B5EF4-FFF2-40B4-BE49-F238E27FC236}">
-                <a16:creationId xmlns:a16="http://schemas.microsoft.com/office/drawing/2014/main" id="{9B1C16B8-C906-A3C3-BC0F-CFDB223E7196}"/>
-              </a:ext>
-            </a:extLst>
-          </p:cNvPr>
-          <p:cNvSpPr/>
-          <p:nvPr/>
-        </p:nvSpPr>
-        <p:spPr>
-          <a:xfrm>
-            <a:off x="7064190" y="4454618"/>
-            <a:ext cx="896468" cy="333978"/>
-          </a:xfrm>
-          <a:prstGeom prst="ellipse">
-            <a:avLst/>
-          </a:prstGeom>
-          <a:solidFill>
-            <a:srgbClr val="CAD7EE"/>
-          </a:solidFill>
-          <a:ln w="38100"/>
-        </p:spPr>
-        <p:style>
-          <a:lnRef idx="2">
-            <a:schemeClr val="accent1">
-              <a:shade val="15000"/>
-            </a:schemeClr>
-          </a:lnRef>
-          <a:fillRef idx="1">
-            <a:schemeClr val="accent1"/>
-          </a:fillRef>
-          <a:effectRef idx="0">
-            <a:schemeClr val="accent1"/>
-          </a:effectRef>
-          <a:fontRef idx="minor">
-            <a:schemeClr val="lt1"/>
-          </a:fontRef>
-        </p:style>
-        <p:txBody>
-          <a:bodyPr rtlCol="0" anchor="ctr"/>
-          <a:lstStyle/>
-          <a:p>
-            <a:pPr algn="ctr"/>
-            <a:endParaRPr lang="en-US"/>
-          </a:p>
-        </p:txBody>
-      </p:sp>
-      <p:sp>
-        <p:nvSpPr>
-          <p:cNvPr id="9" name="Elipse 8">
-            <a:extLst>
-              <a:ext uri="{FF2B5EF4-FFF2-40B4-BE49-F238E27FC236}">
-                <a16:creationId xmlns:a16="http://schemas.microsoft.com/office/drawing/2014/main" id="{64D3C52F-F39A-5067-AE1C-3C1384711BEA}"/>
-              </a:ext>
-            </a:extLst>
-          </p:cNvPr>
-          <p:cNvSpPr/>
-          <p:nvPr/>
-        </p:nvSpPr>
-        <p:spPr>
-          <a:xfrm>
-            <a:off x="5095094" y="5450194"/>
-            <a:ext cx="612286" cy="228106"/>
-          </a:xfrm>
-          <a:prstGeom prst="ellipse">
-            <a:avLst/>
-          </a:prstGeom>
-          <a:solidFill>
-            <a:srgbClr val="CAD7EE"/>
-          </a:solidFill>
-          <a:ln w="38100"/>
-        </p:spPr>
-        <p:style>
-          <a:lnRef idx="2">
-            <a:schemeClr val="accent1">
-              <a:shade val="15000"/>
-            </a:schemeClr>
-          </a:lnRef>
-          <a:fillRef idx="1">
-            <a:schemeClr val="accent1"/>
-          </a:fillRef>
-          <a:effectRef idx="0">
-            <a:schemeClr val="accent1"/>
-          </a:effectRef>
-          <a:fontRef idx="minor">
-            <a:schemeClr val="lt1"/>
-          </a:fontRef>
-        </p:style>
-        <p:txBody>
-          <a:bodyPr rtlCol="0" anchor="ctr"/>
-          <a:lstStyle/>
-          <a:p>
-            <a:pPr algn="ctr"/>
-            <a:endParaRPr lang="en-US"/>
-          </a:p>
-        </p:txBody>
-      </p:sp>
-      <p:sp>
-        <p:nvSpPr>
-          <p:cNvPr id="10" name="Elipse 9">
-            <a:extLst>
-              <a:ext uri="{FF2B5EF4-FFF2-40B4-BE49-F238E27FC236}">
-                <a16:creationId xmlns:a16="http://schemas.microsoft.com/office/drawing/2014/main" id="{F1E47987-3623-7AC3-524C-03498B4CB9F4}"/>
-              </a:ext>
-            </a:extLst>
-          </p:cNvPr>
-          <p:cNvSpPr/>
-          <p:nvPr/>
-        </p:nvSpPr>
-        <p:spPr>
-          <a:xfrm>
-            <a:off x="6362250" y="5487932"/>
-            <a:ext cx="510990" cy="190368"/>
-          </a:xfrm>
-          <a:prstGeom prst="ellipse">
-            <a:avLst/>
-          </a:prstGeom>
-          <a:solidFill>
-            <a:srgbClr val="CAD7EE"/>
-          </a:solidFill>
-          <a:ln w="38100"/>
-        </p:spPr>
-        <p:style>
-          <a:lnRef idx="2">
-            <a:schemeClr val="accent1">
-              <a:shade val="15000"/>
-            </a:schemeClr>
-          </a:lnRef>
-          <a:fillRef idx="1">
-            <a:schemeClr val="accent1"/>
-          </a:fillRef>
-          <a:effectRef idx="0">
-            <a:schemeClr val="accent1"/>
-          </a:effectRef>
-          <a:fontRef idx="minor">
-            <a:schemeClr val="lt1"/>
-          </a:fontRef>
-        </p:style>
-        <p:txBody>
-          <a:bodyPr rtlCol="0" anchor="ctr"/>
-          <a:lstStyle/>
-          <a:p>
-            <a:pPr algn="ctr"/>
-            <a:endParaRPr lang="en-US"/>
-          </a:p>
-        </p:txBody>
-      </p:sp>
-      <p:cxnSp>
-        <p:nvCxnSpPr>
-          <p:cNvPr id="13" name="Conector recto de flecha 12">
-            <a:extLst>
-              <a:ext uri="{FF2B5EF4-FFF2-40B4-BE49-F238E27FC236}">
-                <a16:creationId xmlns:a16="http://schemas.microsoft.com/office/drawing/2014/main" id="{44BB4E3F-C3A1-8BE8-7F99-3C13A592DD73}"/>
-              </a:ext>
-            </a:extLst>
-          </p:cNvPr>
-          <p:cNvCxnSpPr>
-            <a:cxnSpLocks/>
-          </p:cNvCxnSpPr>
-          <p:nvPr/>
-        </p:nvCxnSpPr>
-        <p:spPr>
-          <a:xfrm>
-            <a:off x="5570220" y="2811780"/>
-            <a:ext cx="480060" cy="579120"/>
-          </a:xfrm>
-          <a:prstGeom prst="straightConnector1">
-            <a:avLst/>
-          </a:prstGeom>
-          <a:ln w="38100">
-            <a:solidFill>
-              <a:srgbClr val="8C308C"/>
-            </a:solidFill>
-            <a:tailEnd type="triangle"/>
-          </a:ln>
-        </p:spPr>
-        <p:style>
-          <a:lnRef idx="1">
-            <a:schemeClr val="accent1"/>
-          </a:lnRef>
-          <a:fillRef idx="0">
-            <a:schemeClr val="accent1"/>
-          </a:fillRef>
-          <a:effectRef idx="0">
-            <a:schemeClr val="accent1"/>
-          </a:effectRef>
-          <a:fontRef idx="minor">
-            <a:schemeClr val="tx1"/>
-          </a:fontRef>
-        </p:style>
-      </p:cxnSp>
-      <p:cxnSp>
-        <p:nvCxnSpPr>
-          <p:cNvPr id="3" name="Conector recto de flecha 2">
-            <a:extLst>
-              <a:ext uri="{FF2B5EF4-FFF2-40B4-BE49-F238E27FC236}">
-                <a16:creationId xmlns:a16="http://schemas.microsoft.com/office/drawing/2014/main" id="{BCAA3593-B499-FE90-74A8-4EF44A834EA2}"/>
-              </a:ext>
-            </a:extLst>
-          </p:cNvPr>
-          <p:cNvCxnSpPr>
-            <a:cxnSpLocks/>
-          </p:cNvCxnSpPr>
-          <p:nvPr/>
-        </p:nvCxnSpPr>
-        <p:spPr>
-          <a:xfrm>
-            <a:off x="7064190" y="4042487"/>
-            <a:ext cx="228785" cy="364413"/>
-          </a:xfrm>
-          <a:prstGeom prst="straightConnector1">
-            <a:avLst/>
-          </a:prstGeom>
-          <a:ln w="38100">
-            <a:solidFill>
-              <a:srgbClr val="8C308C"/>
-            </a:solidFill>
-            <a:tailEnd type="triangle"/>
-          </a:ln>
-        </p:spPr>
-        <p:style>
-          <a:lnRef idx="1">
-            <a:schemeClr val="accent1"/>
-          </a:lnRef>
-          <a:fillRef idx="0">
-            <a:schemeClr val="accent1"/>
-          </a:fillRef>
-          <a:effectRef idx="0">
-            <a:schemeClr val="accent1"/>
-          </a:effectRef>
-          <a:fontRef idx="minor">
-            <a:schemeClr val="tx1"/>
-          </a:fontRef>
-        </p:style>
-      </p:cxnSp>
-      <p:cxnSp>
-        <p:nvCxnSpPr>
-          <p:cNvPr id="12" name="Conector recto de flecha 11">
-            <a:extLst>
-              <a:ext uri="{FF2B5EF4-FFF2-40B4-BE49-F238E27FC236}">
-                <a16:creationId xmlns:a16="http://schemas.microsoft.com/office/drawing/2014/main" id="{67D50BAA-D249-DDAA-665D-B5E1EBCB1052}"/>
-              </a:ext>
-            </a:extLst>
-          </p:cNvPr>
-          <p:cNvCxnSpPr>
-            <a:cxnSpLocks/>
-          </p:cNvCxnSpPr>
-          <p:nvPr/>
-        </p:nvCxnSpPr>
-        <p:spPr>
-          <a:xfrm flipH="1">
-            <a:off x="6045200" y="4015096"/>
-            <a:ext cx="117290" cy="363229"/>
-          </a:xfrm>
-          <a:prstGeom prst="straightConnector1">
-            <a:avLst/>
-          </a:prstGeom>
-          <a:ln w="38100">
-            <a:solidFill>
-              <a:srgbClr val="8C308C"/>
-            </a:solidFill>
-            <a:tailEnd type="triangle"/>
-          </a:ln>
-        </p:spPr>
-        <p:style>
-          <a:lnRef idx="1">
-            <a:schemeClr val="accent1"/>
-          </a:lnRef>
-          <a:fillRef idx="0">
-            <a:schemeClr val="accent1"/>
-          </a:fillRef>
-          <a:effectRef idx="0">
-            <a:schemeClr val="accent1"/>
-          </a:effectRef>
-          <a:fontRef idx="minor">
-            <a:schemeClr val="tx1"/>
-          </a:fontRef>
-        </p:style>
-      </p:cxnSp>
-      <p:cxnSp>
-        <p:nvCxnSpPr>
-          <p:cNvPr id="15" name="Conector recto de flecha 14">
-            <a:extLst>
-              <a:ext uri="{FF2B5EF4-FFF2-40B4-BE49-F238E27FC236}">
-                <a16:creationId xmlns:a16="http://schemas.microsoft.com/office/drawing/2014/main" id="{A788B5FD-8371-B90F-59FA-5CCDBE0839E5}"/>
-              </a:ext>
-            </a:extLst>
-          </p:cNvPr>
-          <p:cNvCxnSpPr>
-            <a:cxnSpLocks/>
-          </p:cNvCxnSpPr>
-          <p:nvPr/>
-        </p:nvCxnSpPr>
-        <p:spPr>
-          <a:xfrm flipH="1">
-            <a:off x="5499100" y="4864889"/>
-            <a:ext cx="171827" cy="450061"/>
-          </a:xfrm>
-          <a:prstGeom prst="straightConnector1">
-            <a:avLst/>
-          </a:prstGeom>
-          <a:ln w="38100">
-            <a:solidFill>
-              <a:srgbClr val="8C308C"/>
-            </a:solidFill>
-            <a:tailEnd type="triangle"/>
-          </a:ln>
-        </p:spPr>
-        <p:style>
-          <a:lnRef idx="1">
-            <a:schemeClr val="accent1"/>
-          </a:lnRef>
-          <a:fillRef idx="0">
-            <a:schemeClr val="accent1"/>
-          </a:fillRef>
-          <a:effectRef idx="0">
-            <a:schemeClr val="accent1"/>
-          </a:effectRef>
-          <a:fontRef idx="minor">
-            <a:schemeClr val="tx1"/>
-          </a:fontRef>
-        </p:style>
-      </p:cxnSp>
-      <p:cxnSp>
-        <p:nvCxnSpPr>
-          <p:cNvPr id="17" name="Conector recto de flecha 16">
-            <a:extLst>
-              <a:ext uri="{FF2B5EF4-FFF2-40B4-BE49-F238E27FC236}">
-                <a16:creationId xmlns:a16="http://schemas.microsoft.com/office/drawing/2014/main" id="{8F43E409-93ED-8176-90B5-50F9DC7FBD15}"/>
-              </a:ext>
-            </a:extLst>
-          </p:cNvPr>
-          <p:cNvCxnSpPr>
-            <a:cxnSpLocks/>
-          </p:cNvCxnSpPr>
-          <p:nvPr/>
-        </p:nvCxnSpPr>
-        <p:spPr>
-          <a:xfrm>
-            <a:off x="6275672" y="4892955"/>
-            <a:ext cx="214028" cy="479145"/>
-          </a:xfrm>
-          <a:prstGeom prst="straightConnector1">
-            <a:avLst/>
-          </a:prstGeom>
-          <a:ln w="38100">
-            <a:solidFill>
-              <a:srgbClr val="8C308C"/>
-            </a:solidFill>
-            <a:tailEnd type="triangle"/>
-          </a:ln>
-        </p:spPr>
-        <p:style>
-          <a:lnRef idx="1">
-            <a:schemeClr val="accent1"/>
-          </a:lnRef>
-          <a:fillRef idx="0">
-            <a:schemeClr val="accent1"/>
-          </a:fillRef>
-          <a:effectRef idx="0">
-            <a:schemeClr val="accent1"/>
-          </a:effectRef>
-          <a:fontRef idx="minor">
-            <a:schemeClr val="tx1"/>
-          </a:fontRef>
-        </p:style>
-      </p:cxnSp>
-      <p:cxnSp>
-        <p:nvCxnSpPr>
-          <p:cNvPr id="19" name="Conector recto de flecha 18">
-            <a:extLst>
-              <a:ext uri="{FF2B5EF4-FFF2-40B4-BE49-F238E27FC236}">
-                <a16:creationId xmlns:a16="http://schemas.microsoft.com/office/drawing/2014/main" id="{E8F6B92C-A7B0-2FE2-2303-78BBFD642AA3}"/>
-              </a:ext>
-            </a:extLst>
-          </p:cNvPr>
-          <p:cNvCxnSpPr>
-            <a:cxnSpLocks/>
-          </p:cNvCxnSpPr>
-          <p:nvPr/>
-        </p:nvCxnSpPr>
-        <p:spPr>
-          <a:xfrm flipH="1">
-            <a:off x="4425950" y="2811780"/>
-            <a:ext cx="287021" cy="560070"/>
-          </a:xfrm>
-          <a:prstGeom prst="straightConnector1">
-            <a:avLst/>
-          </a:prstGeom>
-          <a:ln w="38100">
-            <a:solidFill>
-              <a:srgbClr val="8C308C"/>
-            </a:solidFill>
-            <a:tailEnd type="triangle"/>
-          </a:ln>
-        </p:spPr>
-        <p:style>
-          <a:lnRef idx="1">
-            <a:schemeClr val="accent1"/>
-          </a:lnRef>
-          <a:fillRef idx="0">
-            <a:schemeClr val="accent1"/>
-          </a:fillRef>
-          <a:effectRef idx="0">
-            <a:schemeClr val="accent1"/>
-          </a:effectRef>
-          <a:fontRef idx="minor">
-            <a:schemeClr val="tx1"/>
-          </a:fontRef>
-        </p:style>
-      </p:cxnSp>
-      <p:cxnSp>
-        <p:nvCxnSpPr>
-          <p:cNvPr id="21" name="Conector recto de flecha 20">
-            <a:extLst>
-              <a:ext uri="{FF2B5EF4-FFF2-40B4-BE49-F238E27FC236}">
-                <a16:creationId xmlns:a16="http://schemas.microsoft.com/office/drawing/2014/main" id="{CA7C94DD-AF9A-8E05-1D5E-99884ED59211}"/>
-              </a:ext>
-            </a:extLst>
-          </p:cNvPr>
-          <p:cNvCxnSpPr>
-            <a:cxnSpLocks/>
-          </p:cNvCxnSpPr>
-          <p:nvPr/>
-        </p:nvCxnSpPr>
-        <p:spPr>
-          <a:xfrm flipH="1">
-            <a:off x="6267083" y="5852314"/>
-            <a:ext cx="171827" cy="450061"/>
-          </a:xfrm>
-          <a:prstGeom prst="straightConnector1">
-            <a:avLst/>
-          </a:prstGeom>
-          <a:ln w="38100">
-            <a:solidFill>
-              <a:srgbClr val="8C308C"/>
-            </a:solidFill>
-            <a:tailEnd type="triangle"/>
-          </a:ln>
-        </p:spPr>
-        <p:style>
-          <a:lnRef idx="1">
-            <a:schemeClr val="accent1"/>
-          </a:lnRef>
-          <a:fillRef idx="0">
-            <a:schemeClr val="accent1"/>
-          </a:fillRef>
-          <a:effectRef idx="0">
-            <a:schemeClr val="accent1"/>
-          </a:effectRef>
-          <a:fontRef idx="minor">
-            <a:schemeClr val="tx1"/>
-          </a:fontRef>
-        </p:style>
-      </p:cxnSp>
-      <p:cxnSp>
-        <p:nvCxnSpPr>
-          <p:cNvPr id="22" name="Conector recto de flecha 21">
-            <a:extLst>
-              <a:ext uri="{FF2B5EF4-FFF2-40B4-BE49-F238E27FC236}">
-                <a16:creationId xmlns:a16="http://schemas.microsoft.com/office/drawing/2014/main" id="{5E1D05D7-E521-7E86-0D2B-5FE633F646B0}"/>
-              </a:ext>
-            </a:extLst>
-          </p:cNvPr>
-          <p:cNvCxnSpPr>
-            <a:cxnSpLocks/>
-          </p:cNvCxnSpPr>
-          <p:nvPr/>
-        </p:nvCxnSpPr>
-        <p:spPr>
-          <a:xfrm>
-            <a:off x="6818690" y="5841725"/>
-            <a:ext cx="286960" cy="450062"/>
-          </a:xfrm>
-          <a:prstGeom prst="straightConnector1">
-            <a:avLst/>
-          </a:prstGeom>
-          <a:ln w="38100">
-            <a:solidFill>
-              <a:srgbClr val="8C308C"/>
-            </a:solidFill>
-            <a:tailEnd type="triangle"/>
-          </a:ln>
-        </p:spPr>
-        <p:style>
-          <a:lnRef idx="1">
-            <a:schemeClr val="accent1"/>
-          </a:lnRef>
-          <a:fillRef idx="0">
-            <a:schemeClr val="accent1"/>
-          </a:fillRef>
-          <a:effectRef idx="0">
-            <a:schemeClr val="accent1"/>
-          </a:effectRef>
-          <a:fontRef idx="minor">
-            <a:schemeClr val="tx1"/>
-          </a:fontRef>
-        </p:style>
-      </p:cxnSp>
-      <p:sp>
-        <p:nvSpPr>
-          <p:cNvPr id="24" name="CuadroTexto 23">
-            <a:extLst>
-              <a:ext uri="{FF2B5EF4-FFF2-40B4-BE49-F238E27FC236}">
-                <a16:creationId xmlns:a16="http://schemas.microsoft.com/office/drawing/2014/main" id="{C41EC24C-E427-29F5-20DE-AFAF20671589}"/>
-              </a:ext>
-            </a:extLst>
-          </p:cNvPr>
-          <p:cNvSpPr txBox="1"/>
-          <p:nvPr/>
-        </p:nvSpPr>
-        <p:spPr>
-          <a:xfrm>
-            <a:off x="6001871" y="6291787"/>
-            <a:ext cx="622767" cy="307777"/>
-          </a:xfrm>
-          <a:prstGeom prst="rect">
-            <a:avLst/>
-          </a:prstGeom>
-          <a:noFill/>
-        </p:spPr>
-        <p:txBody>
-          <a:bodyPr wrap="square" rtlCol="0">
-            <a:spAutoFit/>
-          </a:bodyPr>
-          <a:lstStyle/>
-          <a:p>
-            <a:r>
-              <a:rPr lang="en-US" sz="1400" i="1" dirty="0">
-                <a:solidFill>
-                  <a:schemeClr val="bg2">
-                    <a:lumMod val="50000"/>
-                  </a:schemeClr>
-                </a:solidFill>
-              </a:rPr>
-              <a:t>Etc.</a:t>
-            </a:r>
-          </a:p>
-        </p:txBody>
-      </p:sp>
-      <p:sp>
-        <p:nvSpPr>
-          <p:cNvPr id="25" name="CuadroTexto 24">
-            <a:extLst>
-              <a:ext uri="{FF2B5EF4-FFF2-40B4-BE49-F238E27FC236}">
-                <a16:creationId xmlns:a16="http://schemas.microsoft.com/office/drawing/2014/main" id="{160D2AED-48D3-9E53-C8AD-A6912AC7373A}"/>
-              </a:ext>
-            </a:extLst>
-          </p:cNvPr>
-          <p:cNvSpPr txBox="1"/>
-          <p:nvPr/>
-        </p:nvSpPr>
-        <p:spPr>
-          <a:xfrm>
-            <a:off x="7032993" y="6291787"/>
-            <a:ext cx="622767" cy="307777"/>
-          </a:xfrm>
-          <a:prstGeom prst="rect">
-            <a:avLst/>
-          </a:prstGeom>
-          <a:noFill/>
-        </p:spPr>
-        <p:txBody>
-          <a:bodyPr wrap="square" rtlCol="0">
-            <a:spAutoFit/>
-          </a:bodyPr>
-          <a:lstStyle/>
-          <a:p>
-            <a:r>
-              <a:rPr lang="en-US" sz="1400" i="1" dirty="0">
-                <a:solidFill>
-                  <a:schemeClr val="bg2">
-                    <a:lumMod val="50000"/>
-                  </a:schemeClr>
-                </a:solidFill>
-              </a:rPr>
-              <a:t>Etc.</a:t>
-            </a:r>
-          </a:p>
-        </p:txBody>
-      </p:sp>
-    </p:spTree>
-    <p:extLst>
-      <p:ext uri="{BB962C8B-B14F-4D97-AF65-F5344CB8AC3E}">
-        <p14:creationId xmlns:p14="http://schemas.microsoft.com/office/powerpoint/2010/main" val="2395973969"/>
-      </p:ext>
-    </p:extLst>
-  </p:cSld>
-  <p:clrMapOvr>
-    <a:masterClrMapping/>
-  </p:clrMapOvr>
-</p:sld>
-</file>
-
-<file path=ppt/slides/slide8.xml><?xml version="1.0" encoding="utf-8"?>
-<p:sld xmlns:a="http://schemas.openxmlformats.org/drawingml/2006/main" xmlns:r="http://schemas.openxmlformats.org/officeDocument/2006/relationships" xmlns:p="http://schemas.openxmlformats.org/presentationml/2006/main">
-  <p:cSld>
-    <p:spTree>
-      <p:nvGrpSpPr>
-        <p:cNvPr id="1" name=""/>
-        <p:cNvGrpSpPr/>
-        <p:nvPr/>
-      </p:nvGrpSpPr>
-      <p:grpSpPr>
-        <a:xfrm>
-          <a:off x="0" y="0"/>
-          <a:ext cx="0" cy="0"/>
-          <a:chOff x="0" y="0"/>
-          <a:chExt cx="0" cy="0"/>
-        </a:xfrm>
-      </p:grpSpPr>
-      <p:sp>
-        <p:nvSpPr>
-          <p:cNvPr id="2" name="Título 1">
-            <a:extLst>
-              <a:ext uri="{FF2B5EF4-FFF2-40B4-BE49-F238E27FC236}">
-                <a16:creationId xmlns:a16="http://schemas.microsoft.com/office/drawing/2014/main" id="{D124B94B-EA6C-22DA-E37D-4574F40ABF16}"/>
-              </a:ext>
-            </a:extLst>
-          </p:cNvPr>
-          <p:cNvSpPr>
-            <a:spLocks noGrp="1"/>
-          </p:cNvSpPr>
-          <p:nvPr>
-            <p:ph type="title"/>
-          </p:nvPr>
-        </p:nvSpPr>
-        <p:spPr/>
-        <p:txBody>
-          <a:bodyPr/>
-          <a:lstStyle/>
-          <a:p>
-            <a:r>
-              <a:rPr lang="en-US" dirty="0"/>
-              <a:t>It’s very easy to </a:t>
-            </a:r>
-            <a:r>
-              <a:rPr lang="en-US" b="1" i="1" dirty="0">
-                <a:solidFill>
-                  <a:srgbClr val="C00000"/>
-                </a:solidFill>
-              </a:rPr>
-              <a:t>get lost</a:t>
-            </a:r>
-            <a:r>
-              <a:rPr lang="en-US" dirty="0"/>
-              <a:t>… right?</a:t>
-            </a:r>
-          </a:p>
-        </p:txBody>
-      </p:sp>
-      <p:sp>
-        <p:nvSpPr>
-          <p:cNvPr id="3" name="Marcador de contenido 2">
-            <a:extLst>
-              <a:ext uri="{FF2B5EF4-FFF2-40B4-BE49-F238E27FC236}">
-                <a16:creationId xmlns:a16="http://schemas.microsoft.com/office/drawing/2014/main" id="{51B2091F-F58B-2073-ED14-0B909D8B1E24}"/>
-              </a:ext>
-            </a:extLst>
-          </p:cNvPr>
-          <p:cNvSpPr>
-            <a:spLocks noGrp="1"/>
-          </p:cNvSpPr>
-          <p:nvPr>
-            <p:ph idx="1"/>
-          </p:nvPr>
-        </p:nvSpPr>
-        <p:spPr/>
-        <p:txBody>
-          <a:bodyPr/>
-          <a:lstStyle/>
-          <a:p>
-            <a:pPr marL="0" indent="0">
-              <a:buNone/>
-            </a:pPr>
-            <a:r>
-              <a:rPr lang="en-US" dirty="0"/>
-              <a:t>If you get lost when coding, do your own drawings on pen and paper!</a:t>
-            </a:r>
-          </a:p>
-        </p:txBody>
-      </p:sp>
-    </p:spTree>
-    <p:extLst>
-      <p:ext uri="{BB962C8B-B14F-4D97-AF65-F5344CB8AC3E}">
-        <p14:creationId xmlns:p14="http://schemas.microsoft.com/office/powerpoint/2010/main" val="202441297"/>
       </p:ext>
     </p:extLst>
   </p:cSld>
@@ -7358,7 +8160,7 @@
           <p:cNvPr id="2" name="Título 1">
             <a:extLst>
               <a:ext uri="{FF2B5EF4-FFF2-40B4-BE49-F238E27FC236}">
-                <a16:creationId xmlns:a16="http://schemas.microsoft.com/office/drawing/2014/main" id="{BAAA4A2C-E2FF-62C5-40E9-8254794D89C9}"/>
+                <a16:creationId xmlns:a16="http://schemas.microsoft.com/office/drawing/2014/main" id="{C2C1A36E-6995-86A7-BF67-E4CD22FAA9A1}"/>
               </a:ext>
             </a:extLst>
           </p:cNvPr>
@@ -7375,78 +8177,832 @@
           <a:lstStyle/>
           <a:p>
             <a:r>
-              <a:rPr lang="es-AR" b="1" dirty="0" err="1">
-                <a:latin typeface="Consolas" panose="020B0609020204030204" pitchFamily="49" charset="0"/>
-                <a:cs typeface="Cascadia Code SemiBold" panose="020B0609020000020004" pitchFamily="49" charset="0"/>
-              </a:rPr>
-              <a:t>While</a:t>
-            </a:r>
-            <a:br>
-              <a:rPr lang="es-AR" dirty="0"/>
-            </a:br>
-            <a:r>
-              <a:rPr lang="es-AR" i="1" dirty="0">
+              <a:rPr lang="en-US" dirty="0"/>
+              <a:t>If </a:t>
+            </a:r>
+            <a:r>
+              <a:rPr lang="en-US" dirty="0" err="1"/>
+              <a:t>elif</a:t>
+            </a:r>
+            <a:r>
+              <a:rPr lang="en-US" dirty="0"/>
+              <a:t> </a:t>
+            </a:r>
+            <a:r>
+              <a:rPr lang="en-US" dirty="0" err="1"/>
+              <a:t>elif</a:t>
+            </a:r>
+            <a:r>
+              <a:rPr lang="en-US" dirty="0"/>
+              <a:t> </a:t>
+            </a:r>
+            <a:r>
+              <a:rPr lang="en-US" dirty="0" err="1"/>
+              <a:t>elif</a:t>
+            </a:r>
+            <a:r>
+              <a:rPr lang="en-US" dirty="0"/>
+              <a:t> </a:t>
+            </a:r>
+            <a:r>
+              <a:rPr lang="en-US" dirty="0" err="1"/>
+              <a:t>elif</a:t>
+            </a:r>
+            <a:r>
+              <a:rPr lang="en-US" dirty="0"/>
+              <a:t>… else</a:t>
+            </a:r>
+          </a:p>
+        </p:txBody>
+      </p:sp>
+      <p:sp>
+        <p:nvSpPr>
+          <p:cNvPr id="4" name="Elipse 3">
+            <a:extLst>
+              <a:ext uri="{FF2B5EF4-FFF2-40B4-BE49-F238E27FC236}">
+                <a16:creationId xmlns:a16="http://schemas.microsoft.com/office/drawing/2014/main" id="{74FA6E06-181C-FD4D-1578-B066BD26D278}"/>
+              </a:ext>
+            </a:extLst>
+          </p:cNvPr>
+          <p:cNvSpPr/>
+          <p:nvPr/>
+        </p:nvSpPr>
+        <p:spPr>
+          <a:xfrm>
+            <a:off x="4477871" y="2205318"/>
+            <a:ext cx="1371600" cy="510988"/>
+          </a:xfrm>
+          <a:prstGeom prst="ellipse">
+            <a:avLst/>
+          </a:prstGeom>
+          <a:solidFill>
+            <a:srgbClr val="CAD7EE"/>
+          </a:solidFill>
+          <a:ln w="38100"/>
+        </p:spPr>
+        <p:style>
+          <a:lnRef idx="2">
+            <a:schemeClr val="accent1">
+              <a:shade val="15000"/>
+            </a:schemeClr>
+          </a:lnRef>
+          <a:fillRef idx="1">
+            <a:schemeClr val="accent1"/>
+          </a:fillRef>
+          <a:effectRef idx="0">
+            <a:schemeClr val="accent1"/>
+          </a:effectRef>
+          <a:fontRef idx="minor">
+            <a:schemeClr val="lt1"/>
+          </a:fontRef>
+        </p:style>
+        <p:txBody>
+          <a:bodyPr rtlCol="0" anchor="ctr"/>
+          <a:lstStyle/>
+          <a:p>
+            <a:pPr algn="ctr"/>
+            <a:endParaRPr lang="en-US"/>
+          </a:p>
+        </p:txBody>
+      </p:sp>
+      <p:sp>
+        <p:nvSpPr>
+          <p:cNvPr id="5" name="Elipse 4">
+            <a:extLst>
+              <a:ext uri="{FF2B5EF4-FFF2-40B4-BE49-F238E27FC236}">
+                <a16:creationId xmlns:a16="http://schemas.microsoft.com/office/drawing/2014/main" id="{9CA15D1E-56B3-9AF2-4BFC-193F9C87DE52}"/>
+              </a:ext>
+            </a:extLst>
+          </p:cNvPr>
+          <p:cNvSpPr/>
+          <p:nvPr/>
+        </p:nvSpPr>
+        <p:spPr>
+          <a:xfrm>
+            <a:off x="3581401" y="3429000"/>
+            <a:ext cx="1371600" cy="510988"/>
+          </a:xfrm>
+          <a:prstGeom prst="ellipse">
+            <a:avLst/>
+          </a:prstGeom>
+          <a:solidFill>
+            <a:srgbClr val="CAD7EE"/>
+          </a:solidFill>
+          <a:ln w="38100"/>
+        </p:spPr>
+        <p:style>
+          <a:lnRef idx="2">
+            <a:schemeClr val="accent1">
+              <a:shade val="15000"/>
+            </a:schemeClr>
+          </a:lnRef>
+          <a:fillRef idx="1">
+            <a:schemeClr val="accent1"/>
+          </a:fillRef>
+          <a:effectRef idx="0">
+            <a:schemeClr val="accent1"/>
+          </a:effectRef>
+          <a:fontRef idx="minor">
+            <a:schemeClr val="lt1"/>
+          </a:fontRef>
+        </p:style>
+        <p:txBody>
+          <a:bodyPr rtlCol="0" anchor="ctr"/>
+          <a:lstStyle/>
+          <a:p>
+            <a:pPr algn="ctr"/>
+            <a:endParaRPr lang="en-US"/>
+          </a:p>
+        </p:txBody>
+      </p:sp>
+      <p:sp>
+        <p:nvSpPr>
+          <p:cNvPr id="6" name="Elipse 5">
+            <a:extLst>
+              <a:ext uri="{FF2B5EF4-FFF2-40B4-BE49-F238E27FC236}">
+                <a16:creationId xmlns:a16="http://schemas.microsoft.com/office/drawing/2014/main" id="{49B89C6F-F762-CAEF-1D31-F598E09F8D1F}"/>
+              </a:ext>
+            </a:extLst>
+          </p:cNvPr>
+          <p:cNvSpPr/>
+          <p:nvPr/>
+        </p:nvSpPr>
+        <p:spPr>
+          <a:xfrm>
+            <a:off x="5867401" y="3429000"/>
+            <a:ext cx="1371600" cy="510988"/>
+          </a:xfrm>
+          <a:prstGeom prst="ellipse">
+            <a:avLst/>
+          </a:prstGeom>
+          <a:solidFill>
+            <a:srgbClr val="CAD7EE"/>
+          </a:solidFill>
+          <a:ln w="38100"/>
+        </p:spPr>
+        <p:style>
+          <a:lnRef idx="2">
+            <a:schemeClr val="accent1">
+              <a:shade val="15000"/>
+            </a:schemeClr>
+          </a:lnRef>
+          <a:fillRef idx="1">
+            <a:schemeClr val="accent1"/>
+          </a:fillRef>
+          <a:effectRef idx="0">
+            <a:schemeClr val="accent1"/>
+          </a:effectRef>
+          <a:fontRef idx="minor">
+            <a:schemeClr val="lt1"/>
+          </a:fontRef>
+        </p:style>
+        <p:txBody>
+          <a:bodyPr rtlCol="0" anchor="ctr"/>
+          <a:lstStyle/>
+          <a:p>
+            <a:pPr algn="ctr"/>
+            <a:endParaRPr lang="en-US"/>
+          </a:p>
+        </p:txBody>
+      </p:sp>
+      <p:sp>
+        <p:nvSpPr>
+          <p:cNvPr id="7" name="Elipse 6">
+            <a:extLst>
+              <a:ext uri="{FF2B5EF4-FFF2-40B4-BE49-F238E27FC236}">
+                <a16:creationId xmlns:a16="http://schemas.microsoft.com/office/drawing/2014/main" id="{BEE1E460-A4AC-2787-2999-4A2395CD7562}"/>
+              </a:ext>
+            </a:extLst>
+          </p:cNvPr>
+          <p:cNvSpPr/>
+          <p:nvPr/>
+        </p:nvSpPr>
+        <p:spPr>
+          <a:xfrm>
+            <a:off x="5553637" y="4454618"/>
+            <a:ext cx="896468" cy="333978"/>
+          </a:xfrm>
+          <a:prstGeom prst="ellipse">
+            <a:avLst/>
+          </a:prstGeom>
+          <a:solidFill>
+            <a:srgbClr val="CAD7EE"/>
+          </a:solidFill>
+          <a:ln w="38100"/>
+        </p:spPr>
+        <p:style>
+          <a:lnRef idx="2">
+            <a:schemeClr val="accent1">
+              <a:shade val="15000"/>
+            </a:schemeClr>
+          </a:lnRef>
+          <a:fillRef idx="1">
+            <a:schemeClr val="accent1"/>
+          </a:fillRef>
+          <a:effectRef idx="0">
+            <a:schemeClr val="accent1"/>
+          </a:effectRef>
+          <a:fontRef idx="minor">
+            <a:schemeClr val="lt1"/>
+          </a:fontRef>
+        </p:style>
+        <p:txBody>
+          <a:bodyPr rtlCol="0" anchor="ctr"/>
+          <a:lstStyle/>
+          <a:p>
+            <a:pPr algn="ctr"/>
+            <a:endParaRPr lang="en-US"/>
+          </a:p>
+        </p:txBody>
+      </p:sp>
+      <p:sp>
+        <p:nvSpPr>
+          <p:cNvPr id="8" name="Elipse 7">
+            <a:extLst>
+              <a:ext uri="{FF2B5EF4-FFF2-40B4-BE49-F238E27FC236}">
+                <a16:creationId xmlns:a16="http://schemas.microsoft.com/office/drawing/2014/main" id="{9B1C16B8-C906-A3C3-BC0F-CFDB223E7196}"/>
+              </a:ext>
+            </a:extLst>
+          </p:cNvPr>
+          <p:cNvSpPr/>
+          <p:nvPr/>
+        </p:nvSpPr>
+        <p:spPr>
+          <a:xfrm>
+            <a:off x="7064190" y="4454618"/>
+            <a:ext cx="896468" cy="333978"/>
+          </a:xfrm>
+          <a:prstGeom prst="ellipse">
+            <a:avLst/>
+          </a:prstGeom>
+          <a:solidFill>
+            <a:srgbClr val="CAD7EE"/>
+          </a:solidFill>
+          <a:ln w="38100"/>
+        </p:spPr>
+        <p:style>
+          <a:lnRef idx="2">
+            <a:schemeClr val="accent1">
+              <a:shade val="15000"/>
+            </a:schemeClr>
+          </a:lnRef>
+          <a:fillRef idx="1">
+            <a:schemeClr val="accent1"/>
+          </a:fillRef>
+          <a:effectRef idx="0">
+            <a:schemeClr val="accent1"/>
+          </a:effectRef>
+          <a:fontRef idx="minor">
+            <a:schemeClr val="lt1"/>
+          </a:fontRef>
+        </p:style>
+        <p:txBody>
+          <a:bodyPr rtlCol="0" anchor="ctr"/>
+          <a:lstStyle/>
+          <a:p>
+            <a:pPr algn="ctr"/>
+            <a:endParaRPr lang="en-US"/>
+          </a:p>
+        </p:txBody>
+      </p:sp>
+      <p:sp>
+        <p:nvSpPr>
+          <p:cNvPr id="9" name="Elipse 8">
+            <a:extLst>
+              <a:ext uri="{FF2B5EF4-FFF2-40B4-BE49-F238E27FC236}">
+                <a16:creationId xmlns:a16="http://schemas.microsoft.com/office/drawing/2014/main" id="{64D3C52F-F39A-5067-AE1C-3C1384711BEA}"/>
+              </a:ext>
+            </a:extLst>
+          </p:cNvPr>
+          <p:cNvSpPr/>
+          <p:nvPr/>
+        </p:nvSpPr>
+        <p:spPr>
+          <a:xfrm>
+            <a:off x="5095094" y="5450194"/>
+            <a:ext cx="612286" cy="228106"/>
+          </a:xfrm>
+          <a:prstGeom prst="ellipse">
+            <a:avLst/>
+          </a:prstGeom>
+          <a:solidFill>
+            <a:srgbClr val="CAD7EE"/>
+          </a:solidFill>
+          <a:ln w="38100"/>
+        </p:spPr>
+        <p:style>
+          <a:lnRef idx="2">
+            <a:schemeClr val="accent1">
+              <a:shade val="15000"/>
+            </a:schemeClr>
+          </a:lnRef>
+          <a:fillRef idx="1">
+            <a:schemeClr val="accent1"/>
+          </a:fillRef>
+          <a:effectRef idx="0">
+            <a:schemeClr val="accent1"/>
+          </a:effectRef>
+          <a:fontRef idx="minor">
+            <a:schemeClr val="lt1"/>
+          </a:fontRef>
+        </p:style>
+        <p:txBody>
+          <a:bodyPr rtlCol="0" anchor="ctr"/>
+          <a:lstStyle/>
+          <a:p>
+            <a:pPr algn="ctr"/>
+            <a:endParaRPr lang="en-US"/>
+          </a:p>
+        </p:txBody>
+      </p:sp>
+      <p:sp>
+        <p:nvSpPr>
+          <p:cNvPr id="10" name="Elipse 9">
+            <a:extLst>
+              <a:ext uri="{FF2B5EF4-FFF2-40B4-BE49-F238E27FC236}">
+                <a16:creationId xmlns:a16="http://schemas.microsoft.com/office/drawing/2014/main" id="{F1E47987-3623-7AC3-524C-03498B4CB9F4}"/>
+              </a:ext>
+            </a:extLst>
+          </p:cNvPr>
+          <p:cNvSpPr/>
+          <p:nvPr/>
+        </p:nvSpPr>
+        <p:spPr>
+          <a:xfrm>
+            <a:off x="6362250" y="5487932"/>
+            <a:ext cx="510990" cy="190368"/>
+          </a:xfrm>
+          <a:prstGeom prst="ellipse">
+            <a:avLst/>
+          </a:prstGeom>
+          <a:solidFill>
+            <a:srgbClr val="CAD7EE"/>
+          </a:solidFill>
+          <a:ln w="38100"/>
+        </p:spPr>
+        <p:style>
+          <a:lnRef idx="2">
+            <a:schemeClr val="accent1">
+              <a:shade val="15000"/>
+            </a:schemeClr>
+          </a:lnRef>
+          <a:fillRef idx="1">
+            <a:schemeClr val="accent1"/>
+          </a:fillRef>
+          <a:effectRef idx="0">
+            <a:schemeClr val="accent1"/>
+          </a:effectRef>
+          <a:fontRef idx="minor">
+            <a:schemeClr val="lt1"/>
+          </a:fontRef>
+        </p:style>
+        <p:txBody>
+          <a:bodyPr rtlCol="0" anchor="ctr"/>
+          <a:lstStyle/>
+          <a:p>
+            <a:pPr algn="ctr"/>
+            <a:endParaRPr lang="en-US"/>
+          </a:p>
+        </p:txBody>
+      </p:sp>
+      <p:cxnSp>
+        <p:nvCxnSpPr>
+          <p:cNvPr id="13" name="Conector recto de flecha 12">
+            <a:extLst>
+              <a:ext uri="{FF2B5EF4-FFF2-40B4-BE49-F238E27FC236}">
+                <a16:creationId xmlns:a16="http://schemas.microsoft.com/office/drawing/2014/main" id="{44BB4E3F-C3A1-8BE8-7F99-3C13A592DD73}"/>
+              </a:ext>
+            </a:extLst>
+          </p:cNvPr>
+          <p:cNvCxnSpPr>
+            <a:cxnSpLocks/>
+          </p:cNvCxnSpPr>
+          <p:nvPr/>
+        </p:nvCxnSpPr>
+        <p:spPr>
+          <a:xfrm>
+            <a:off x="5570220" y="2811780"/>
+            <a:ext cx="480060" cy="579120"/>
+          </a:xfrm>
+          <a:prstGeom prst="straightConnector1">
+            <a:avLst/>
+          </a:prstGeom>
+          <a:ln w="38100">
+            <a:solidFill>
+              <a:srgbClr val="8C308C"/>
+            </a:solidFill>
+            <a:tailEnd type="triangle"/>
+          </a:ln>
+        </p:spPr>
+        <p:style>
+          <a:lnRef idx="1">
+            <a:schemeClr val="accent1"/>
+          </a:lnRef>
+          <a:fillRef idx="0">
+            <a:schemeClr val="accent1"/>
+          </a:fillRef>
+          <a:effectRef idx="0">
+            <a:schemeClr val="accent1"/>
+          </a:effectRef>
+          <a:fontRef idx="minor">
+            <a:schemeClr val="tx1"/>
+          </a:fontRef>
+        </p:style>
+      </p:cxnSp>
+      <p:cxnSp>
+        <p:nvCxnSpPr>
+          <p:cNvPr id="3" name="Conector recto de flecha 2">
+            <a:extLst>
+              <a:ext uri="{FF2B5EF4-FFF2-40B4-BE49-F238E27FC236}">
+                <a16:creationId xmlns:a16="http://schemas.microsoft.com/office/drawing/2014/main" id="{BCAA3593-B499-FE90-74A8-4EF44A834EA2}"/>
+              </a:ext>
+            </a:extLst>
+          </p:cNvPr>
+          <p:cNvCxnSpPr>
+            <a:cxnSpLocks/>
+          </p:cNvCxnSpPr>
+          <p:nvPr/>
+        </p:nvCxnSpPr>
+        <p:spPr>
+          <a:xfrm>
+            <a:off x="7064190" y="4042487"/>
+            <a:ext cx="228785" cy="364413"/>
+          </a:xfrm>
+          <a:prstGeom prst="straightConnector1">
+            <a:avLst/>
+          </a:prstGeom>
+          <a:ln w="38100">
+            <a:solidFill>
+              <a:srgbClr val="8C308C"/>
+            </a:solidFill>
+            <a:tailEnd type="triangle"/>
+          </a:ln>
+        </p:spPr>
+        <p:style>
+          <a:lnRef idx="1">
+            <a:schemeClr val="accent1"/>
+          </a:lnRef>
+          <a:fillRef idx="0">
+            <a:schemeClr val="accent1"/>
+          </a:fillRef>
+          <a:effectRef idx="0">
+            <a:schemeClr val="accent1"/>
+          </a:effectRef>
+          <a:fontRef idx="minor">
+            <a:schemeClr val="tx1"/>
+          </a:fontRef>
+        </p:style>
+      </p:cxnSp>
+      <p:cxnSp>
+        <p:nvCxnSpPr>
+          <p:cNvPr id="12" name="Conector recto de flecha 11">
+            <a:extLst>
+              <a:ext uri="{FF2B5EF4-FFF2-40B4-BE49-F238E27FC236}">
+                <a16:creationId xmlns:a16="http://schemas.microsoft.com/office/drawing/2014/main" id="{67D50BAA-D249-DDAA-665D-B5E1EBCB1052}"/>
+              </a:ext>
+            </a:extLst>
+          </p:cNvPr>
+          <p:cNvCxnSpPr>
+            <a:cxnSpLocks/>
+          </p:cNvCxnSpPr>
+          <p:nvPr/>
+        </p:nvCxnSpPr>
+        <p:spPr>
+          <a:xfrm flipH="1">
+            <a:off x="6045200" y="4015096"/>
+            <a:ext cx="117290" cy="363229"/>
+          </a:xfrm>
+          <a:prstGeom prst="straightConnector1">
+            <a:avLst/>
+          </a:prstGeom>
+          <a:ln w="38100">
+            <a:solidFill>
+              <a:srgbClr val="8C308C"/>
+            </a:solidFill>
+            <a:tailEnd type="triangle"/>
+          </a:ln>
+        </p:spPr>
+        <p:style>
+          <a:lnRef idx="1">
+            <a:schemeClr val="accent1"/>
+          </a:lnRef>
+          <a:fillRef idx="0">
+            <a:schemeClr val="accent1"/>
+          </a:fillRef>
+          <a:effectRef idx="0">
+            <a:schemeClr val="accent1"/>
+          </a:effectRef>
+          <a:fontRef idx="minor">
+            <a:schemeClr val="tx1"/>
+          </a:fontRef>
+        </p:style>
+      </p:cxnSp>
+      <p:cxnSp>
+        <p:nvCxnSpPr>
+          <p:cNvPr id="15" name="Conector recto de flecha 14">
+            <a:extLst>
+              <a:ext uri="{FF2B5EF4-FFF2-40B4-BE49-F238E27FC236}">
+                <a16:creationId xmlns:a16="http://schemas.microsoft.com/office/drawing/2014/main" id="{A788B5FD-8371-B90F-59FA-5CCDBE0839E5}"/>
+              </a:ext>
+            </a:extLst>
+          </p:cNvPr>
+          <p:cNvCxnSpPr>
+            <a:cxnSpLocks/>
+          </p:cNvCxnSpPr>
+          <p:nvPr/>
+        </p:nvCxnSpPr>
+        <p:spPr>
+          <a:xfrm flipH="1">
+            <a:off x="5499100" y="4864889"/>
+            <a:ext cx="171827" cy="450061"/>
+          </a:xfrm>
+          <a:prstGeom prst="straightConnector1">
+            <a:avLst/>
+          </a:prstGeom>
+          <a:ln w="38100">
+            <a:solidFill>
+              <a:srgbClr val="8C308C"/>
+            </a:solidFill>
+            <a:tailEnd type="triangle"/>
+          </a:ln>
+        </p:spPr>
+        <p:style>
+          <a:lnRef idx="1">
+            <a:schemeClr val="accent1"/>
+          </a:lnRef>
+          <a:fillRef idx="0">
+            <a:schemeClr val="accent1"/>
+          </a:fillRef>
+          <a:effectRef idx="0">
+            <a:schemeClr val="accent1"/>
+          </a:effectRef>
+          <a:fontRef idx="minor">
+            <a:schemeClr val="tx1"/>
+          </a:fontRef>
+        </p:style>
+      </p:cxnSp>
+      <p:cxnSp>
+        <p:nvCxnSpPr>
+          <p:cNvPr id="17" name="Conector recto de flecha 16">
+            <a:extLst>
+              <a:ext uri="{FF2B5EF4-FFF2-40B4-BE49-F238E27FC236}">
+                <a16:creationId xmlns:a16="http://schemas.microsoft.com/office/drawing/2014/main" id="{8F43E409-93ED-8176-90B5-50F9DC7FBD15}"/>
+              </a:ext>
+            </a:extLst>
+          </p:cNvPr>
+          <p:cNvCxnSpPr>
+            <a:cxnSpLocks/>
+          </p:cNvCxnSpPr>
+          <p:nvPr/>
+        </p:nvCxnSpPr>
+        <p:spPr>
+          <a:xfrm>
+            <a:off x="6275672" y="4892955"/>
+            <a:ext cx="214028" cy="479145"/>
+          </a:xfrm>
+          <a:prstGeom prst="straightConnector1">
+            <a:avLst/>
+          </a:prstGeom>
+          <a:ln w="38100">
+            <a:solidFill>
+              <a:srgbClr val="8C308C"/>
+            </a:solidFill>
+            <a:tailEnd type="triangle"/>
+          </a:ln>
+        </p:spPr>
+        <p:style>
+          <a:lnRef idx="1">
+            <a:schemeClr val="accent1"/>
+          </a:lnRef>
+          <a:fillRef idx="0">
+            <a:schemeClr val="accent1"/>
+          </a:fillRef>
+          <a:effectRef idx="0">
+            <a:schemeClr val="accent1"/>
+          </a:effectRef>
+          <a:fontRef idx="minor">
+            <a:schemeClr val="tx1"/>
+          </a:fontRef>
+        </p:style>
+      </p:cxnSp>
+      <p:cxnSp>
+        <p:nvCxnSpPr>
+          <p:cNvPr id="19" name="Conector recto de flecha 18">
+            <a:extLst>
+              <a:ext uri="{FF2B5EF4-FFF2-40B4-BE49-F238E27FC236}">
+                <a16:creationId xmlns:a16="http://schemas.microsoft.com/office/drawing/2014/main" id="{E8F6B92C-A7B0-2FE2-2303-78BBFD642AA3}"/>
+              </a:ext>
+            </a:extLst>
+          </p:cNvPr>
+          <p:cNvCxnSpPr>
+            <a:cxnSpLocks/>
+          </p:cNvCxnSpPr>
+          <p:nvPr/>
+        </p:nvCxnSpPr>
+        <p:spPr>
+          <a:xfrm flipH="1">
+            <a:off x="4425950" y="2811780"/>
+            <a:ext cx="287021" cy="560070"/>
+          </a:xfrm>
+          <a:prstGeom prst="straightConnector1">
+            <a:avLst/>
+          </a:prstGeom>
+          <a:ln w="38100">
+            <a:solidFill>
+              <a:srgbClr val="8C308C"/>
+            </a:solidFill>
+            <a:tailEnd type="triangle"/>
+          </a:ln>
+        </p:spPr>
+        <p:style>
+          <a:lnRef idx="1">
+            <a:schemeClr val="accent1"/>
+          </a:lnRef>
+          <a:fillRef idx="0">
+            <a:schemeClr val="accent1"/>
+          </a:fillRef>
+          <a:effectRef idx="0">
+            <a:schemeClr val="accent1"/>
+          </a:effectRef>
+          <a:fontRef idx="minor">
+            <a:schemeClr val="tx1"/>
+          </a:fontRef>
+        </p:style>
+      </p:cxnSp>
+      <p:cxnSp>
+        <p:nvCxnSpPr>
+          <p:cNvPr id="21" name="Conector recto de flecha 20">
+            <a:extLst>
+              <a:ext uri="{FF2B5EF4-FFF2-40B4-BE49-F238E27FC236}">
+                <a16:creationId xmlns:a16="http://schemas.microsoft.com/office/drawing/2014/main" id="{CA7C94DD-AF9A-8E05-1D5E-99884ED59211}"/>
+              </a:ext>
+            </a:extLst>
+          </p:cNvPr>
+          <p:cNvCxnSpPr>
+            <a:cxnSpLocks/>
+          </p:cNvCxnSpPr>
+          <p:nvPr/>
+        </p:nvCxnSpPr>
+        <p:spPr>
+          <a:xfrm flipH="1">
+            <a:off x="6267083" y="5852314"/>
+            <a:ext cx="171827" cy="450061"/>
+          </a:xfrm>
+          <a:prstGeom prst="straightConnector1">
+            <a:avLst/>
+          </a:prstGeom>
+          <a:ln w="38100">
+            <a:solidFill>
+              <a:srgbClr val="8C308C"/>
+            </a:solidFill>
+            <a:tailEnd type="triangle"/>
+          </a:ln>
+        </p:spPr>
+        <p:style>
+          <a:lnRef idx="1">
+            <a:schemeClr val="accent1"/>
+          </a:lnRef>
+          <a:fillRef idx="0">
+            <a:schemeClr val="accent1"/>
+          </a:fillRef>
+          <a:effectRef idx="0">
+            <a:schemeClr val="accent1"/>
+          </a:effectRef>
+          <a:fontRef idx="minor">
+            <a:schemeClr val="tx1"/>
+          </a:fontRef>
+        </p:style>
+      </p:cxnSp>
+      <p:cxnSp>
+        <p:nvCxnSpPr>
+          <p:cNvPr id="22" name="Conector recto de flecha 21">
+            <a:extLst>
+              <a:ext uri="{FF2B5EF4-FFF2-40B4-BE49-F238E27FC236}">
+                <a16:creationId xmlns:a16="http://schemas.microsoft.com/office/drawing/2014/main" id="{5E1D05D7-E521-7E86-0D2B-5FE633F646B0}"/>
+              </a:ext>
+            </a:extLst>
+          </p:cNvPr>
+          <p:cNvCxnSpPr>
+            <a:cxnSpLocks/>
+          </p:cNvCxnSpPr>
+          <p:nvPr/>
+        </p:nvCxnSpPr>
+        <p:spPr>
+          <a:xfrm>
+            <a:off x="6818690" y="5841725"/>
+            <a:ext cx="286960" cy="450062"/>
+          </a:xfrm>
+          <a:prstGeom prst="straightConnector1">
+            <a:avLst/>
+          </a:prstGeom>
+          <a:ln w="38100">
+            <a:solidFill>
+              <a:srgbClr val="8C308C"/>
+            </a:solidFill>
+            <a:tailEnd type="triangle"/>
+          </a:ln>
+        </p:spPr>
+        <p:style>
+          <a:lnRef idx="1">
+            <a:schemeClr val="accent1"/>
+          </a:lnRef>
+          <a:fillRef idx="0">
+            <a:schemeClr val="accent1"/>
+          </a:fillRef>
+          <a:effectRef idx="0">
+            <a:schemeClr val="accent1"/>
+          </a:effectRef>
+          <a:fontRef idx="minor">
+            <a:schemeClr val="tx1"/>
+          </a:fontRef>
+        </p:style>
+      </p:cxnSp>
+      <p:sp>
+        <p:nvSpPr>
+          <p:cNvPr id="24" name="CuadroTexto 23">
+            <a:extLst>
+              <a:ext uri="{FF2B5EF4-FFF2-40B4-BE49-F238E27FC236}">
+                <a16:creationId xmlns:a16="http://schemas.microsoft.com/office/drawing/2014/main" id="{C41EC24C-E427-29F5-20DE-AFAF20671589}"/>
+              </a:ext>
+            </a:extLst>
+          </p:cNvPr>
+          <p:cNvSpPr txBox="1"/>
+          <p:nvPr/>
+        </p:nvSpPr>
+        <p:spPr>
+          <a:xfrm>
+            <a:off x="6001871" y="6291787"/>
+            <a:ext cx="622767" cy="307777"/>
+          </a:xfrm>
+          <a:prstGeom prst="rect">
+            <a:avLst/>
+          </a:prstGeom>
+          <a:noFill/>
+        </p:spPr>
+        <p:txBody>
+          <a:bodyPr wrap="square" rtlCol="0">
+            <a:spAutoFit/>
+          </a:bodyPr>
+          <a:lstStyle/>
+          <a:p>
+            <a:r>
+              <a:rPr lang="en-US" sz="1400" i="1" dirty="0">
                 <a:solidFill>
                   <a:schemeClr val="bg2">
                     <a:lumMod val="50000"/>
                   </a:schemeClr>
                 </a:solidFill>
               </a:rPr>
-              <a:t>(</a:t>
-            </a:r>
-            <a:r>
-              <a:rPr lang="es-AR" i="1" dirty="0" err="1">
+              <a:t>Etc.</a:t>
+            </a:r>
+          </a:p>
+        </p:txBody>
+      </p:sp>
+      <p:sp>
+        <p:nvSpPr>
+          <p:cNvPr id="25" name="CuadroTexto 24">
+            <a:extLst>
+              <a:ext uri="{FF2B5EF4-FFF2-40B4-BE49-F238E27FC236}">
+                <a16:creationId xmlns:a16="http://schemas.microsoft.com/office/drawing/2014/main" id="{160D2AED-48D3-9E53-C8AD-A6912AC7373A}"/>
+              </a:ext>
+            </a:extLst>
+          </p:cNvPr>
+          <p:cNvSpPr txBox="1"/>
+          <p:nvPr/>
+        </p:nvSpPr>
+        <p:spPr>
+          <a:xfrm>
+            <a:off x="7032993" y="6291787"/>
+            <a:ext cx="622767" cy="307777"/>
+          </a:xfrm>
+          <a:prstGeom prst="rect">
+            <a:avLst/>
+          </a:prstGeom>
+          <a:noFill/>
+        </p:spPr>
+        <p:txBody>
+          <a:bodyPr wrap="square" rtlCol="0">
+            <a:spAutoFit/>
+          </a:bodyPr>
+          <a:lstStyle/>
+          <a:p>
+            <a:r>
+              <a:rPr lang="en-US" sz="1400" i="1" dirty="0">
                 <a:solidFill>
                   <a:schemeClr val="bg2">
                     <a:lumMod val="50000"/>
                   </a:schemeClr>
                 </a:solidFill>
               </a:rPr>
-              <a:t>loop</a:t>
-            </a:r>
-            <a:r>
-              <a:rPr lang="es-AR" i="1" dirty="0">
-                <a:solidFill>
-                  <a:schemeClr val="bg2">
-                    <a:lumMod val="50000"/>
-                  </a:schemeClr>
-                </a:solidFill>
-              </a:rPr>
-              <a:t>)</a:t>
-            </a:r>
-            <a:endParaRPr lang="en-US" dirty="0"/>
-          </a:p>
-        </p:txBody>
-      </p:sp>
-      <p:sp>
-        <p:nvSpPr>
-          <p:cNvPr id="3" name="Marcador de contenido 2">
-            <a:extLst>
-              <a:ext uri="{FF2B5EF4-FFF2-40B4-BE49-F238E27FC236}">
-                <a16:creationId xmlns:a16="http://schemas.microsoft.com/office/drawing/2014/main" id="{537D51C3-5EF3-749B-27FD-8C8A89953D12}"/>
-              </a:ext>
-            </a:extLst>
-          </p:cNvPr>
-          <p:cNvSpPr>
-            <a:spLocks noGrp="1"/>
-          </p:cNvSpPr>
-          <p:nvPr>
-            <p:ph idx="1"/>
-          </p:nvPr>
-        </p:nvSpPr>
-        <p:spPr/>
-        <p:txBody>
-          <a:bodyPr/>
-          <a:lstStyle/>
-          <a:p>
-            <a:endParaRPr lang="en-US"/>
+              <a:t>Etc.</a:t>
+            </a:r>
           </a:p>
         </p:txBody>
       </p:sp>
     </p:spTree>
     <p:extLst>
       <p:ext uri="{BB962C8B-B14F-4D97-AF65-F5344CB8AC3E}">
-        <p14:creationId xmlns:p14="http://schemas.microsoft.com/office/powerpoint/2010/main" val="1858723434"/>
+        <p14:creationId xmlns:p14="http://schemas.microsoft.com/office/powerpoint/2010/main" val="2395973969"/>
       </p:ext>
     </p:extLst>
   </p:cSld>

</xml_diff>

<commit_message>
Adds two "for" examples :3
</commit_message>
<xml_diff>
--- a/Python/CONTROL FLOW STRUCTURES (lessons #7 - )/Lesson +#7 - Making decisions (CFGs).pptx
+++ b/Python/CONTROL FLOW STRUCTURES (lessons #7 - )/Lesson +#7 - Making decisions (CFGs).pptx
@@ -17,6 +17,7 @@
     <p:sldId id="266" r:id="rId11"/>
     <p:sldId id="260" r:id="rId12"/>
     <p:sldId id="261" r:id="rId13"/>
+    <p:sldId id="270" r:id="rId14"/>
   </p:sldIdLst>
   <p:sldSz cx="12192000" cy="6858000"/>
   <p:notesSz cx="6858000" cy="9144000"/>
@@ -3645,6 +3646,42 @@
           <a:chExt cx="0" cy="0"/>
         </a:xfrm>
       </p:grpSpPr>
+      <p:pic>
+        <p:nvPicPr>
+          <p:cNvPr id="19" name="Imagen 18">
+            <a:extLst>
+              <a:ext uri="{FF2B5EF4-FFF2-40B4-BE49-F238E27FC236}">
+                <a16:creationId xmlns:a16="http://schemas.microsoft.com/office/drawing/2014/main" id="{C21463CE-2ECC-823B-7A96-782688CD48EE}"/>
+              </a:ext>
+            </a:extLst>
+          </p:cNvPr>
+          <p:cNvPicPr>
+            <a:picLocks noChangeAspect="1"/>
+          </p:cNvPicPr>
+          <p:nvPr/>
+        </p:nvPicPr>
+        <p:blipFill>
+          <a:blip r:embed="rId2">
+            <a:extLst>
+              <a:ext uri="{28A0092B-C50C-407E-A947-70E740481C1C}">
+                <a14:useLocalDpi xmlns:a14="http://schemas.microsoft.com/office/drawing/2010/main" val="0"/>
+              </a:ext>
+            </a:extLst>
+          </a:blip>
+          <a:stretch>
+            <a:fillRect/>
+          </a:stretch>
+        </p:blipFill>
+        <p:spPr>
+          <a:xfrm>
+            <a:off x="10468761" y="1771531"/>
+            <a:ext cx="1177254" cy="3632596"/>
+          </a:xfrm>
+          <a:prstGeom prst="rect">
+            <a:avLst/>
+          </a:prstGeom>
+        </p:spPr>
+      </p:pic>
       <p:sp>
         <p:nvSpPr>
           <p:cNvPr id="2" name="Título 1">
@@ -3661,7 +3698,12 @@
             <p:ph type="title"/>
           </p:nvPr>
         </p:nvSpPr>
-        <p:spPr/>
+        <p:spPr>
+          <a:xfrm>
+            <a:off x="129863" y="365125"/>
+            <a:ext cx="10515600" cy="1325563"/>
+          </a:xfrm>
+        </p:spPr>
         <p:txBody>
           <a:bodyPr/>
           <a:lstStyle/>
@@ -3712,10 +3754,10 @@
       </p:sp>
       <p:sp>
         <p:nvSpPr>
-          <p:cNvPr id="4" name="Forma libre: forma 3">
-            <a:extLst>
-              <a:ext uri="{FF2B5EF4-FFF2-40B4-BE49-F238E27FC236}">
-                <a16:creationId xmlns:a16="http://schemas.microsoft.com/office/drawing/2014/main" id="{89AFC35C-0164-5A16-A2B1-84D916E242D9}"/>
+          <p:cNvPr id="3" name="Elipse 2">
+            <a:extLst>
+              <a:ext uri="{FF2B5EF4-FFF2-40B4-BE49-F238E27FC236}">
+                <a16:creationId xmlns:a16="http://schemas.microsoft.com/office/drawing/2014/main" id="{2CB7D4F2-4E66-01F3-BFC8-F9BE215440BD}"/>
               </a:ext>
             </a:extLst>
           </p:cNvPr>
@@ -3724,8 +3766,830 @@
         </p:nvSpPr>
         <p:spPr>
           <a:xfrm>
-            <a:off x="838200" y="2756079"/>
-            <a:ext cx="1177254" cy="2786130"/>
+            <a:off x="7661457" y="991441"/>
+            <a:ext cx="2743200" cy="958383"/>
+          </a:xfrm>
+          <a:prstGeom prst="ellipse">
+            <a:avLst/>
+          </a:prstGeom>
+          <a:solidFill>
+            <a:srgbClr val="CAD7EE"/>
+          </a:solidFill>
+          <a:ln w="38100"/>
+        </p:spPr>
+        <p:style>
+          <a:lnRef idx="2">
+            <a:schemeClr val="accent1">
+              <a:shade val="15000"/>
+            </a:schemeClr>
+          </a:lnRef>
+          <a:fillRef idx="1">
+            <a:schemeClr val="accent1"/>
+          </a:fillRef>
+          <a:effectRef idx="0">
+            <a:schemeClr val="accent1"/>
+          </a:effectRef>
+          <a:fontRef idx="minor">
+            <a:schemeClr val="lt1"/>
+          </a:fontRef>
+        </p:style>
+        <p:txBody>
+          <a:bodyPr rtlCol="0" anchor="ctr"/>
+          <a:lstStyle/>
+          <a:p>
+            <a:pPr algn="ctr"/>
+            <a:endParaRPr lang="en-US"/>
+          </a:p>
+        </p:txBody>
+      </p:sp>
+      <p:sp>
+        <p:nvSpPr>
+          <p:cNvPr id="5" name="CuadroTexto 4">
+            <a:extLst>
+              <a:ext uri="{FF2B5EF4-FFF2-40B4-BE49-F238E27FC236}">
+                <a16:creationId xmlns:a16="http://schemas.microsoft.com/office/drawing/2014/main" id="{B116FCBB-538F-8DE6-B01C-A838AF459EA0}"/>
+              </a:ext>
+            </a:extLst>
+          </p:cNvPr>
+          <p:cNvSpPr txBox="1"/>
+          <p:nvPr/>
+        </p:nvSpPr>
+        <p:spPr>
+          <a:xfrm>
+            <a:off x="7896781" y="1285966"/>
+            <a:ext cx="2541494" cy="369332"/>
+          </a:xfrm>
+          <a:prstGeom prst="rect">
+            <a:avLst/>
+          </a:prstGeom>
+          <a:noFill/>
+        </p:spPr>
+        <p:txBody>
+          <a:bodyPr wrap="square" rtlCol="0">
+            <a:spAutoFit/>
+          </a:bodyPr>
+          <a:lstStyle/>
+          <a:p>
+            <a:r>
+              <a:rPr lang="en-US" dirty="0" err="1"/>
+              <a:t>kettle_temperature</a:t>
+            </a:r>
+            <a:r>
+              <a:rPr lang="en-US" dirty="0"/>
+              <a:t> = 20</a:t>
+            </a:r>
+          </a:p>
+        </p:txBody>
+      </p:sp>
+      <p:sp>
+        <p:nvSpPr>
+          <p:cNvPr id="6" name="CuadroTexto 5">
+            <a:extLst>
+              <a:ext uri="{FF2B5EF4-FFF2-40B4-BE49-F238E27FC236}">
+                <a16:creationId xmlns:a16="http://schemas.microsoft.com/office/drawing/2014/main" id="{727A149B-8F39-91A3-4658-71157F1B301B}"/>
+              </a:ext>
+            </a:extLst>
+          </p:cNvPr>
+          <p:cNvSpPr txBox="1"/>
+          <p:nvPr/>
+        </p:nvSpPr>
+        <p:spPr>
+          <a:xfrm>
+            <a:off x="7695075" y="5034795"/>
+            <a:ext cx="847164" cy="369332"/>
+          </a:xfrm>
+          <a:prstGeom prst="rect">
+            <a:avLst/>
+          </a:prstGeom>
+          <a:noFill/>
+        </p:spPr>
+        <p:txBody>
+          <a:bodyPr wrap="square" rtlCol="0">
+            <a:spAutoFit/>
+          </a:bodyPr>
+          <a:lstStyle/>
+          <a:p>
+            <a:r>
+              <a:rPr lang="en-US" dirty="0"/>
+              <a:t>Ln 6</a:t>
+            </a:r>
+          </a:p>
+        </p:txBody>
+      </p:sp>
+      <p:sp>
+        <p:nvSpPr>
+          <p:cNvPr id="8" name="Elipse 7">
+            <a:extLst>
+              <a:ext uri="{FF2B5EF4-FFF2-40B4-BE49-F238E27FC236}">
+                <a16:creationId xmlns:a16="http://schemas.microsoft.com/office/drawing/2014/main" id="{801AEFAF-9B02-65FD-F0C5-D0F38EF5323A}"/>
+              </a:ext>
+            </a:extLst>
+          </p:cNvPr>
+          <p:cNvSpPr/>
+          <p:nvPr/>
+        </p:nvSpPr>
+        <p:spPr>
+          <a:xfrm>
+            <a:off x="7695075" y="5256864"/>
+            <a:ext cx="2743200" cy="958383"/>
+          </a:xfrm>
+          <a:prstGeom prst="ellipse">
+            <a:avLst/>
+          </a:prstGeom>
+          <a:solidFill>
+            <a:srgbClr val="CAD7EE"/>
+          </a:solidFill>
+          <a:ln w="38100"/>
+        </p:spPr>
+        <p:style>
+          <a:lnRef idx="2">
+            <a:schemeClr val="accent1">
+              <a:shade val="15000"/>
+            </a:schemeClr>
+          </a:lnRef>
+          <a:fillRef idx="1">
+            <a:schemeClr val="accent1"/>
+          </a:fillRef>
+          <a:effectRef idx="0">
+            <a:schemeClr val="accent1"/>
+          </a:effectRef>
+          <a:fontRef idx="minor">
+            <a:schemeClr val="lt1"/>
+          </a:fontRef>
+        </p:style>
+        <p:txBody>
+          <a:bodyPr rtlCol="0" anchor="ctr"/>
+          <a:lstStyle/>
+          <a:p>
+            <a:pPr algn="ctr"/>
+            <a:endParaRPr lang="en-US"/>
+          </a:p>
+        </p:txBody>
+      </p:sp>
+      <p:sp>
+        <p:nvSpPr>
+          <p:cNvPr id="9" name="CuadroTexto 8">
+            <a:extLst>
+              <a:ext uri="{FF2B5EF4-FFF2-40B4-BE49-F238E27FC236}">
+                <a16:creationId xmlns:a16="http://schemas.microsoft.com/office/drawing/2014/main" id="{083836FA-90FE-BF93-1E0B-E57B0C09EF0C}"/>
+              </a:ext>
+            </a:extLst>
+          </p:cNvPr>
+          <p:cNvSpPr txBox="1"/>
+          <p:nvPr/>
+        </p:nvSpPr>
+        <p:spPr>
+          <a:xfrm>
+            <a:off x="7793088" y="5551389"/>
+            <a:ext cx="2743200" cy="369332"/>
+          </a:xfrm>
+          <a:prstGeom prst="rect">
+            <a:avLst/>
+          </a:prstGeom>
+          <a:noFill/>
+        </p:spPr>
+        <p:txBody>
+          <a:bodyPr wrap="square" rtlCol="0">
+            <a:spAutoFit/>
+          </a:bodyPr>
+          <a:lstStyle/>
+          <a:p>
+            <a:r>
+              <a:rPr lang="en-US" dirty="0"/>
+              <a:t>print(</a:t>
+            </a:r>
+            <a:r>
+              <a:rPr lang="en-US" dirty="0" err="1"/>
+              <a:t>kettle_temperature</a:t>
+            </a:r>
+            <a:r>
+              <a:rPr lang="en-US" dirty="0"/>
+              <a:t>)</a:t>
+            </a:r>
+          </a:p>
+        </p:txBody>
+      </p:sp>
+      <p:sp>
+        <p:nvSpPr>
+          <p:cNvPr id="10" name="CuadroTexto 9">
+            <a:extLst>
+              <a:ext uri="{FF2B5EF4-FFF2-40B4-BE49-F238E27FC236}">
+                <a16:creationId xmlns:a16="http://schemas.microsoft.com/office/drawing/2014/main" id="{998573A2-FFCB-389C-E7DF-612C8F651851}"/>
+              </a:ext>
+            </a:extLst>
+          </p:cNvPr>
+          <p:cNvSpPr txBox="1"/>
+          <p:nvPr/>
+        </p:nvSpPr>
+        <p:spPr>
+          <a:xfrm>
+            <a:off x="7896781" y="695741"/>
+            <a:ext cx="847164" cy="369332"/>
+          </a:xfrm>
+          <a:prstGeom prst="rect">
+            <a:avLst/>
+          </a:prstGeom>
+          <a:noFill/>
+        </p:spPr>
+        <p:txBody>
+          <a:bodyPr wrap="square" rtlCol="0">
+            <a:spAutoFit/>
+          </a:bodyPr>
+          <a:lstStyle/>
+          <a:p>
+            <a:r>
+              <a:rPr lang="en-US" dirty="0"/>
+              <a:t>Ln 1</a:t>
+            </a:r>
+          </a:p>
+        </p:txBody>
+      </p:sp>
+      <p:grpSp>
+        <p:nvGrpSpPr>
+          <p:cNvPr id="16" name="Grupo 15">
+            <a:extLst>
+              <a:ext uri="{FF2B5EF4-FFF2-40B4-BE49-F238E27FC236}">
+                <a16:creationId xmlns:a16="http://schemas.microsoft.com/office/drawing/2014/main" id="{4637E389-9877-9299-CFE1-F60ADCAA8740}"/>
+              </a:ext>
+            </a:extLst>
+          </p:cNvPr>
+          <p:cNvGrpSpPr/>
+          <p:nvPr/>
+        </p:nvGrpSpPr>
+        <p:grpSpPr>
+          <a:xfrm rot="1017173">
+            <a:off x="5372715" y="939616"/>
+            <a:ext cx="2337358" cy="2087943"/>
+            <a:chOff x="4312494" y="1392221"/>
+            <a:chExt cx="2564824" cy="2291137"/>
+          </a:xfrm>
+        </p:grpSpPr>
+        <p:sp>
+          <p:nvSpPr>
+            <p:cNvPr id="11" name="Forma libre: forma 10">
+              <a:extLst>
+                <a:ext uri="{FF2B5EF4-FFF2-40B4-BE49-F238E27FC236}">
+                  <a16:creationId xmlns:a16="http://schemas.microsoft.com/office/drawing/2014/main" id="{93EFBE91-D05C-C766-B686-79B2C6386D37}"/>
+                </a:ext>
+              </a:extLst>
+            </p:cNvPr>
+            <p:cNvSpPr/>
+            <p:nvPr/>
+          </p:nvSpPr>
+          <p:spPr>
+            <a:xfrm>
+              <a:off x="4312494" y="1532583"/>
+              <a:ext cx="2564824" cy="2150775"/>
+            </a:xfrm>
+            <a:custGeom>
+              <a:avLst/>
+              <a:gdLst>
+                <a:gd name="connsiteX0" fmla="*/ 2564824 w 2564824"/>
+                <a:gd name="connsiteY0" fmla="*/ 631068 h 2150775"/>
+                <a:gd name="connsiteX1" fmla="*/ 2126943 w 2564824"/>
+                <a:gd name="connsiteY1" fmla="*/ 1661378 h 2150775"/>
+                <a:gd name="connsiteX2" fmla="*/ 1882244 w 2564824"/>
+                <a:gd name="connsiteY2" fmla="*/ 1841682 h 2150775"/>
+                <a:gd name="connsiteX3" fmla="*/ 1624667 w 2564824"/>
+                <a:gd name="connsiteY3" fmla="*/ 1957592 h 2150775"/>
+                <a:gd name="connsiteX4" fmla="*/ 787540 w 2564824"/>
+                <a:gd name="connsiteY4" fmla="*/ 2150775 h 2150775"/>
+                <a:gd name="connsiteX5" fmla="*/ 607236 w 2564824"/>
+                <a:gd name="connsiteY5" fmla="*/ 2137896 h 2150775"/>
+                <a:gd name="connsiteX6" fmla="*/ 414052 w 2564824"/>
+                <a:gd name="connsiteY6" fmla="*/ 2021986 h 2150775"/>
+                <a:gd name="connsiteX7" fmla="*/ 27686 w 2564824"/>
+                <a:gd name="connsiteY7" fmla="*/ 1390921 h 2150775"/>
+                <a:gd name="connsiteX8" fmla="*/ 53444 w 2564824"/>
+                <a:gd name="connsiteY8" fmla="*/ 901524 h 2150775"/>
+                <a:gd name="connsiteX9" fmla="*/ 594357 w 2564824"/>
+                <a:gd name="connsiteY9" fmla="*/ 437885 h 2150775"/>
+                <a:gd name="connsiteX10" fmla="*/ 736024 w 2564824"/>
+                <a:gd name="connsiteY10" fmla="*/ 347732 h 2150775"/>
+                <a:gd name="connsiteX11" fmla="*/ 877692 w 2564824"/>
+                <a:gd name="connsiteY11" fmla="*/ 270459 h 2150775"/>
+                <a:gd name="connsiteX12" fmla="*/ 1238300 w 2564824"/>
+                <a:gd name="connsiteY12" fmla="*/ 128792 h 2150775"/>
+                <a:gd name="connsiteX13" fmla="*/ 1367089 w 2564824"/>
+                <a:gd name="connsiteY13" fmla="*/ 25761 h 2150775"/>
+                <a:gd name="connsiteX14" fmla="*/ 1444362 w 2564824"/>
+                <a:gd name="connsiteY14" fmla="*/ 12882 h 2150775"/>
+                <a:gd name="connsiteX15" fmla="*/ 1663303 w 2564824"/>
+                <a:gd name="connsiteY15" fmla="*/ 3 h 2150775"/>
+              </a:gdLst>
+              <a:ahLst/>
+              <a:cxnLst>
+                <a:cxn ang="0">
+                  <a:pos x="connsiteX0" y="connsiteY0"/>
+                </a:cxn>
+                <a:cxn ang="0">
+                  <a:pos x="connsiteX1" y="connsiteY1"/>
+                </a:cxn>
+                <a:cxn ang="0">
+                  <a:pos x="connsiteX2" y="connsiteY2"/>
+                </a:cxn>
+                <a:cxn ang="0">
+                  <a:pos x="connsiteX3" y="connsiteY3"/>
+                </a:cxn>
+                <a:cxn ang="0">
+                  <a:pos x="connsiteX4" y="connsiteY4"/>
+                </a:cxn>
+                <a:cxn ang="0">
+                  <a:pos x="connsiteX5" y="connsiteY5"/>
+                </a:cxn>
+                <a:cxn ang="0">
+                  <a:pos x="connsiteX6" y="connsiteY6"/>
+                </a:cxn>
+                <a:cxn ang="0">
+                  <a:pos x="connsiteX7" y="connsiteY7"/>
+                </a:cxn>
+                <a:cxn ang="0">
+                  <a:pos x="connsiteX8" y="connsiteY8"/>
+                </a:cxn>
+                <a:cxn ang="0">
+                  <a:pos x="connsiteX9" y="connsiteY9"/>
+                </a:cxn>
+                <a:cxn ang="0">
+                  <a:pos x="connsiteX10" y="connsiteY10"/>
+                </a:cxn>
+                <a:cxn ang="0">
+                  <a:pos x="connsiteX11" y="connsiteY11"/>
+                </a:cxn>
+                <a:cxn ang="0">
+                  <a:pos x="connsiteX12" y="connsiteY12"/>
+                </a:cxn>
+                <a:cxn ang="0">
+                  <a:pos x="connsiteX13" y="connsiteY13"/>
+                </a:cxn>
+                <a:cxn ang="0">
+                  <a:pos x="connsiteX14" y="connsiteY14"/>
+                </a:cxn>
+                <a:cxn ang="0">
+                  <a:pos x="connsiteX15" y="connsiteY15"/>
+                </a:cxn>
+              </a:cxnLst>
+              <a:rect l="l" t="t" r="r" b="b"/>
+              <a:pathLst>
+                <a:path w="2564824" h="2150775">
+                  <a:moveTo>
+                    <a:pt x="2564824" y="631068"/>
+                  </a:moveTo>
+                  <a:cubicBezTo>
+                    <a:pt x="2417431" y="1114191"/>
+                    <a:pt x="2443202" y="1345119"/>
+                    <a:pt x="2126943" y="1661378"/>
+                  </a:cubicBezTo>
+                  <a:cubicBezTo>
+                    <a:pt x="2055301" y="1733020"/>
+                    <a:pt x="1969515" y="1790214"/>
+                    <a:pt x="1882244" y="1841682"/>
+                  </a:cubicBezTo>
+                  <a:cubicBezTo>
+                    <a:pt x="1801145" y="1889510"/>
+                    <a:pt x="1715276" y="1932008"/>
+                    <a:pt x="1624667" y="1957592"/>
+                  </a:cubicBezTo>
+                  <a:cubicBezTo>
+                    <a:pt x="1349066" y="2035409"/>
+                    <a:pt x="787540" y="2150775"/>
+                    <a:pt x="787540" y="2150775"/>
+                  </a:cubicBezTo>
+                  <a:cubicBezTo>
+                    <a:pt x="727439" y="2146482"/>
+                    <a:pt x="664199" y="2157538"/>
+                    <a:pt x="607236" y="2137896"/>
+                  </a:cubicBezTo>
+                  <a:cubicBezTo>
+                    <a:pt x="536242" y="2113415"/>
+                    <a:pt x="466378" y="2075851"/>
+                    <a:pt x="414052" y="2021986"/>
+                  </a:cubicBezTo>
+                  <a:cubicBezTo>
+                    <a:pt x="203552" y="1805295"/>
+                    <a:pt x="150799" y="1648339"/>
+                    <a:pt x="27686" y="1390921"/>
+                  </a:cubicBezTo>
+                  <a:cubicBezTo>
+                    <a:pt x="11956" y="1257210"/>
+                    <a:pt x="-37734" y="1023895"/>
+                    <a:pt x="53444" y="901524"/>
+                  </a:cubicBezTo>
+                  <a:cubicBezTo>
+                    <a:pt x="77699" y="868972"/>
+                    <a:pt x="433922" y="547657"/>
+                    <a:pt x="594357" y="437885"/>
+                  </a:cubicBezTo>
+                  <a:cubicBezTo>
+                    <a:pt x="640552" y="406278"/>
+                    <a:pt x="687835" y="376207"/>
+                    <a:pt x="736024" y="347732"/>
+                  </a:cubicBezTo>
+                  <a:cubicBezTo>
+                    <a:pt x="782334" y="320367"/>
+                    <a:pt x="828382" y="291953"/>
+                    <a:pt x="877692" y="270459"/>
+                  </a:cubicBezTo>
+                  <a:cubicBezTo>
+                    <a:pt x="996079" y="218854"/>
+                    <a:pt x="1238300" y="128792"/>
+                    <a:pt x="1238300" y="128792"/>
+                  </a:cubicBezTo>
+                  <a:cubicBezTo>
+                    <a:pt x="1281230" y="94448"/>
+                    <a:pt x="1319173" y="52714"/>
+                    <a:pt x="1367089" y="25761"/>
+                  </a:cubicBezTo>
+                  <a:cubicBezTo>
+                    <a:pt x="1389848" y="12959"/>
+                    <a:pt x="1418367" y="15358"/>
+                    <a:pt x="1444362" y="12882"/>
+                  </a:cubicBezTo>
+                  <a:cubicBezTo>
+                    <a:pt x="1585587" y="-568"/>
+                    <a:pt x="1581060" y="3"/>
+                    <a:pt x="1663303" y="3"/>
+                  </a:cubicBezTo>
+                </a:path>
+              </a:pathLst>
+            </a:custGeom>
+            <a:noFill/>
+            <a:ln w="57150">
+              <a:solidFill>
+                <a:srgbClr val="791179"/>
+              </a:solidFill>
+            </a:ln>
+          </p:spPr>
+          <p:style>
+            <a:lnRef idx="2">
+              <a:schemeClr val="accent1">
+                <a:shade val="15000"/>
+              </a:schemeClr>
+            </a:lnRef>
+            <a:fillRef idx="1">
+              <a:schemeClr val="accent1"/>
+            </a:fillRef>
+            <a:effectRef idx="0">
+              <a:schemeClr val="accent1"/>
+            </a:effectRef>
+            <a:fontRef idx="minor">
+              <a:schemeClr val="lt1"/>
+            </a:fontRef>
+          </p:style>
+          <p:txBody>
+            <a:bodyPr rtlCol="0" anchor="ctr"/>
+            <a:lstStyle/>
+            <a:p>
+              <a:pPr algn="ctr"/>
+              <a:endParaRPr lang="en-US">
+                <a:solidFill>
+                  <a:srgbClr val="791179"/>
+                </a:solidFill>
+              </a:endParaRPr>
+            </a:p>
+          </p:txBody>
+        </p:sp>
+        <p:sp>
+          <p:nvSpPr>
+            <p:cNvPr id="12" name="Forma libre: forma 11">
+              <a:extLst>
+                <a:ext uri="{FF2B5EF4-FFF2-40B4-BE49-F238E27FC236}">
+                  <a16:creationId xmlns:a16="http://schemas.microsoft.com/office/drawing/2014/main" id="{D6721B3E-B356-995B-F1B4-09A6E562C7C3}"/>
+                </a:ext>
+              </a:extLst>
+            </p:cNvPr>
+            <p:cNvSpPr/>
+            <p:nvPr/>
+          </p:nvSpPr>
+          <p:spPr>
+            <a:xfrm rot="1067707">
+              <a:off x="5579942" y="1392221"/>
+              <a:ext cx="416126" cy="371948"/>
+            </a:xfrm>
+            <a:custGeom>
+              <a:avLst/>
+              <a:gdLst>
+                <a:gd name="connsiteX0" fmla="*/ 0 w 188119"/>
+                <a:gd name="connsiteY0" fmla="*/ 0 h 211932"/>
+                <a:gd name="connsiteX1" fmla="*/ 109537 w 188119"/>
+                <a:gd name="connsiteY1" fmla="*/ 26194 h 211932"/>
+                <a:gd name="connsiteX2" fmla="*/ 133350 w 188119"/>
+                <a:gd name="connsiteY2" fmla="*/ 38100 h 211932"/>
+                <a:gd name="connsiteX3" fmla="*/ 159544 w 188119"/>
+                <a:gd name="connsiteY3" fmla="*/ 50007 h 211932"/>
+                <a:gd name="connsiteX4" fmla="*/ 180975 w 188119"/>
+                <a:gd name="connsiteY4" fmla="*/ 54769 h 211932"/>
+                <a:gd name="connsiteX5" fmla="*/ 188119 w 188119"/>
+                <a:gd name="connsiteY5" fmla="*/ 57150 h 211932"/>
+                <a:gd name="connsiteX6" fmla="*/ 140494 w 188119"/>
+                <a:gd name="connsiteY6" fmla="*/ 121444 h 211932"/>
+                <a:gd name="connsiteX7" fmla="*/ 123825 w 188119"/>
+                <a:gd name="connsiteY7" fmla="*/ 140494 h 211932"/>
+                <a:gd name="connsiteX8" fmla="*/ 102394 w 188119"/>
+                <a:gd name="connsiteY8" fmla="*/ 150019 h 211932"/>
+                <a:gd name="connsiteX9" fmla="*/ 80962 w 188119"/>
+                <a:gd name="connsiteY9" fmla="*/ 173832 h 211932"/>
+                <a:gd name="connsiteX10" fmla="*/ 73819 w 188119"/>
+                <a:gd name="connsiteY10" fmla="*/ 180975 h 211932"/>
+                <a:gd name="connsiteX11" fmla="*/ 69056 w 188119"/>
+                <a:gd name="connsiteY11" fmla="*/ 190500 h 211932"/>
+                <a:gd name="connsiteX12" fmla="*/ 61912 w 188119"/>
+                <a:gd name="connsiteY12" fmla="*/ 202407 h 211932"/>
+                <a:gd name="connsiteX13" fmla="*/ 52387 w 188119"/>
+                <a:gd name="connsiteY13" fmla="*/ 211932 h 211932"/>
+              </a:gdLst>
+              <a:ahLst/>
+              <a:cxnLst>
+                <a:cxn ang="0">
+                  <a:pos x="connsiteX0" y="connsiteY0"/>
+                </a:cxn>
+                <a:cxn ang="0">
+                  <a:pos x="connsiteX1" y="connsiteY1"/>
+                </a:cxn>
+                <a:cxn ang="0">
+                  <a:pos x="connsiteX2" y="connsiteY2"/>
+                </a:cxn>
+                <a:cxn ang="0">
+                  <a:pos x="connsiteX3" y="connsiteY3"/>
+                </a:cxn>
+                <a:cxn ang="0">
+                  <a:pos x="connsiteX4" y="connsiteY4"/>
+                </a:cxn>
+                <a:cxn ang="0">
+                  <a:pos x="connsiteX5" y="connsiteY5"/>
+                </a:cxn>
+                <a:cxn ang="0">
+                  <a:pos x="connsiteX6" y="connsiteY6"/>
+                </a:cxn>
+                <a:cxn ang="0">
+                  <a:pos x="connsiteX7" y="connsiteY7"/>
+                </a:cxn>
+                <a:cxn ang="0">
+                  <a:pos x="connsiteX8" y="connsiteY8"/>
+                </a:cxn>
+                <a:cxn ang="0">
+                  <a:pos x="connsiteX9" y="connsiteY9"/>
+                </a:cxn>
+                <a:cxn ang="0">
+                  <a:pos x="connsiteX10" y="connsiteY10"/>
+                </a:cxn>
+                <a:cxn ang="0">
+                  <a:pos x="connsiteX11" y="connsiteY11"/>
+                </a:cxn>
+                <a:cxn ang="0">
+                  <a:pos x="connsiteX12" y="connsiteY12"/>
+                </a:cxn>
+                <a:cxn ang="0">
+                  <a:pos x="connsiteX13" y="connsiteY13"/>
+                </a:cxn>
+              </a:cxnLst>
+              <a:rect l="l" t="t" r="r" b="b"/>
+              <a:pathLst>
+                <a:path w="188119" h="211932">
+                  <a:moveTo>
+                    <a:pt x="0" y="0"/>
+                  </a:moveTo>
+                  <a:cubicBezTo>
+                    <a:pt x="59974" y="11996"/>
+                    <a:pt x="54255" y="9184"/>
+                    <a:pt x="109537" y="26194"/>
+                  </a:cubicBezTo>
+                  <a:cubicBezTo>
+                    <a:pt x="125437" y="31086"/>
+                    <a:pt x="118108" y="30479"/>
+                    <a:pt x="133350" y="38100"/>
+                  </a:cubicBezTo>
+                  <a:cubicBezTo>
+                    <a:pt x="141929" y="42389"/>
+                    <a:pt x="150639" y="46445"/>
+                    <a:pt x="159544" y="50007"/>
+                  </a:cubicBezTo>
+                  <a:cubicBezTo>
+                    <a:pt x="163616" y="51636"/>
+                    <a:pt x="177459" y="53890"/>
+                    <a:pt x="180975" y="54769"/>
+                  </a:cubicBezTo>
+                  <a:cubicBezTo>
+                    <a:pt x="183410" y="55378"/>
+                    <a:pt x="185738" y="56356"/>
+                    <a:pt x="188119" y="57150"/>
+                  </a:cubicBezTo>
+                  <a:cubicBezTo>
+                    <a:pt x="187294" y="58275"/>
+                    <a:pt x="144649" y="116696"/>
+                    <a:pt x="140494" y="121444"/>
+                  </a:cubicBezTo>
+                  <a:cubicBezTo>
+                    <a:pt x="134938" y="127794"/>
+                    <a:pt x="130575" y="135431"/>
+                    <a:pt x="123825" y="140494"/>
+                  </a:cubicBezTo>
+                  <a:cubicBezTo>
+                    <a:pt x="117571" y="145184"/>
+                    <a:pt x="109538" y="146844"/>
+                    <a:pt x="102394" y="150019"/>
+                  </a:cubicBezTo>
+                  <a:cubicBezTo>
+                    <a:pt x="76108" y="176303"/>
+                    <a:pt x="103760" y="147776"/>
+                    <a:pt x="80962" y="173832"/>
+                  </a:cubicBezTo>
+                  <a:cubicBezTo>
+                    <a:pt x="78745" y="176366"/>
+                    <a:pt x="75776" y="178235"/>
+                    <a:pt x="73819" y="180975"/>
+                  </a:cubicBezTo>
+                  <a:cubicBezTo>
+                    <a:pt x="71756" y="183864"/>
+                    <a:pt x="70780" y="187397"/>
+                    <a:pt x="69056" y="190500"/>
+                  </a:cubicBezTo>
+                  <a:cubicBezTo>
+                    <a:pt x="66808" y="194546"/>
+                    <a:pt x="64689" y="198704"/>
+                    <a:pt x="61912" y="202407"/>
+                  </a:cubicBezTo>
+                  <a:cubicBezTo>
+                    <a:pt x="59218" y="205999"/>
+                    <a:pt x="55562" y="208757"/>
+                    <a:pt x="52387" y="211932"/>
+                  </a:cubicBezTo>
+                </a:path>
+              </a:pathLst>
+            </a:custGeom>
+            <a:noFill/>
+            <a:ln w="57150">
+              <a:solidFill>
+                <a:srgbClr val="8A008A"/>
+              </a:solidFill>
+            </a:ln>
+          </p:spPr>
+          <p:style>
+            <a:lnRef idx="2">
+              <a:schemeClr val="accent1">
+                <a:shade val="15000"/>
+              </a:schemeClr>
+            </a:lnRef>
+            <a:fillRef idx="1">
+              <a:schemeClr val="accent1"/>
+            </a:fillRef>
+            <a:effectRef idx="0">
+              <a:schemeClr val="accent1"/>
+            </a:effectRef>
+            <a:fontRef idx="minor">
+              <a:schemeClr val="lt1"/>
+            </a:fontRef>
+          </p:style>
+          <p:txBody>
+            <a:bodyPr rtlCol="0" anchor="ctr"/>
+            <a:lstStyle/>
+            <a:p>
+              <a:pPr algn="ctr"/>
+              <a:endParaRPr lang="en-US">
+                <a:solidFill>
+                  <a:srgbClr val="791179"/>
+                </a:solidFill>
+              </a:endParaRPr>
+            </a:p>
+          </p:txBody>
+        </p:sp>
+      </p:grpSp>
+      <p:sp>
+        <p:nvSpPr>
+          <p:cNvPr id="13" name="CuadroTexto 12">
+            <a:extLst>
+              <a:ext uri="{FF2B5EF4-FFF2-40B4-BE49-F238E27FC236}">
+                <a16:creationId xmlns:a16="http://schemas.microsoft.com/office/drawing/2014/main" id="{45EC1769-58C5-19F6-ED4E-81D0E2650381}"/>
+              </a:ext>
+            </a:extLst>
+          </p:cNvPr>
+          <p:cNvSpPr txBox="1"/>
+          <p:nvPr/>
+        </p:nvSpPr>
+        <p:spPr>
+          <a:xfrm>
+            <a:off x="6983290" y="2662913"/>
+            <a:ext cx="361682" cy="769441"/>
+          </a:xfrm>
+          <a:prstGeom prst="rect">
+            <a:avLst/>
+          </a:prstGeom>
+          <a:noFill/>
+        </p:spPr>
+        <p:txBody>
+          <a:bodyPr wrap="square" rtlCol="0">
+            <a:spAutoFit/>
+          </a:bodyPr>
+          <a:lstStyle/>
+          <a:p>
+            <a:r>
+              <a:rPr lang="en-US" sz="4400" b="1" dirty="0">
+                <a:solidFill>
+                  <a:srgbClr val="00B050"/>
+                </a:solidFill>
+              </a:rPr>
+              <a:t>T</a:t>
+            </a:r>
+          </a:p>
+        </p:txBody>
+      </p:sp>
+      <p:sp>
+        <p:nvSpPr>
+          <p:cNvPr id="14" name="CuadroTexto 13">
+            <a:extLst>
+              <a:ext uri="{FF2B5EF4-FFF2-40B4-BE49-F238E27FC236}">
+                <a16:creationId xmlns:a16="http://schemas.microsoft.com/office/drawing/2014/main" id="{E6A8207D-903B-F223-FC1C-645B209A93B3}"/>
+              </a:ext>
+            </a:extLst>
+          </p:cNvPr>
+          <p:cNvSpPr txBox="1"/>
+          <p:nvPr/>
+        </p:nvSpPr>
+        <p:spPr>
+          <a:xfrm>
+            <a:off x="10903574" y="2553521"/>
+            <a:ext cx="583841" cy="769441"/>
+          </a:xfrm>
+          <a:prstGeom prst="rect">
+            <a:avLst/>
+          </a:prstGeom>
+          <a:noFill/>
+        </p:spPr>
+        <p:txBody>
+          <a:bodyPr wrap="square" rtlCol="0">
+            <a:spAutoFit/>
+          </a:bodyPr>
+          <a:lstStyle/>
+          <a:p>
+            <a:r>
+              <a:rPr lang="en-US" sz="4400" b="1" dirty="0">
+                <a:solidFill>
+                  <a:srgbClr val="FF0000"/>
+                </a:solidFill>
+              </a:rPr>
+              <a:t>F</a:t>
+            </a:r>
+          </a:p>
+        </p:txBody>
+      </p:sp>
+      <p:sp>
+        <p:nvSpPr>
+          <p:cNvPr id="15" name="CuadroTexto 14">
+            <a:extLst>
+              <a:ext uri="{FF2B5EF4-FFF2-40B4-BE49-F238E27FC236}">
+                <a16:creationId xmlns:a16="http://schemas.microsoft.com/office/drawing/2014/main" id="{4B4F8199-CCFA-42D1-8ED2-649051600151}"/>
+              </a:ext>
+            </a:extLst>
+          </p:cNvPr>
+          <p:cNvSpPr txBox="1"/>
+          <p:nvPr/>
+        </p:nvSpPr>
+        <p:spPr>
+          <a:xfrm>
+            <a:off x="7693154" y="2262593"/>
+            <a:ext cx="2943068" cy="369332"/>
+          </a:xfrm>
+          <a:prstGeom prst="rect">
+            <a:avLst/>
+          </a:prstGeom>
+          <a:noFill/>
+        </p:spPr>
+        <p:txBody>
+          <a:bodyPr wrap="square" rtlCol="0">
+            <a:spAutoFit/>
+          </a:bodyPr>
+          <a:lstStyle/>
+          <a:p>
+            <a:r>
+              <a:rPr lang="en-US" dirty="0"/>
+              <a:t>is </a:t>
+            </a:r>
+            <a:r>
+              <a:rPr lang="en-US" dirty="0" err="1"/>
+              <a:t>kettle_temperature</a:t>
+            </a:r>
+            <a:r>
+              <a:rPr lang="en-US" dirty="0"/>
+              <a:t> &lt; 100?</a:t>
+            </a:r>
+          </a:p>
+        </p:txBody>
+      </p:sp>
+      <p:sp>
+        <p:nvSpPr>
+          <p:cNvPr id="18" name="Forma libre: forma 17">
+            <a:extLst>
+              <a:ext uri="{FF2B5EF4-FFF2-40B4-BE49-F238E27FC236}">
+                <a16:creationId xmlns:a16="http://schemas.microsoft.com/office/drawing/2014/main" id="{177ADE44-6079-298D-9B32-98503FED8A1A}"/>
+              </a:ext>
+            </a:extLst>
+          </p:cNvPr>
+          <p:cNvSpPr/>
+          <p:nvPr/>
+        </p:nvSpPr>
+        <p:spPr>
+          <a:xfrm>
+            <a:off x="319303" y="1826482"/>
+            <a:ext cx="891890" cy="2110778"/>
           </a:xfrm>
           <a:custGeom>
             <a:avLst/>
@@ -3996,12 +4860,42 @@
           </a:p>
         </p:txBody>
       </p:sp>
-      <p:sp>
-        <p:nvSpPr>
-          <p:cNvPr id="3" name="Elipse 2">
-            <a:extLst>
-              <a:ext uri="{FF2B5EF4-FFF2-40B4-BE49-F238E27FC236}">
-                <a16:creationId xmlns:a16="http://schemas.microsoft.com/office/drawing/2014/main" id="{2CB7D4F2-4E66-01F3-BFC8-F9BE215440BD}"/>
+      <p:pic>
+        <p:nvPicPr>
+          <p:cNvPr id="21" name="Imagen 20">
+            <a:extLst>
+              <a:ext uri="{FF2B5EF4-FFF2-40B4-BE49-F238E27FC236}">
+                <a16:creationId xmlns:a16="http://schemas.microsoft.com/office/drawing/2014/main" id="{DD59D213-C35C-8917-D92F-99544163F523}"/>
+              </a:ext>
+            </a:extLst>
+          </p:cNvPr>
+          <p:cNvPicPr>
+            <a:picLocks noChangeAspect="1"/>
+          </p:cNvPicPr>
+          <p:nvPr/>
+        </p:nvPicPr>
+        <p:blipFill>
+          <a:blip r:embed="rId3"/>
+          <a:stretch>
+            <a:fillRect/>
+          </a:stretch>
+        </p:blipFill>
+        <p:spPr>
+          <a:xfrm>
+            <a:off x="-14381" y="5034794"/>
+            <a:ext cx="7407730" cy="1823205"/>
+          </a:xfrm>
+          <a:prstGeom prst="rect">
+            <a:avLst/>
+          </a:prstGeom>
+        </p:spPr>
+      </p:pic>
+      <p:sp>
+        <p:nvSpPr>
+          <p:cNvPr id="25" name="Elipse 24">
+            <a:extLst>
+              <a:ext uri="{FF2B5EF4-FFF2-40B4-BE49-F238E27FC236}">
+                <a16:creationId xmlns:a16="http://schemas.microsoft.com/office/drawing/2014/main" id="{AD573619-E381-56A8-D27D-CFF759978C65}"/>
               </a:ext>
             </a:extLst>
           </p:cNvPr>
@@ -4010,8 +4904,8 @@
         </p:nvSpPr>
         <p:spPr>
           <a:xfrm>
-            <a:off x="6270542" y="991441"/>
-            <a:ext cx="2743200" cy="958383"/>
+            <a:off x="2266682" y="1684359"/>
+            <a:ext cx="4716608" cy="958383"/>
           </a:xfrm>
           <a:prstGeom prst="ellipse">
             <a:avLst/>
@@ -4048,10 +4942,10 @@
       </p:sp>
       <p:sp>
         <p:nvSpPr>
-          <p:cNvPr id="5" name="CuadroTexto 4">
-            <a:extLst>
-              <a:ext uri="{FF2B5EF4-FFF2-40B4-BE49-F238E27FC236}">
-                <a16:creationId xmlns:a16="http://schemas.microsoft.com/office/drawing/2014/main" id="{B116FCBB-538F-8DE6-B01C-A838AF459EA0}"/>
+          <p:cNvPr id="26" name="CuadroTexto 25">
+            <a:extLst>
+              <a:ext uri="{FF2B5EF4-FFF2-40B4-BE49-F238E27FC236}">
+                <a16:creationId xmlns:a16="http://schemas.microsoft.com/office/drawing/2014/main" id="{E97C2030-D306-34E4-BBFE-8B6DB877A003}"/>
               </a:ext>
             </a:extLst>
           </p:cNvPr>
@@ -4060,8 +4954,8 @@
         </p:nvSpPr>
         <p:spPr>
           <a:xfrm>
-            <a:off x="6505866" y="1285966"/>
-            <a:ext cx="2541494" cy="369332"/>
+            <a:off x="2521355" y="1978884"/>
+            <a:ext cx="4523388" cy="369332"/>
           </a:xfrm>
           <a:prstGeom prst="rect">
             <a:avLst/>
@@ -4080,17 +4974,25 @@
             </a:r>
             <a:r>
               <a:rPr lang="en-US" dirty="0"/>
-              <a:t> = 20</a:t>
-            </a:r>
-          </a:p>
-        </p:txBody>
-      </p:sp>
-      <p:sp>
-        <p:nvSpPr>
-          <p:cNvPr id="6" name="CuadroTexto 5">
-            <a:extLst>
-              <a:ext uri="{FF2B5EF4-FFF2-40B4-BE49-F238E27FC236}">
-                <a16:creationId xmlns:a16="http://schemas.microsoft.com/office/drawing/2014/main" id="{727A149B-8F39-91A3-4658-71157F1B301B}"/>
+              <a:t> = </a:t>
+            </a:r>
+            <a:r>
+              <a:rPr lang="en-US" dirty="0" err="1"/>
+              <a:t>kettle_temperature</a:t>
+            </a:r>
+            <a:r>
+              <a:rPr lang="en-US" dirty="0"/>
+              <a:t> + 1</a:t>
+            </a:r>
+          </a:p>
+        </p:txBody>
+      </p:sp>
+      <p:sp>
+        <p:nvSpPr>
+          <p:cNvPr id="27" name="CuadroTexto 26">
+            <a:extLst>
+              <a:ext uri="{FF2B5EF4-FFF2-40B4-BE49-F238E27FC236}">
+                <a16:creationId xmlns:a16="http://schemas.microsoft.com/office/drawing/2014/main" id="{17BA455D-9C6C-EA4D-7F41-348C515612A7}"/>
               </a:ext>
             </a:extLst>
           </p:cNvPr>
@@ -4099,7 +5001,7 @@
         </p:nvSpPr>
         <p:spPr>
           <a:xfrm>
-            <a:off x="6304160" y="5034795"/>
+            <a:off x="2665781" y="1450924"/>
             <a:ext cx="847164" cy="369332"/>
           </a:xfrm>
           <a:prstGeom prst="rect">
@@ -4115,697 +5017,7 @@
           <a:p>
             <a:r>
               <a:rPr lang="en-US" dirty="0"/>
-              <a:t>Ln 5</a:t>
-            </a:r>
-          </a:p>
-        </p:txBody>
-      </p:sp>
-      <p:sp>
-        <p:nvSpPr>
-          <p:cNvPr id="8" name="Elipse 7">
-            <a:extLst>
-              <a:ext uri="{FF2B5EF4-FFF2-40B4-BE49-F238E27FC236}">
-                <a16:creationId xmlns:a16="http://schemas.microsoft.com/office/drawing/2014/main" id="{801AEFAF-9B02-65FD-F0C5-D0F38EF5323A}"/>
-              </a:ext>
-            </a:extLst>
-          </p:cNvPr>
-          <p:cNvSpPr/>
-          <p:nvPr/>
-        </p:nvSpPr>
-        <p:spPr>
-          <a:xfrm>
-            <a:off x="6304160" y="5256864"/>
-            <a:ext cx="2743200" cy="958383"/>
-          </a:xfrm>
-          <a:prstGeom prst="ellipse">
-            <a:avLst/>
-          </a:prstGeom>
-          <a:solidFill>
-            <a:srgbClr val="CAD7EE"/>
-          </a:solidFill>
-          <a:ln w="38100"/>
-        </p:spPr>
-        <p:style>
-          <a:lnRef idx="2">
-            <a:schemeClr val="accent1">
-              <a:shade val="15000"/>
-            </a:schemeClr>
-          </a:lnRef>
-          <a:fillRef idx="1">
-            <a:schemeClr val="accent1"/>
-          </a:fillRef>
-          <a:effectRef idx="0">
-            <a:schemeClr val="accent1"/>
-          </a:effectRef>
-          <a:fontRef idx="minor">
-            <a:schemeClr val="lt1"/>
-          </a:fontRef>
-        </p:style>
-        <p:txBody>
-          <a:bodyPr rtlCol="0" anchor="ctr"/>
-          <a:lstStyle/>
-          <a:p>
-            <a:pPr algn="ctr"/>
-            <a:endParaRPr lang="en-US"/>
-          </a:p>
-        </p:txBody>
-      </p:sp>
-      <p:sp>
-        <p:nvSpPr>
-          <p:cNvPr id="9" name="CuadroTexto 8">
-            <a:extLst>
-              <a:ext uri="{FF2B5EF4-FFF2-40B4-BE49-F238E27FC236}">
-                <a16:creationId xmlns:a16="http://schemas.microsoft.com/office/drawing/2014/main" id="{083836FA-90FE-BF93-1E0B-E57B0C09EF0C}"/>
-              </a:ext>
-            </a:extLst>
-          </p:cNvPr>
-          <p:cNvSpPr txBox="1"/>
-          <p:nvPr/>
-        </p:nvSpPr>
-        <p:spPr>
-          <a:xfrm>
-            <a:off x="6402173" y="5551389"/>
-            <a:ext cx="2743200" cy="369332"/>
-          </a:xfrm>
-          <a:prstGeom prst="rect">
-            <a:avLst/>
-          </a:prstGeom>
-          <a:noFill/>
-        </p:spPr>
-        <p:txBody>
-          <a:bodyPr wrap="square" rtlCol="0">
-            <a:spAutoFit/>
-          </a:bodyPr>
-          <a:lstStyle/>
-          <a:p>
-            <a:r>
-              <a:rPr lang="en-US" dirty="0"/>
-              <a:t>print(</a:t>
-            </a:r>
-            <a:r>
-              <a:rPr lang="en-US" dirty="0" err="1"/>
-              <a:t>kettle_temperature</a:t>
-            </a:r>
-            <a:r>
-              <a:rPr lang="en-US" dirty="0"/>
-              <a:t>)</a:t>
-            </a:r>
-          </a:p>
-        </p:txBody>
-      </p:sp>
-      <p:sp>
-        <p:nvSpPr>
-          <p:cNvPr id="10" name="CuadroTexto 9">
-            <a:extLst>
-              <a:ext uri="{FF2B5EF4-FFF2-40B4-BE49-F238E27FC236}">
-                <a16:creationId xmlns:a16="http://schemas.microsoft.com/office/drawing/2014/main" id="{998573A2-FFCB-389C-E7DF-612C8F651851}"/>
-              </a:ext>
-            </a:extLst>
-          </p:cNvPr>
-          <p:cNvSpPr txBox="1"/>
-          <p:nvPr/>
-        </p:nvSpPr>
-        <p:spPr>
-          <a:xfrm>
-            <a:off x="6505866" y="695741"/>
-            <a:ext cx="847164" cy="369332"/>
-          </a:xfrm>
-          <a:prstGeom prst="rect">
-            <a:avLst/>
-          </a:prstGeom>
-          <a:noFill/>
-        </p:spPr>
-        <p:txBody>
-          <a:bodyPr wrap="square" rtlCol="0">
-            <a:spAutoFit/>
-          </a:bodyPr>
-          <a:lstStyle/>
-          <a:p>
-            <a:r>
-              <a:rPr lang="en-US" dirty="0"/>
-              <a:t>Ln 1</a:t>
-            </a:r>
-          </a:p>
-        </p:txBody>
-      </p:sp>
-      <p:grpSp>
-        <p:nvGrpSpPr>
-          <p:cNvPr id="16" name="Grupo 15">
-            <a:extLst>
-              <a:ext uri="{FF2B5EF4-FFF2-40B4-BE49-F238E27FC236}">
-                <a16:creationId xmlns:a16="http://schemas.microsoft.com/office/drawing/2014/main" id="{4637E389-9877-9299-CFE1-F60ADCAA8740}"/>
-              </a:ext>
-            </a:extLst>
-          </p:cNvPr>
-          <p:cNvGrpSpPr/>
-          <p:nvPr/>
-        </p:nvGrpSpPr>
-        <p:grpSpPr>
-          <a:xfrm rot="1017173">
-            <a:off x="3970303" y="1016763"/>
-            <a:ext cx="2337358" cy="2009082"/>
-            <a:chOff x="4312494" y="1478756"/>
-            <a:chExt cx="2564824" cy="2204602"/>
-          </a:xfrm>
-        </p:grpSpPr>
-        <p:sp>
-          <p:nvSpPr>
-            <p:cNvPr id="11" name="Forma libre: forma 10">
-              <a:extLst>
-                <a:ext uri="{FF2B5EF4-FFF2-40B4-BE49-F238E27FC236}">
-                  <a16:creationId xmlns:a16="http://schemas.microsoft.com/office/drawing/2014/main" id="{93EFBE91-D05C-C766-B686-79B2C6386D37}"/>
-                </a:ext>
-              </a:extLst>
-            </p:cNvPr>
-            <p:cNvSpPr/>
-            <p:nvPr/>
-          </p:nvSpPr>
-          <p:spPr>
-            <a:xfrm>
-              <a:off x="4312494" y="1532583"/>
-              <a:ext cx="2564824" cy="2150775"/>
-            </a:xfrm>
-            <a:custGeom>
-              <a:avLst/>
-              <a:gdLst>
-                <a:gd name="connsiteX0" fmla="*/ 2564824 w 2564824"/>
-                <a:gd name="connsiteY0" fmla="*/ 631068 h 2150775"/>
-                <a:gd name="connsiteX1" fmla="*/ 2126943 w 2564824"/>
-                <a:gd name="connsiteY1" fmla="*/ 1661378 h 2150775"/>
-                <a:gd name="connsiteX2" fmla="*/ 1882244 w 2564824"/>
-                <a:gd name="connsiteY2" fmla="*/ 1841682 h 2150775"/>
-                <a:gd name="connsiteX3" fmla="*/ 1624667 w 2564824"/>
-                <a:gd name="connsiteY3" fmla="*/ 1957592 h 2150775"/>
-                <a:gd name="connsiteX4" fmla="*/ 787540 w 2564824"/>
-                <a:gd name="connsiteY4" fmla="*/ 2150775 h 2150775"/>
-                <a:gd name="connsiteX5" fmla="*/ 607236 w 2564824"/>
-                <a:gd name="connsiteY5" fmla="*/ 2137896 h 2150775"/>
-                <a:gd name="connsiteX6" fmla="*/ 414052 w 2564824"/>
-                <a:gd name="connsiteY6" fmla="*/ 2021986 h 2150775"/>
-                <a:gd name="connsiteX7" fmla="*/ 27686 w 2564824"/>
-                <a:gd name="connsiteY7" fmla="*/ 1390921 h 2150775"/>
-                <a:gd name="connsiteX8" fmla="*/ 53444 w 2564824"/>
-                <a:gd name="connsiteY8" fmla="*/ 901524 h 2150775"/>
-                <a:gd name="connsiteX9" fmla="*/ 594357 w 2564824"/>
-                <a:gd name="connsiteY9" fmla="*/ 437885 h 2150775"/>
-                <a:gd name="connsiteX10" fmla="*/ 736024 w 2564824"/>
-                <a:gd name="connsiteY10" fmla="*/ 347732 h 2150775"/>
-                <a:gd name="connsiteX11" fmla="*/ 877692 w 2564824"/>
-                <a:gd name="connsiteY11" fmla="*/ 270459 h 2150775"/>
-                <a:gd name="connsiteX12" fmla="*/ 1238300 w 2564824"/>
-                <a:gd name="connsiteY12" fmla="*/ 128792 h 2150775"/>
-                <a:gd name="connsiteX13" fmla="*/ 1367089 w 2564824"/>
-                <a:gd name="connsiteY13" fmla="*/ 25761 h 2150775"/>
-                <a:gd name="connsiteX14" fmla="*/ 1444362 w 2564824"/>
-                <a:gd name="connsiteY14" fmla="*/ 12882 h 2150775"/>
-                <a:gd name="connsiteX15" fmla="*/ 1663303 w 2564824"/>
-                <a:gd name="connsiteY15" fmla="*/ 3 h 2150775"/>
-              </a:gdLst>
-              <a:ahLst/>
-              <a:cxnLst>
-                <a:cxn ang="0">
-                  <a:pos x="connsiteX0" y="connsiteY0"/>
-                </a:cxn>
-                <a:cxn ang="0">
-                  <a:pos x="connsiteX1" y="connsiteY1"/>
-                </a:cxn>
-                <a:cxn ang="0">
-                  <a:pos x="connsiteX2" y="connsiteY2"/>
-                </a:cxn>
-                <a:cxn ang="0">
-                  <a:pos x="connsiteX3" y="connsiteY3"/>
-                </a:cxn>
-                <a:cxn ang="0">
-                  <a:pos x="connsiteX4" y="connsiteY4"/>
-                </a:cxn>
-                <a:cxn ang="0">
-                  <a:pos x="connsiteX5" y="connsiteY5"/>
-                </a:cxn>
-                <a:cxn ang="0">
-                  <a:pos x="connsiteX6" y="connsiteY6"/>
-                </a:cxn>
-                <a:cxn ang="0">
-                  <a:pos x="connsiteX7" y="connsiteY7"/>
-                </a:cxn>
-                <a:cxn ang="0">
-                  <a:pos x="connsiteX8" y="connsiteY8"/>
-                </a:cxn>
-                <a:cxn ang="0">
-                  <a:pos x="connsiteX9" y="connsiteY9"/>
-                </a:cxn>
-                <a:cxn ang="0">
-                  <a:pos x="connsiteX10" y="connsiteY10"/>
-                </a:cxn>
-                <a:cxn ang="0">
-                  <a:pos x="connsiteX11" y="connsiteY11"/>
-                </a:cxn>
-                <a:cxn ang="0">
-                  <a:pos x="connsiteX12" y="connsiteY12"/>
-                </a:cxn>
-                <a:cxn ang="0">
-                  <a:pos x="connsiteX13" y="connsiteY13"/>
-                </a:cxn>
-                <a:cxn ang="0">
-                  <a:pos x="connsiteX14" y="connsiteY14"/>
-                </a:cxn>
-                <a:cxn ang="0">
-                  <a:pos x="connsiteX15" y="connsiteY15"/>
-                </a:cxn>
-              </a:cxnLst>
-              <a:rect l="l" t="t" r="r" b="b"/>
-              <a:pathLst>
-                <a:path w="2564824" h="2150775">
-                  <a:moveTo>
-                    <a:pt x="2564824" y="631068"/>
-                  </a:moveTo>
-                  <a:cubicBezTo>
-                    <a:pt x="2417431" y="1114191"/>
-                    <a:pt x="2443202" y="1345119"/>
-                    <a:pt x="2126943" y="1661378"/>
-                  </a:cubicBezTo>
-                  <a:cubicBezTo>
-                    <a:pt x="2055301" y="1733020"/>
-                    <a:pt x="1969515" y="1790214"/>
-                    <a:pt x="1882244" y="1841682"/>
-                  </a:cubicBezTo>
-                  <a:cubicBezTo>
-                    <a:pt x="1801145" y="1889510"/>
-                    <a:pt x="1715276" y="1932008"/>
-                    <a:pt x="1624667" y="1957592"/>
-                  </a:cubicBezTo>
-                  <a:cubicBezTo>
-                    <a:pt x="1349066" y="2035409"/>
-                    <a:pt x="787540" y="2150775"/>
-                    <a:pt x="787540" y="2150775"/>
-                  </a:cubicBezTo>
-                  <a:cubicBezTo>
-                    <a:pt x="727439" y="2146482"/>
-                    <a:pt x="664199" y="2157538"/>
-                    <a:pt x="607236" y="2137896"/>
-                  </a:cubicBezTo>
-                  <a:cubicBezTo>
-                    <a:pt x="536242" y="2113415"/>
-                    <a:pt x="466378" y="2075851"/>
-                    <a:pt x="414052" y="2021986"/>
-                  </a:cubicBezTo>
-                  <a:cubicBezTo>
-                    <a:pt x="203552" y="1805295"/>
-                    <a:pt x="150799" y="1648339"/>
-                    <a:pt x="27686" y="1390921"/>
-                  </a:cubicBezTo>
-                  <a:cubicBezTo>
-                    <a:pt x="11956" y="1257210"/>
-                    <a:pt x="-37734" y="1023895"/>
-                    <a:pt x="53444" y="901524"/>
-                  </a:cubicBezTo>
-                  <a:cubicBezTo>
-                    <a:pt x="77699" y="868972"/>
-                    <a:pt x="433922" y="547657"/>
-                    <a:pt x="594357" y="437885"/>
-                  </a:cubicBezTo>
-                  <a:cubicBezTo>
-                    <a:pt x="640552" y="406278"/>
-                    <a:pt x="687835" y="376207"/>
-                    <a:pt x="736024" y="347732"/>
-                  </a:cubicBezTo>
-                  <a:cubicBezTo>
-                    <a:pt x="782334" y="320367"/>
-                    <a:pt x="828382" y="291953"/>
-                    <a:pt x="877692" y="270459"/>
-                  </a:cubicBezTo>
-                  <a:cubicBezTo>
-                    <a:pt x="996079" y="218854"/>
-                    <a:pt x="1238300" y="128792"/>
-                    <a:pt x="1238300" y="128792"/>
-                  </a:cubicBezTo>
-                  <a:cubicBezTo>
-                    <a:pt x="1281230" y="94448"/>
-                    <a:pt x="1319173" y="52714"/>
-                    <a:pt x="1367089" y="25761"/>
-                  </a:cubicBezTo>
-                  <a:cubicBezTo>
-                    <a:pt x="1389848" y="12959"/>
-                    <a:pt x="1418367" y="15358"/>
-                    <a:pt x="1444362" y="12882"/>
-                  </a:cubicBezTo>
-                  <a:cubicBezTo>
-                    <a:pt x="1585587" y="-568"/>
-                    <a:pt x="1581060" y="3"/>
-                    <a:pt x="1663303" y="3"/>
-                  </a:cubicBezTo>
-                </a:path>
-              </a:pathLst>
-            </a:custGeom>
-            <a:noFill/>
-            <a:ln w="38100">
-              <a:solidFill>
-                <a:srgbClr val="791179"/>
-              </a:solidFill>
-            </a:ln>
-          </p:spPr>
-          <p:style>
-            <a:lnRef idx="2">
-              <a:schemeClr val="accent1">
-                <a:shade val="15000"/>
-              </a:schemeClr>
-            </a:lnRef>
-            <a:fillRef idx="1">
-              <a:schemeClr val="accent1"/>
-            </a:fillRef>
-            <a:effectRef idx="0">
-              <a:schemeClr val="accent1"/>
-            </a:effectRef>
-            <a:fontRef idx="minor">
-              <a:schemeClr val="lt1"/>
-            </a:fontRef>
-          </p:style>
-          <p:txBody>
-            <a:bodyPr rtlCol="0" anchor="ctr"/>
-            <a:lstStyle/>
-            <a:p>
-              <a:pPr algn="ctr"/>
-              <a:endParaRPr lang="en-US"/>
-            </a:p>
-          </p:txBody>
-        </p:sp>
-        <p:sp>
-          <p:nvSpPr>
-            <p:cNvPr id="12" name="Forma libre: forma 11">
-              <a:extLst>
-                <a:ext uri="{FF2B5EF4-FFF2-40B4-BE49-F238E27FC236}">
-                  <a16:creationId xmlns:a16="http://schemas.microsoft.com/office/drawing/2014/main" id="{D6721B3E-B356-995B-F1B4-09A6E562C7C3}"/>
-                </a:ext>
-              </a:extLst>
-            </p:cNvPr>
-            <p:cNvSpPr/>
-            <p:nvPr/>
-          </p:nvSpPr>
-          <p:spPr>
-            <a:xfrm>
-              <a:off x="5798344" y="1478756"/>
-              <a:ext cx="188119" cy="211932"/>
-            </a:xfrm>
-            <a:custGeom>
-              <a:avLst/>
-              <a:gdLst>
-                <a:gd name="connsiteX0" fmla="*/ 0 w 188119"/>
-                <a:gd name="connsiteY0" fmla="*/ 0 h 211932"/>
-                <a:gd name="connsiteX1" fmla="*/ 109537 w 188119"/>
-                <a:gd name="connsiteY1" fmla="*/ 26194 h 211932"/>
-                <a:gd name="connsiteX2" fmla="*/ 133350 w 188119"/>
-                <a:gd name="connsiteY2" fmla="*/ 38100 h 211932"/>
-                <a:gd name="connsiteX3" fmla="*/ 159544 w 188119"/>
-                <a:gd name="connsiteY3" fmla="*/ 50007 h 211932"/>
-                <a:gd name="connsiteX4" fmla="*/ 180975 w 188119"/>
-                <a:gd name="connsiteY4" fmla="*/ 54769 h 211932"/>
-                <a:gd name="connsiteX5" fmla="*/ 188119 w 188119"/>
-                <a:gd name="connsiteY5" fmla="*/ 57150 h 211932"/>
-                <a:gd name="connsiteX6" fmla="*/ 140494 w 188119"/>
-                <a:gd name="connsiteY6" fmla="*/ 121444 h 211932"/>
-                <a:gd name="connsiteX7" fmla="*/ 123825 w 188119"/>
-                <a:gd name="connsiteY7" fmla="*/ 140494 h 211932"/>
-                <a:gd name="connsiteX8" fmla="*/ 102394 w 188119"/>
-                <a:gd name="connsiteY8" fmla="*/ 150019 h 211932"/>
-                <a:gd name="connsiteX9" fmla="*/ 80962 w 188119"/>
-                <a:gd name="connsiteY9" fmla="*/ 173832 h 211932"/>
-                <a:gd name="connsiteX10" fmla="*/ 73819 w 188119"/>
-                <a:gd name="connsiteY10" fmla="*/ 180975 h 211932"/>
-                <a:gd name="connsiteX11" fmla="*/ 69056 w 188119"/>
-                <a:gd name="connsiteY11" fmla="*/ 190500 h 211932"/>
-                <a:gd name="connsiteX12" fmla="*/ 61912 w 188119"/>
-                <a:gd name="connsiteY12" fmla="*/ 202407 h 211932"/>
-                <a:gd name="connsiteX13" fmla="*/ 52387 w 188119"/>
-                <a:gd name="connsiteY13" fmla="*/ 211932 h 211932"/>
-              </a:gdLst>
-              <a:ahLst/>
-              <a:cxnLst>
-                <a:cxn ang="0">
-                  <a:pos x="connsiteX0" y="connsiteY0"/>
-                </a:cxn>
-                <a:cxn ang="0">
-                  <a:pos x="connsiteX1" y="connsiteY1"/>
-                </a:cxn>
-                <a:cxn ang="0">
-                  <a:pos x="connsiteX2" y="connsiteY2"/>
-                </a:cxn>
-                <a:cxn ang="0">
-                  <a:pos x="connsiteX3" y="connsiteY3"/>
-                </a:cxn>
-                <a:cxn ang="0">
-                  <a:pos x="connsiteX4" y="connsiteY4"/>
-                </a:cxn>
-                <a:cxn ang="0">
-                  <a:pos x="connsiteX5" y="connsiteY5"/>
-                </a:cxn>
-                <a:cxn ang="0">
-                  <a:pos x="connsiteX6" y="connsiteY6"/>
-                </a:cxn>
-                <a:cxn ang="0">
-                  <a:pos x="connsiteX7" y="connsiteY7"/>
-                </a:cxn>
-                <a:cxn ang="0">
-                  <a:pos x="connsiteX8" y="connsiteY8"/>
-                </a:cxn>
-                <a:cxn ang="0">
-                  <a:pos x="connsiteX9" y="connsiteY9"/>
-                </a:cxn>
-                <a:cxn ang="0">
-                  <a:pos x="connsiteX10" y="connsiteY10"/>
-                </a:cxn>
-                <a:cxn ang="0">
-                  <a:pos x="connsiteX11" y="connsiteY11"/>
-                </a:cxn>
-                <a:cxn ang="0">
-                  <a:pos x="connsiteX12" y="connsiteY12"/>
-                </a:cxn>
-                <a:cxn ang="0">
-                  <a:pos x="connsiteX13" y="connsiteY13"/>
-                </a:cxn>
-              </a:cxnLst>
-              <a:rect l="l" t="t" r="r" b="b"/>
-              <a:pathLst>
-                <a:path w="188119" h="211932">
-                  <a:moveTo>
-                    <a:pt x="0" y="0"/>
-                  </a:moveTo>
-                  <a:cubicBezTo>
-                    <a:pt x="59974" y="11996"/>
-                    <a:pt x="54255" y="9184"/>
-                    <a:pt x="109537" y="26194"/>
-                  </a:cubicBezTo>
-                  <a:cubicBezTo>
-                    <a:pt x="125437" y="31086"/>
-                    <a:pt x="118108" y="30479"/>
-                    <a:pt x="133350" y="38100"/>
-                  </a:cubicBezTo>
-                  <a:cubicBezTo>
-                    <a:pt x="141929" y="42389"/>
-                    <a:pt x="150639" y="46445"/>
-                    <a:pt x="159544" y="50007"/>
-                  </a:cubicBezTo>
-                  <a:cubicBezTo>
-                    <a:pt x="163616" y="51636"/>
-                    <a:pt x="177459" y="53890"/>
-                    <a:pt x="180975" y="54769"/>
-                  </a:cubicBezTo>
-                  <a:cubicBezTo>
-                    <a:pt x="183410" y="55378"/>
-                    <a:pt x="185738" y="56356"/>
-                    <a:pt x="188119" y="57150"/>
-                  </a:cubicBezTo>
-                  <a:cubicBezTo>
-                    <a:pt x="187294" y="58275"/>
-                    <a:pt x="144649" y="116696"/>
-                    <a:pt x="140494" y="121444"/>
-                  </a:cubicBezTo>
-                  <a:cubicBezTo>
-                    <a:pt x="134938" y="127794"/>
-                    <a:pt x="130575" y="135431"/>
-                    <a:pt x="123825" y="140494"/>
-                  </a:cubicBezTo>
-                  <a:cubicBezTo>
-                    <a:pt x="117571" y="145184"/>
-                    <a:pt x="109538" y="146844"/>
-                    <a:pt x="102394" y="150019"/>
-                  </a:cubicBezTo>
-                  <a:cubicBezTo>
-                    <a:pt x="76108" y="176303"/>
-                    <a:pt x="103760" y="147776"/>
-                    <a:pt x="80962" y="173832"/>
-                  </a:cubicBezTo>
-                  <a:cubicBezTo>
-                    <a:pt x="78745" y="176366"/>
-                    <a:pt x="75776" y="178235"/>
-                    <a:pt x="73819" y="180975"/>
-                  </a:cubicBezTo>
-                  <a:cubicBezTo>
-                    <a:pt x="71756" y="183864"/>
-                    <a:pt x="70780" y="187397"/>
-                    <a:pt x="69056" y="190500"/>
-                  </a:cubicBezTo>
-                  <a:cubicBezTo>
-                    <a:pt x="66808" y="194546"/>
-                    <a:pt x="64689" y="198704"/>
-                    <a:pt x="61912" y="202407"/>
-                  </a:cubicBezTo>
-                  <a:cubicBezTo>
-                    <a:pt x="59218" y="205999"/>
-                    <a:pt x="55562" y="208757"/>
-                    <a:pt x="52387" y="211932"/>
-                  </a:cubicBezTo>
-                </a:path>
-              </a:pathLst>
-            </a:custGeom>
-            <a:noFill/>
-            <a:ln w="38100">
-              <a:solidFill>
-                <a:srgbClr val="8A008A"/>
-              </a:solidFill>
-            </a:ln>
-          </p:spPr>
-          <p:style>
-            <a:lnRef idx="2">
-              <a:schemeClr val="accent1">
-                <a:shade val="15000"/>
-              </a:schemeClr>
-            </a:lnRef>
-            <a:fillRef idx="1">
-              <a:schemeClr val="accent1"/>
-            </a:fillRef>
-            <a:effectRef idx="0">
-              <a:schemeClr val="accent1"/>
-            </a:effectRef>
-            <a:fontRef idx="minor">
-              <a:schemeClr val="lt1"/>
-            </a:fontRef>
-          </p:style>
-          <p:txBody>
-            <a:bodyPr rtlCol="0" anchor="ctr"/>
-            <a:lstStyle/>
-            <a:p>
-              <a:pPr algn="ctr"/>
-              <a:endParaRPr lang="en-US"/>
-            </a:p>
-          </p:txBody>
-        </p:sp>
-      </p:grpSp>
-      <p:sp>
-        <p:nvSpPr>
-          <p:cNvPr id="13" name="CuadroTexto 12">
-            <a:extLst>
-              <a:ext uri="{FF2B5EF4-FFF2-40B4-BE49-F238E27FC236}">
-                <a16:creationId xmlns:a16="http://schemas.microsoft.com/office/drawing/2014/main" id="{45EC1769-58C5-19F6-ED4E-81D0E2650381}"/>
-              </a:ext>
-            </a:extLst>
-          </p:cNvPr>
-          <p:cNvSpPr txBox="1"/>
-          <p:nvPr/>
-        </p:nvSpPr>
-        <p:spPr>
-          <a:xfrm>
-            <a:off x="5592375" y="2662913"/>
-            <a:ext cx="361682" cy="769441"/>
-          </a:xfrm>
-          <a:prstGeom prst="rect">
-            <a:avLst/>
-          </a:prstGeom>
-          <a:noFill/>
-        </p:spPr>
-        <p:txBody>
-          <a:bodyPr wrap="square" rtlCol="0">
-            <a:spAutoFit/>
-          </a:bodyPr>
-          <a:lstStyle/>
-          <a:p>
-            <a:r>
-              <a:rPr lang="en-US" sz="4400" b="1" dirty="0">
-                <a:solidFill>
-                  <a:srgbClr val="00B050"/>
-                </a:solidFill>
-              </a:rPr>
-              <a:t>T</a:t>
-            </a:r>
-          </a:p>
-        </p:txBody>
-      </p:sp>
-      <p:sp>
-        <p:nvSpPr>
-          <p:cNvPr id="14" name="CuadroTexto 13">
-            <a:extLst>
-              <a:ext uri="{FF2B5EF4-FFF2-40B4-BE49-F238E27FC236}">
-                <a16:creationId xmlns:a16="http://schemas.microsoft.com/office/drawing/2014/main" id="{E6A8207D-903B-F223-FC1C-645B209A93B3}"/>
-              </a:ext>
-            </a:extLst>
-          </p:cNvPr>
-          <p:cNvSpPr txBox="1"/>
-          <p:nvPr/>
-        </p:nvSpPr>
-        <p:spPr>
-          <a:xfrm>
-            <a:off x="9331684" y="2553521"/>
-            <a:ext cx="583841" cy="769441"/>
-          </a:xfrm>
-          <a:prstGeom prst="rect">
-            <a:avLst/>
-          </a:prstGeom>
-          <a:noFill/>
-        </p:spPr>
-        <p:txBody>
-          <a:bodyPr wrap="square" rtlCol="0">
-            <a:spAutoFit/>
-          </a:bodyPr>
-          <a:lstStyle/>
-          <a:p>
-            <a:r>
-              <a:rPr lang="en-US" sz="4400" b="1" dirty="0">
-                <a:solidFill>
-                  <a:srgbClr val="FF0000"/>
-                </a:solidFill>
-              </a:rPr>
-              <a:t>F</a:t>
-            </a:r>
-          </a:p>
-        </p:txBody>
-      </p:sp>
-      <p:sp>
-        <p:nvSpPr>
-          <p:cNvPr id="15" name="CuadroTexto 14">
-            <a:extLst>
-              <a:ext uri="{FF2B5EF4-FFF2-40B4-BE49-F238E27FC236}">
-                <a16:creationId xmlns:a16="http://schemas.microsoft.com/office/drawing/2014/main" id="{4B4F8199-CCFA-42D1-8ED2-649051600151}"/>
-              </a:ext>
-            </a:extLst>
-          </p:cNvPr>
-          <p:cNvSpPr txBox="1"/>
-          <p:nvPr/>
-        </p:nvSpPr>
-        <p:spPr>
-          <a:xfrm>
-            <a:off x="6302239" y="2262593"/>
-            <a:ext cx="2943068" cy="369332"/>
-          </a:xfrm>
-          <a:prstGeom prst="rect">
-            <a:avLst/>
-          </a:prstGeom>
-          <a:noFill/>
-        </p:spPr>
-        <p:txBody>
-          <a:bodyPr wrap="square" rtlCol="0">
-            <a:spAutoFit/>
-          </a:bodyPr>
-          <a:lstStyle/>
-          <a:p>
-            <a:r>
-              <a:rPr lang="en-US" dirty="0"/>
-              <a:t>is </a:t>
-            </a:r>
-            <a:r>
-              <a:rPr lang="en-US" dirty="0" err="1"/>
-              <a:t>kettle_temperature</a:t>
-            </a:r>
-            <a:r>
-              <a:rPr lang="en-US" dirty="0"/>
-              <a:t> &lt; 100?</a:t>
+              <a:t>Ln 3</a:t>
             </a:r>
           </a:p>
         </p:txBody>
@@ -4856,7 +5068,12 @@
             <p:ph type="title"/>
           </p:nvPr>
         </p:nvSpPr>
-        <p:spPr/>
+        <p:spPr>
+          <a:xfrm>
+            <a:off x="129860" y="365125"/>
+            <a:ext cx="10515600" cy="1325563"/>
+          </a:xfrm>
+        </p:spPr>
         <p:txBody>
           <a:bodyPr/>
           <a:lstStyle/>
@@ -4867,6 +5084,13 @@
                 <a:cs typeface="Cascadia Code SemiBold" panose="020B0609020000020004" pitchFamily="49" charset="0"/>
               </a:rPr>
               <a:t>For</a:t>
+            </a:r>
+            <a:r>
+              <a:rPr lang="es-AR" b="1" dirty="0">
+                <a:latin typeface="Consolas" panose="020B0609020204030204" pitchFamily="49" charset="0"/>
+                <a:cs typeface="Cascadia Code SemiBold" panose="020B0609020000020004" pitchFamily="49" charset="0"/>
+              </a:rPr>
+              <a:t> ____ in ____</a:t>
             </a:r>
             <a:br>
               <a:rPr lang="es-AR" dirty="0"/>
@@ -4923,8 +5147,8 @@
         </p:nvSpPr>
         <p:spPr>
           <a:xfrm>
-            <a:off x="838200" y="2756079"/>
-            <a:ext cx="1177254" cy="2786130"/>
+            <a:off x="319303" y="1826482"/>
+            <a:ext cx="891890" cy="2110778"/>
           </a:xfrm>
           <a:custGeom>
             <a:avLst/>
@@ -5195,10 +5419,2448 @@
           </a:p>
         </p:txBody>
       </p:sp>
+      <p:pic>
+        <p:nvPicPr>
+          <p:cNvPr id="3" name="Imagen 2">
+            <a:extLst>
+              <a:ext uri="{FF2B5EF4-FFF2-40B4-BE49-F238E27FC236}">
+                <a16:creationId xmlns:a16="http://schemas.microsoft.com/office/drawing/2014/main" id="{C646EF31-6ACD-5252-AB1B-7DC323B41E95}"/>
+              </a:ext>
+            </a:extLst>
+          </p:cNvPr>
+          <p:cNvPicPr>
+            <a:picLocks noChangeAspect="1"/>
+          </p:cNvPicPr>
+          <p:nvPr/>
+        </p:nvPicPr>
+        <p:blipFill>
+          <a:blip r:embed="rId2">
+            <a:extLst>
+              <a:ext uri="{28A0092B-C50C-407E-A947-70E740481C1C}">
+                <a14:useLocalDpi xmlns:a14="http://schemas.microsoft.com/office/drawing/2010/main" val="0"/>
+              </a:ext>
+            </a:extLst>
+          </a:blip>
+          <a:stretch>
+            <a:fillRect/>
+          </a:stretch>
+        </p:blipFill>
+        <p:spPr>
+          <a:xfrm>
+            <a:off x="10765173" y="3428999"/>
+            <a:ext cx="1177254" cy="2261919"/>
+          </a:xfrm>
+          <a:prstGeom prst="rect">
+            <a:avLst/>
+          </a:prstGeom>
+        </p:spPr>
+      </p:pic>
+      <p:sp>
+        <p:nvSpPr>
+          <p:cNvPr id="7" name="CuadroTexto 6">
+            <a:extLst>
+              <a:ext uri="{FF2B5EF4-FFF2-40B4-BE49-F238E27FC236}">
+                <a16:creationId xmlns:a16="http://schemas.microsoft.com/office/drawing/2014/main" id="{36F9D99F-297C-A5EC-E924-942CFB386CFB}"/>
+              </a:ext>
+            </a:extLst>
+          </p:cNvPr>
+          <p:cNvSpPr txBox="1"/>
+          <p:nvPr/>
+        </p:nvSpPr>
+        <p:spPr>
+          <a:xfrm>
+            <a:off x="7695075" y="5034795"/>
+            <a:ext cx="847164" cy="369332"/>
+          </a:xfrm>
+          <a:prstGeom prst="rect">
+            <a:avLst/>
+          </a:prstGeom>
+          <a:noFill/>
+        </p:spPr>
+        <p:txBody>
+          <a:bodyPr wrap="square" rtlCol="0">
+            <a:spAutoFit/>
+          </a:bodyPr>
+          <a:lstStyle/>
+          <a:p>
+            <a:r>
+              <a:rPr lang="en-US" dirty="0"/>
+              <a:t>Ln 5</a:t>
+            </a:r>
+          </a:p>
+        </p:txBody>
+      </p:sp>
+      <p:sp>
+        <p:nvSpPr>
+          <p:cNvPr id="8" name="Elipse 7">
+            <a:extLst>
+              <a:ext uri="{FF2B5EF4-FFF2-40B4-BE49-F238E27FC236}">
+                <a16:creationId xmlns:a16="http://schemas.microsoft.com/office/drawing/2014/main" id="{C2F364C0-E51A-FF84-DFF2-F1912A623D9C}"/>
+              </a:ext>
+            </a:extLst>
+          </p:cNvPr>
+          <p:cNvSpPr/>
+          <p:nvPr/>
+        </p:nvSpPr>
+        <p:spPr>
+          <a:xfrm>
+            <a:off x="7695075" y="5256864"/>
+            <a:ext cx="2743200" cy="958383"/>
+          </a:xfrm>
+          <a:prstGeom prst="ellipse">
+            <a:avLst/>
+          </a:prstGeom>
+          <a:solidFill>
+            <a:srgbClr val="CAD7EE"/>
+          </a:solidFill>
+          <a:ln w="38100"/>
+        </p:spPr>
+        <p:style>
+          <a:lnRef idx="2">
+            <a:schemeClr val="accent1">
+              <a:shade val="15000"/>
+            </a:schemeClr>
+          </a:lnRef>
+          <a:fillRef idx="1">
+            <a:schemeClr val="accent1"/>
+          </a:fillRef>
+          <a:effectRef idx="0">
+            <a:schemeClr val="accent1"/>
+          </a:effectRef>
+          <a:fontRef idx="minor">
+            <a:schemeClr val="lt1"/>
+          </a:fontRef>
+        </p:style>
+        <p:txBody>
+          <a:bodyPr rtlCol="0" anchor="ctr"/>
+          <a:lstStyle/>
+          <a:p>
+            <a:pPr algn="ctr"/>
+            <a:endParaRPr lang="en-US"/>
+          </a:p>
+        </p:txBody>
+      </p:sp>
+      <p:sp>
+        <p:nvSpPr>
+          <p:cNvPr id="9" name="CuadroTexto 8">
+            <a:extLst>
+              <a:ext uri="{FF2B5EF4-FFF2-40B4-BE49-F238E27FC236}">
+                <a16:creationId xmlns:a16="http://schemas.microsoft.com/office/drawing/2014/main" id="{40988F13-3576-2A11-742A-7BFBD617168A}"/>
+              </a:ext>
+            </a:extLst>
+          </p:cNvPr>
+          <p:cNvSpPr txBox="1"/>
+          <p:nvPr/>
+        </p:nvSpPr>
+        <p:spPr>
+          <a:xfrm>
+            <a:off x="7793088" y="5551389"/>
+            <a:ext cx="2743200" cy="369332"/>
+          </a:xfrm>
+          <a:prstGeom prst="rect">
+            <a:avLst/>
+          </a:prstGeom>
+          <a:noFill/>
+        </p:spPr>
+        <p:txBody>
+          <a:bodyPr wrap="square" rtlCol="0">
+            <a:spAutoFit/>
+          </a:bodyPr>
+          <a:lstStyle/>
+          <a:p>
+            <a:pPr algn="ctr"/>
+            <a:r>
+              <a:rPr lang="en-US" dirty="0"/>
+              <a:t>print(</a:t>
+            </a:r>
+            <a:r>
+              <a:rPr lang="en-US" dirty="0" err="1"/>
+              <a:t>full_names</a:t>
+            </a:r>
+            <a:r>
+              <a:rPr lang="en-US" dirty="0"/>
+              <a:t>)</a:t>
+            </a:r>
+          </a:p>
+        </p:txBody>
+      </p:sp>
+      <p:grpSp>
+        <p:nvGrpSpPr>
+          <p:cNvPr id="17" name="Grupo 16">
+            <a:extLst>
+              <a:ext uri="{FF2B5EF4-FFF2-40B4-BE49-F238E27FC236}">
+                <a16:creationId xmlns:a16="http://schemas.microsoft.com/office/drawing/2014/main" id="{985445FB-B587-C2FB-458E-2CDECE581D7C}"/>
+              </a:ext>
+            </a:extLst>
+          </p:cNvPr>
+          <p:cNvGrpSpPr/>
+          <p:nvPr/>
+        </p:nvGrpSpPr>
+        <p:grpSpPr>
+          <a:xfrm>
+            <a:off x="7837125" y="38921"/>
+            <a:ext cx="3058402" cy="1254083"/>
+            <a:chOff x="7470476" y="695741"/>
+            <a:chExt cx="4446516" cy="1254083"/>
+          </a:xfrm>
+        </p:grpSpPr>
+        <p:sp>
+          <p:nvSpPr>
+            <p:cNvPr id="5" name="Elipse 4">
+              <a:extLst>
+                <a:ext uri="{FF2B5EF4-FFF2-40B4-BE49-F238E27FC236}">
+                  <a16:creationId xmlns:a16="http://schemas.microsoft.com/office/drawing/2014/main" id="{74F86612-FB7B-9959-B06C-73857629FA4E}"/>
+                </a:ext>
+              </a:extLst>
+            </p:cNvPr>
+            <p:cNvSpPr/>
+            <p:nvPr/>
+          </p:nvSpPr>
+          <p:spPr>
+            <a:xfrm>
+              <a:off x="7661457" y="991441"/>
+              <a:ext cx="3984558" cy="958383"/>
+            </a:xfrm>
+            <a:prstGeom prst="ellipse">
+              <a:avLst/>
+            </a:prstGeom>
+            <a:solidFill>
+              <a:srgbClr val="CAD7EE"/>
+            </a:solidFill>
+            <a:ln w="38100"/>
+          </p:spPr>
+          <p:style>
+            <a:lnRef idx="2">
+              <a:schemeClr val="accent1">
+                <a:shade val="15000"/>
+              </a:schemeClr>
+            </a:lnRef>
+            <a:fillRef idx="1">
+              <a:schemeClr val="accent1"/>
+            </a:fillRef>
+            <a:effectRef idx="0">
+              <a:schemeClr val="accent1"/>
+            </a:effectRef>
+            <a:fontRef idx="minor">
+              <a:schemeClr val="lt1"/>
+            </a:fontRef>
+          </p:style>
+          <p:txBody>
+            <a:bodyPr rtlCol="0" anchor="ctr"/>
+            <a:lstStyle/>
+            <a:p>
+              <a:pPr algn="ctr"/>
+              <a:endParaRPr lang="en-US"/>
+            </a:p>
+          </p:txBody>
+        </p:sp>
+        <p:sp>
+          <p:nvSpPr>
+            <p:cNvPr id="6" name="CuadroTexto 5">
+              <a:extLst>
+                <a:ext uri="{FF2B5EF4-FFF2-40B4-BE49-F238E27FC236}">
+                  <a16:creationId xmlns:a16="http://schemas.microsoft.com/office/drawing/2014/main" id="{DBD6D31E-334F-D53E-D7F1-9EF1E6B928F7}"/>
+                </a:ext>
+              </a:extLst>
+            </p:cNvPr>
+            <p:cNvSpPr txBox="1"/>
+            <p:nvPr/>
+          </p:nvSpPr>
+          <p:spPr>
+            <a:xfrm>
+              <a:off x="7470476" y="1304205"/>
+              <a:ext cx="4446516" cy="369332"/>
+            </a:xfrm>
+            <a:prstGeom prst="rect">
+              <a:avLst/>
+            </a:prstGeom>
+            <a:noFill/>
+          </p:spPr>
+          <p:txBody>
+            <a:bodyPr wrap="square" rtlCol="0">
+              <a:spAutoFit/>
+            </a:bodyPr>
+            <a:lstStyle/>
+            <a:p>
+              <a:pPr algn="ctr"/>
+              <a:r>
+                <a:rPr lang="en-US" dirty="0"/>
+                <a:t>numbers = [1, 2, 3, 4, 5]</a:t>
+              </a:r>
+            </a:p>
+          </p:txBody>
+        </p:sp>
+        <p:sp>
+          <p:nvSpPr>
+            <p:cNvPr id="10" name="CuadroTexto 9">
+              <a:extLst>
+                <a:ext uri="{FF2B5EF4-FFF2-40B4-BE49-F238E27FC236}">
+                  <a16:creationId xmlns:a16="http://schemas.microsoft.com/office/drawing/2014/main" id="{E129EDAB-429A-C957-FBD5-9654D3719938}"/>
+                </a:ext>
+              </a:extLst>
+            </p:cNvPr>
+            <p:cNvSpPr txBox="1"/>
+            <p:nvPr/>
+          </p:nvSpPr>
+          <p:spPr>
+            <a:xfrm>
+              <a:off x="7896781" y="695741"/>
+              <a:ext cx="847164" cy="369332"/>
+            </a:xfrm>
+            <a:prstGeom prst="rect">
+              <a:avLst/>
+            </a:prstGeom>
+            <a:noFill/>
+          </p:spPr>
+          <p:txBody>
+            <a:bodyPr wrap="square" rtlCol="0">
+              <a:spAutoFit/>
+            </a:bodyPr>
+            <a:lstStyle/>
+            <a:p>
+              <a:r>
+                <a:rPr lang="en-US" dirty="0"/>
+                <a:t>Ln 1</a:t>
+              </a:r>
+            </a:p>
+          </p:txBody>
+        </p:sp>
+      </p:grpSp>
+      <p:grpSp>
+        <p:nvGrpSpPr>
+          <p:cNvPr id="11" name="Grupo 10">
+            <a:extLst>
+              <a:ext uri="{FF2B5EF4-FFF2-40B4-BE49-F238E27FC236}">
+                <a16:creationId xmlns:a16="http://schemas.microsoft.com/office/drawing/2014/main" id="{4B992A34-F18D-F698-89B1-5D121824A385}"/>
+              </a:ext>
+            </a:extLst>
+          </p:cNvPr>
+          <p:cNvGrpSpPr/>
+          <p:nvPr/>
+        </p:nvGrpSpPr>
+        <p:grpSpPr>
+          <a:xfrm rot="1017173">
+            <a:off x="5372715" y="2382051"/>
+            <a:ext cx="2337358" cy="2087943"/>
+            <a:chOff x="4312494" y="1392221"/>
+            <a:chExt cx="2564824" cy="2291137"/>
+          </a:xfrm>
+        </p:grpSpPr>
+        <p:sp>
+          <p:nvSpPr>
+            <p:cNvPr id="12" name="Forma libre: forma 11">
+              <a:extLst>
+                <a:ext uri="{FF2B5EF4-FFF2-40B4-BE49-F238E27FC236}">
+                  <a16:creationId xmlns:a16="http://schemas.microsoft.com/office/drawing/2014/main" id="{7633CA4D-A114-3659-97BB-616DA2300C6F}"/>
+                </a:ext>
+              </a:extLst>
+            </p:cNvPr>
+            <p:cNvSpPr/>
+            <p:nvPr/>
+          </p:nvSpPr>
+          <p:spPr>
+            <a:xfrm>
+              <a:off x="4312494" y="1532583"/>
+              <a:ext cx="2564824" cy="2150775"/>
+            </a:xfrm>
+            <a:custGeom>
+              <a:avLst/>
+              <a:gdLst>
+                <a:gd name="connsiteX0" fmla="*/ 2564824 w 2564824"/>
+                <a:gd name="connsiteY0" fmla="*/ 631068 h 2150775"/>
+                <a:gd name="connsiteX1" fmla="*/ 2126943 w 2564824"/>
+                <a:gd name="connsiteY1" fmla="*/ 1661378 h 2150775"/>
+                <a:gd name="connsiteX2" fmla="*/ 1882244 w 2564824"/>
+                <a:gd name="connsiteY2" fmla="*/ 1841682 h 2150775"/>
+                <a:gd name="connsiteX3" fmla="*/ 1624667 w 2564824"/>
+                <a:gd name="connsiteY3" fmla="*/ 1957592 h 2150775"/>
+                <a:gd name="connsiteX4" fmla="*/ 787540 w 2564824"/>
+                <a:gd name="connsiteY4" fmla="*/ 2150775 h 2150775"/>
+                <a:gd name="connsiteX5" fmla="*/ 607236 w 2564824"/>
+                <a:gd name="connsiteY5" fmla="*/ 2137896 h 2150775"/>
+                <a:gd name="connsiteX6" fmla="*/ 414052 w 2564824"/>
+                <a:gd name="connsiteY6" fmla="*/ 2021986 h 2150775"/>
+                <a:gd name="connsiteX7" fmla="*/ 27686 w 2564824"/>
+                <a:gd name="connsiteY7" fmla="*/ 1390921 h 2150775"/>
+                <a:gd name="connsiteX8" fmla="*/ 53444 w 2564824"/>
+                <a:gd name="connsiteY8" fmla="*/ 901524 h 2150775"/>
+                <a:gd name="connsiteX9" fmla="*/ 594357 w 2564824"/>
+                <a:gd name="connsiteY9" fmla="*/ 437885 h 2150775"/>
+                <a:gd name="connsiteX10" fmla="*/ 736024 w 2564824"/>
+                <a:gd name="connsiteY10" fmla="*/ 347732 h 2150775"/>
+                <a:gd name="connsiteX11" fmla="*/ 877692 w 2564824"/>
+                <a:gd name="connsiteY11" fmla="*/ 270459 h 2150775"/>
+                <a:gd name="connsiteX12" fmla="*/ 1238300 w 2564824"/>
+                <a:gd name="connsiteY12" fmla="*/ 128792 h 2150775"/>
+                <a:gd name="connsiteX13" fmla="*/ 1367089 w 2564824"/>
+                <a:gd name="connsiteY13" fmla="*/ 25761 h 2150775"/>
+                <a:gd name="connsiteX14" fmla="*/ 1444362 w 2564824"/>
+                <a:gd name="connsiteY14" fmla="*/ 12882 h 2150775"/>
+                <a:gd name="connsiteX15" fmla="*/ 1663303 w 2564824"/>
+                <a:gd name="connsiteY15" fmla="*/ 3 h 2150775"/>
+              </a:gdLst>
+              <a:ahLst/>
+              <a:cxnLst>
+                <a:cxn ang="0">
+                  <a:pos x="connsiteX0" y="connsiteY0"/>
+                </a:cxn>
+                <a:cxn ang="0">
+                  <a:pos x="connsiteX1" y="connsiteY1"/>
+                </a:cxn>
+                <a:cxn ang="0">
+                  <a:pos x="connsiteX2" y="connsiteY2"/>
+                </a:cxn>
+                <a:cxn ang="0">
+                  <a:pos x="connsiteX3" y="connsiteY3"/>
+                </a:cxn>
+                <a:cxn ang="0">
+                  <a:pos x="connsiteX4" y="connsiteY4"/>
+                </a:cxn>
+                <a:cxn ang="0">
+                  <a:pos x="connsiteX5" y="connsiteY5"/>
+                </a:cxn>
+                <a:cxn ang="0">
+                  <a:pos x="connsiteX6" y="connsiteY6"/>
+                </a:cxn>
+                <a:cxn ang="0">
+                  <a:pos x="connsiteX7" y="connsiteY7"/>
+                </a:cxn>
+                <a:cxn ang="0">
+                  <a:pos x="connsiteX8" y="connsiteY8"/>
+                </a:cxn>
+                <a:cxn ang="0">
+                  <a:pos x="connsiteX9" y="connsiteY9"/>
+                </a:cxn>
+                <a:cxn ang="0">
+                  <a:pos x="connsiteX10" y="connsiteY10"/>
+                </a:cxn>
+                <a:cxn ang="0">
+                  <a:pos x="connsiteX11" y="connsiteY11"/>
+                </a:cxn>
+                <a:cxn ang="0">
+                  <a:pos x="connsiteX12" y="connsiteY12"/>
+                </a:cxn>
+                <a:cxn ang="0">
+                  <a:pos x="connsiteX13" y="connsiteY13"/>
+                </a:cxn>
+                <a:cxn ang="0">
+                  <a:pos x="connsiteX14" y="connsiteY14"/>
+                </a:cxn>
+                <a:cxn ang="0">
+                  <a:pos x="connsiteX15" y="connsiteY15"/>
+                </a:cxn>
+              </a:cxnLst>
+              <a:rect l="l" t="t" r="r" b="b"/>
+              <a:pathLst>
+                <a:path w="2564824" h="2150775">
+                  <a:moveTo>
+                    <a:pt x="2564824" y="631068"/>
+                  </a:moveTo>
+                  <a:cubicBezTo>
+                    <a:pt x="2417431" y="1114191"/>
+                    <a:pt x="2443202" y="1345119"/>
+                    <a:pt x="2126943" y="1661378"/>
+                  </a:cubicBezTo>
+                  <a:cubicBezTo>
+                    <a:pt x="2055301" y="1733020"/>
+                    <a:pt x="1969515" y="1790214"/>
+                    <a:pt x="1882244" y="1841682"/>
+                  </a:cubicBezTo>
+                  <a:cubicBezTo>
+                    <a:pt x="1801145" y="1889510"/>
+                    <a:pt x="1715276" y="1932008"/>
+                    <a:pt x="1624667" y="1957592"/>
+                  </a:cubicBezTo>
+                  <a:cubicBezTo>
+                    <a:pt x="1349066" y="2035409"/>
+                    <a:pt x="787540" y="2150775"/>
+                    <a:pt x="787540" y="2150775"/>
+                  </a:cubicBezTo>
+                  <a:cubicBezTo>
+                    <a:pt x="727439" y="2146482"/>
+                    <a:pt x="664199" y="2157538"/>
+                    <a:pt x="607236" y="2137896"/>
+                  </a:cubicBezTo>
+                  <a:cubicBezTo>
+                    <a:pt x="536242" y="2113415"/>
+                    <a:pt x="466378" y="2075851"/>
+                    <a:pt x="414052" y="2021986"/>
+                  </a:cubicBezTo>
+                  <a:cubicBezTo>
+                    <a:pt x="203552" y="1805295"/>
+                    <a:pt x="150799" y="1648339"/>
+                    <a:pt x="27686" y="1390921"/>
+                  </a:cubicBezTo>
+                  <a:cubicBezTo>
+                    <a:pt x="11956" y="1257210"/>
+                    <a:pt x="-37734" y="1023895"/>
+                    <a:pt x="53444" y="901524"/>
+                  </a:cubicBezTo>
+                  <a:cubicBezTo>
+                    <a:pt x="77699" y="868972"/>
+                    <a:pt x="433922" y="547657"/>
+                    <a:pt x="594357" y="437885"/>
+                  </a:cubicBezTo>
+                  <a:cubicBezTo>
+                    <a:pt x="640552" y="406278"/>
+                    <a:pt x="687835" y="376207"/>
+                    <a:pt x="736024" y="347732"/>
+                  </a:cubicBezTo>
+                  <a:cubicBezTo>
+                    <a:pt x="782334" y="320367"/>
+                    <a:pt x="828382" y="291953"/>
+                    <a:pt x="877692" y="270459"/>
+                  </a:cubicBezTo>
+                  <a:cubicBezTo>
+                    <a:pt x="996079" y="218854"/>
+                    <a:pt x="1238300" y="128792"/>
+                    <a:pt x="1238300" y="128792"/>
+                  </a:cubicBezTo>
+                  <a:cubicBezTo>
+                    <a:pt x="1281230" y="94448"/>
+                    <a:pt x="1319173" y="52714"/>
+                    <a:pt x="1367089" y="25761"/>
+                  </a:cubicBezTo>
+                  <a:cubicBezTo>
+                    <a:pt x="1389848" y="12959"/>
+                    <a:pt x="1418367" y="15358"/>
+                    <a:pt x="1444362" y="12882"/>
+                  </a:cubicBezTo>
+                  <a:cubicBezTo>
+                    <a:pt x="1585587" y="-568"/>
+                    <a:pt x="1581060" y="3"/>
+                    <a:pt x="1663303" y="3"/>
+                  </a:cubicBezTo>
+                </a:path>
+              </a:pathLst>
+            </a:custGeom>
+            <a:noFill/>
+            <a:ln w="57150">
+              <a:solidFill>
+                <a:srgbClr val="791179"/>
+              </a:solidFill>
+            </a:ln>
+          </p:spPr>
+          <p:style>
+            <a:lnRef idx="2">
+              <a:schemeClr val="accent1">
+                <a:shade val="15000"/>
+              </a:schemeClr>
+            </a:lnRef>
+            <a:fillRef idx="1">
+              <a:schemeClr val="accent1"/>
+            </a:fillRef>
+            <a:effectRef idx="0">
+              <a:schemeClr val="accent1"/>
+            </a:effectRef>
+            <a:fontRef idx="minor">
+              <a:schemeClr val="lt1"/>
+            </a:fontRef>
+          </p:style>
+          <p:txBody>
+            <a:bodyPr rtlCol="0" anchor="ctr"/>
+            <a:lstStyle/>
+            <a:p>
+              <a:pPr algn="ctr"/>
+              <a:endParaRPr lang="en-US">
+                <a:solidFill>
+                  <a:srgbClr val="791179"/>
+                </a:solidFill>
+              </a:endParaRPr>
+            </a:p>
+          </p:txBody>
+        </p:sp>
+        <p:sp>
+          <p:nvSpPr>
+            <p:cNvPr id="13" name="Forma libre: forma 12">
+              <a:extLst>
+                <a:ext uri="{FF2B5EF4-FFF2-40B4-BE49-F238E27FC236}">
+                  <a16:creationId xmlns:a16="http://schemas.microsoft.com/office/drawing/2014/main" id="{4911BBCF-8911-2F0A-61F7-0AC14C5E7D5F}"/>
+                </a:ext>
+              </a:extLst>
+            </p:cNvPr>
+            <p:cNvSpPr/>
+            <p:nvPr/>
+          </p:nvSpPr>
+          <p:spPr>
+            <a:xfrm rot="1067707">
+              <a:off x="5579942" y="1392221"/>
+              <a:ext cx="416126" cy="371948"/>
+            </a:xfrm>
+            <a:custGeom>
+              <a:avLst/>
+              <a:gdLst>
+                <a:gd name="connsiteX0" fmla="*/ 0 w 188119"/>
+                <a:gd name="connsiteY0" fmla="*/ 0 h 211932"/>
+                <a:gd name="connsiteX1" fmla="*/ 109537 w 188119"/>
+                <a:gd name="connsiteY1" fmla="*/ 26194 h 211932"/>
+                <a:gd name="connsiteX2" fmla="*/ 133350 w 188119"/>
+                <a:gd name="connsiteY2" fmla="*/ 38100 h 211932"/>
+                <a:gd name="connsiteX3" fmla="*/ 159544 w 188119"/>
+                <a:gd name="connsiteY3" fmla="*/ 50007 h 211932"/>
+                <a:gd name="connsiteX4" fmla="*/ 180975 w 188119"/>
+                <a:gd name="connsiteY4" fmla="*/ 54769 h 211932"/>
+                <a:gd name="connsiteX5" fmla="*/ 188119 w 188119"/>
+                <a:gd name="connsiteY5" fmla="*/ 57150 h 211932"/>
+                <a:gd name="connsiteX6" fmla="*/ 140494 w 188119"/>
+                <a:gd name="connsiteY6" fmla="*/ 121444 h 211932"/>
+                <a:gd name="connsiteX7" fmla="*/ 123825 w 188119"/>
+                <a:gd name="connsiteY7" fmla="*/ 140494 h 211932"/>
+                <a:gd name="connsiteX8" fmla="*/ 102394 w 188119"/>
+                <a:gd name="connsiteY8" fmla="*/ 150019 h 211932"/>
+                <a:gd name="connsiteX9" fmla="*/ 80962 w 188119"/>
+                <a:gd name="connsiteY9" fmla="*/ 173832 h 211932"/>
+                <a:gd name="connsiteX10" fmla="*/ 73819 w 188119"/>
+                <a:gd name="connsiteY10" fmla="*/ 180975 h 211932"/>
+                <a:gd name="connsiteX11" fmla="*/ 69056 w 188119"/>
+                <a:gd name="connsiteY11" fmla="*/ 190500 h 211932"/>
+                <a:gd name="connsiteX12" fmla="*/ 61912 w 188119"/>
+                <a:gd name="connsiteY12" fmla="*/ 202407 h 211932"/>
+                <a:gd name="connsiteX13" fmla="*/ 52387 w 188119"/>
+                <a:gd name="connsiteY13" fmla="*/ 211932 h 211932"/>
+              </a:gdLst>
+              <a:ahLst/>
+              <a:cxnLst>
+                <a:cxn ang="0">
+                  <a:pos x="connsiteX0" y="connsiteY0"/>
+                </a:cxn>
+                <a:cxn ang="0">
+                  <a:pos x="connsiteX1" y="connsiteY1"/>
+                </a:cxn>
+                <a:cxn ang="0">
+                  <a:pos x="connsiteX2" y="connsiteY2"/>
+                </a:cxn>
+                <a:cxn ang="0">
+                  <a:pos x="connsiteX3" y="connsiteY3"/>
+                </a:cxn>
+                <a:cxn ang="0">
+                  <a:pos x="connsiteX4" y="connsiteY4"/>
+                </a:cxn>
+                <a:cxn ang="0">
+                  <a:pos x="connsiteX5" y="connsiteY5"/>
+                </a:cxn>
+                <a:cxn ang="0">
+                  <a:pos x="connsiteX6" y="connsiteY6"/>
+                </a:cxn>
+                <a:cxn ang="0">
+                  <a:pos x="connsiteX7" y="connsiteY7"/>
+                </a:cxn>
+                <a:cxn ang="0">
+                  <a:pos x="connsiteX8" y="connsiteY8"/>
+                </a:cxn>
+                <a:cxn ang="0">
+                  <a:pos x="connsiteX9" y="connsiteY9"/>
+                </a:cxn>
+                <a:cxn ang="0">
+                  <a:pos x="connsiteX10" y="connsiteY10"/>
+                </a:cxn>
+                <a:cxn ang="0">
+                  <a:pos x="connsiteX11" y="connsiteY11"/>
+                </a:cxn>
+                <a:cxn ang="0">
+                  <a:pos x="connsiteX12" y="connsiteY12"/>
+                </a:cxn>
+                <a:cxn ang="0">
+                  <a:pos x="connsiteX13" y="connsiteY13"/>
+                </a:cxn>
+              </a:cxnLst>
+              <a:rect l="l" t="t" r="r" b="b"/>
+              <a:pathLst>
+                <a:path w="188119" h="211932">
+                  <a:moveTo>
+                    <a:pt x="0" y="0"/>
+                  </a:moveTo>
+                  <a:cubicBezTo>
+                    <a:pt x="59974" y="11996"/>
+                    <a:pt x="54255" y="9184"/>
+                    <a:pt x="109537" y="26194"/>
+                  </a:cubicBezTo>
+                  <a:cubicBezTo>
+                    <a:pt x="125437" y="31086"/>
+                    <a:pt x="118108" y="30479"/>
+                    <a:pt x="133350" y="38100"/>
+                  </a:cubicBezTo>
+                  <a:cubicBezTo>
+                    <a:pt x="141929" y="42389"/>
+                    <a:pt x="150639" y="46445"/>
+                    <a:pt x="159544" y="50007"/>
+                  </a:cubicBezTo>
+                  <a:cubicBezTo>
+                    <a:pt x="163616" y="51636"/>
+                    <a:pt x="177459" y="53890"/>
+                    <a:pt x="180975" y="54769"/>
+                  </a:cubicBezTo>
+                  <a:cubicBezTo>
+                    <a:pt x="183410" y="55378"/>
+                    <a:pt x="185738" y="56356"/>
+                    <a:pt x="188119" y="57150"/>
+                  </a:cubicBezTo>
+                  <a:cubicBezTo>
+                    <a:pt x="187294" y="58275"/>
+                    <a:pt x="144649" y="116696"/>
+                    <a:pt x="140494" y="121444"/>
+                  </a:cubicBezTo>
+                  <a:cubicBezTo>
+                    <a:pt x="134938" y="127794"/>
+                    <a:pt x="130575" y="135431"/>
+                    <a:pt x="123825" y="140494"/>
+                  </a:cubicBezTo>
+                  <a:cubicBezTo>
+                    <a:pt x="117571" y="145184"/>
+                    <a:pt x="109538" y="146844"/>
+                    <a:pt x="102394" y="150019"/>
+                  </a:cubicBezTo>
+                  <a:cubicBezTo>
+                    <a:pt x="76108" y="176303"/>
+                    <a:pt x="103760" y="147776"/>
+                    <a:pt x="80962" y="173832"/>
+                  </a:cubicBezTo>
+                  <a:cubicBezTo>
+                    <a:pt x="78745" y="176366"/>
+                    <a:pt x="75776" y="178235"/>
+                    <a:pt x="73819" y="180975"/>
+                  </a:cubicBezTo>
+                  <a:cubicBezTo>
+                    <a:pt x="71756" y="183864"/>
+                    <a:pt x="70780" y="187397"/>
+                    <a:pt x="69056" y="190500"/>
+                  </a:cubicBezTo>
+                  <a:cubicBezTo>
+                    <a:pt x="66808" y="194546"/>
+                    <a:pt x="64689" y="198704"/>
+                    <a:pt x="61912" y="202407"/>
+                  </a:cubicBezTo>
+                  <a:cubicBezTo>
+                    <a:pt x="59218" y="205999"/>
+                    <a:pt x="55562" y="208757"/>
+                    <a:pt x="52387" y="211932"/>
+                  </a:cubicBezTo>
+                </a:path>
+              </a:pathLst>
+            </a:custGeom>
+            <a:noFill/>
+            <a:ln w="57150">
+              <a:solidFill>
+                <a:srgbClr val="8A008A"/>
+              </a:solidFill>
+            </a:ln>
+          </p:spPr>
+          <p:style>
+            <a:lnRef idx="2">
+              <a:schemeClr val="accent1">
+                <a:shade val="15000"/>
+              </a:schemeClr>
+            </a:lnRef>
+            <a:fillRef idx="1">
+              <a:schemeClr val="accent1"/>
+            </a:fillRef>
+            <a:effectRef idx="0">
+              <a:schemeClr val="accent1"/>
+            </a:effectRef>
+            <a:fontRef idx="minor">
+              <a:schemeClr val="lt1"/>
+            </a:fontRef>
+          </p:style>
+          <p:txBody>
+            <a:bodyPr rtlCol="0" anchor="ctr"/>
+            <a:lstStyle/>
+            <a:p>
+              <a:pPr algn="ctr"/>
+              <a:endParaRPr lang="en-US">
+                <a:solidFill>
+                  <a:srgbClr val="791179"/>
+                </a:solidFill>
+              </a:endParaRPr>
+            </a:p>
+          </p:txBody>
+        </p:sp>
+      </p:grpSp>
+      <p:sp>
+        <p:nvSpPr>
+          <p:cNvPr id="14" name="CuadroTexto 13">
+            <a:extLst>
+              <a:ext uri="{FF2B5EF4-FFF2-40B4-BE49-F238E27FC236}">
+                <a16:creationId xmlns:a16="http://schemas.microsoft.com/office/drawing/2014/main" id="{298AE535-5F3D-A53C-853B-D24C058A5862}"/>
+              </a:ext>
+            </a:extLst>
+          </p:cNvPr>
+          <p:cNvSpPr txBox="1"/>
+          <p:nvPr/>
+        </p:nvSpPr>
+        <p:spPr>
+          <a:xfrm>
+            <a:off x="6983290" y="4105348"/>
+            <a:ext cx="361682" cy="769441"/>
+          </a:xfrm>
+          <a:prstGeom prst="rect">
+            <a:avLst/>
+          </a:prstGeom>
+          <a:noFill/>
+        </p:spPr>
+        <p:txBody>
+          <a:bodyPr wrap="square" rtlCol="0">
+            <a:spAutoFit/>
+          </a:bodyPr>
+          <a:lstStyle/>
+          <a:p>
+            <a:r>
+              <a:rPr lang="en-US" sz="4400" b="1" dirty="0">
+                <a:solidFill>
+                  <a:srgbClr val="00B050"/>
+                </a:solidFill>
+              </a:rPr>
+              <a:t>T</a:t>
+            </a:r>
+          </a:p>
+        </p:txBody>
+      </p:sp>
+      <p:sp>
+        <p:nvSpPr>
+          <p:cNvPr id="15" name="CuadroTexto 14">
+            <a:extLst>
+              <a:ext uri="{FF2B5EF4-FFF2-40B4-BE49-F238E27FC236}">
+                <a16:creationId xmlns:a16="http://schemas.microsoft.com/office/drawing/2014/main" id="{D593883B-1CC8-CD54-67A6-856951F4F14C}"/>
+              </a:ext>
+            </a:extLst>
+          </p:cNvPr>
+          <p:cNvSpPr txBox="1"/>
+          <p:nvPr/>
+        </p:nvSpPr>
+        <p:spPr>
+          <a:xfrm>
+            <a:off x="11199788" y="3877657"/>
+            <a:ext cx="583841" cy="769441"/>
+          </a:xfrm>
+          <a:prstGeom prst="rect">
+            <a:avLst/>
+          </a:prstGeom>
+          <a:noFill/>
+        </p:spPr>
+        <p:txBody>
+          <a:bodyPr wrap="square" rtlCol="0">
+            <a:spAutoFit/>
+          </a:bodyPr>
+          <a:lstStyle/>
+          <a:p>
+            <a:r>
+              <a:rPr lang="en-US" sz="4400" b="1" dirty="0">
+                <a:solidFill>
+                  <a:srgbClr val="FF0000"/>
+                </a:solidFill>
+              </a:rPr>
+              <a:t>F</a:t>
+            </a:r>
+          </a:p>
+        </p:txBody>
+      </p:sp>
+      <p:grpSp>
+        <p:nvGrpSpPr>
+          <p:cNvPr id="18" name="Grupo 17">
+            <a:extLst>
+              <a:ext uri="{FF2B5EF4-FFF2-40B4-BE49-F238E27FC236}">
+                <a16:creationId xmlns:a16="http://schemas.microsoft.com/office/drawing/2014/main" id="{695CC448-1347-3FE8-7BF3-8F618387A3B0}"/>
+              </a:ext>
+            </a:extLst>
+          </p:cNvPr>
+          <p:cNvGrpSpPr/>
+          <p:nvPr/>
+        </p:nvGrpSpPr>
+        <p:grpSpPr>
+          <a:xfrm>
+            <a:off x="6983289" y="2512539"/>
+            <a:ext cx="4662725" cy="1254083"/>
+            <a:chOff x="7661456" y="695741"/>
+            <a:chExt cx="4002164" cy="1254083"/>
+          </a:xfrm>
+        </p:grpSpPr>
+        <p:sp>
+          <p:nvSpPr>
+            <p:cNvPr id="19" name="Elipse 18">
+              <a:extLst>
+                <a:ext uri="{FF2B5EF4-FFF2-40B4-BE49-F238E27FC236}">
+                  <a16:creationId xmlns:a16="http://schemas.microsoft.com/office/drawing/2014/main" id="{37284DA1-0974-DAEF-C6EA-13A55A8051D0}"/>
+                </a:ext>
+              </a:extLst>
+            </p:cNvPr>
+            <p:cNvSpPr/>
+            <p:nvPr/>
+          </p:nvSpPr>
+          <p:spPr>
+            <a:xfrm>
+              <a:off x="7661457" y="991441"/>
+              <a:ext cx="3984558" cy="958383"/>
+            </a:xfrm>
+            <a:prstGeom prst="ellipse">
+              <a:avLst/>
+            </a:prstGeom>
+            <a:solidFill>
+              <a:srgbClr val="CAD7EE"/>
+            </a:solidFill>
+            <a:ln w="38100"/>
+          </p:spPr>
+          <p:style>
+            <a:lnRef idx="2">
+              <a:schemeClr val="accent1">
+                <a:shade val="15000"/>
+              </a:schemeClr>
+            </a:lnRef>
+            <a:fillRef idx="1">
+              <a:schemeClr val="accent1"/>
+            </a:fillRef>
+            <a:effectRef idx="0">
+              <a:schemeClr val="accent1"/>
+            </a:effectRef>
+            <a:fontRef idx="minor">
+              <a:schemeClr val="lt1"/>
+            </a:fontRef>
+          </p:style>
+          <p:txBody>
+            <a:bodyPr rtlCol="0" anchor="ctr"/>
+            <a:lstStyle/>
+            <a:p>
+              <a:pPr algn="ctr"/>
+              <a:endParaRPr lang="en-US"/>
+            </a:p>
+          </p:txBody>
+        </p:sp>
+        <p:sp>
+          <p:nvSpPr>
+            <p:cNvPr id="20" name="CuadroTexto 19">
+              <a:extLst>
+                <a:ext uri="{FF2B5EF4-FFF2-40B4-BE49-F238E27FC236}">
+                  <a16:creationId xmlns:a16="http://schemas.microsoft.com/office/drawing/2014/main" id="{91997FA1-46A2-5CBE-6F68-358AA0524D64}"/>
+                </a:ext>
+              </a:extLst>
+            </p:cNvPr>
+            <p:cNvSpPr txBox="1"/>
+            <p:nvPr/>
+          </p:nvSpPr>
+          <p:spPr>
+            <a:xfrm>
+              <a:off x="7661456" y="1276957"/>
+              <a:ext cx="4002164" cy="369332"/>
+            </a:xfrm>
+            <a:prstGeom prst="rect">
+              <a:avLst/>
+            </a:prstGeom>
+            <a:noFill/>
+          </p:spPr>
+          <p:txBody>
+            <a:bodyPr wrap="square" rtlCol="0">
+              <a:spAutoFit/>
+            </a:bodyPr>
+            <a:lstStyle/>
+            <a:p>
+              <a:pPr algn="ctr"/>
+              <a:r>
+                <a:rPr lang="en-US" dirty="0"/>
+                <a:t>is </a:t>
+              </a:r>
+              <a:r>
+                <a:rPr lang="en-US" b="1" dirty="0">
+                  <a:solidFill>
+                    <a:srgbClr val="B400B8"/>
+                  </a:solidFill>
+                </a:rPr>
+                <a:t>number</a:t>
+              </a:r>
+              <a:r>
+                <a:rPr lang="en-US" dirty="0"/>
+                <a:t> in </a:t>
+              </a:r>
+              <a:r>
+                <a:rPr lang="en-US" b="1" dirty="0">
+                  <a:solidFill>
+                    <a:srgbClr val="D3934D"/>
+                  </a:solidFill>
+                </a:rPr>
+                <a:t>numbers</a:t>
+              </a:r>
+              <a:r>
+                <a:rPr lang="en-US" dirty="0"/>
+                <a:t>?</a:t>
+              </a:r>
+            </a:p>
+          </p:txBody>
+        </p:sp>
+        <p:sp>
+          <p:nvSpPr>
+            <p:cNvPr id="21" name="CuadroTexto 20">
+              <a:extLst>
+                <a:ext uri="{FF2B5EF4-FFF2-40B4-BE49-F238E27FC236}">
+                  <a16:creationId xmlns:a16="http://schemas.microsoft.com/office/drawing/2014/main" id="{561EF48D-2EDC-BC5C-885B-CB06F2A2E080}"/>
+                </a:ext>
+              </a:extLst>
+            </p:cNvPr>
+            <p:cNvSpPr txBox="1"/>
+            <p:nvPr/>
+          </p:nvSpPr>
+          <p:spPr>
+            <a:xfrm>
+              <a:off x="7896781" y="695741"/>
+              <a:ext cx="847164" cy="369332"/>
+            </a:xfrm>
+            <a:prstGeom prst="rect">
+              <a:avLst/>
+            </a:prstGeom>
+            <a:noFill/>
+          </p:spPr>
+          <p:txBody>
+            <a:bodyPr wrap="square" rtlCol="0">
+              <a:spAutoFit/>
+            </a:bodyPr>
+            <a:lstStyle/>
+            <a:p>
+              <a:r>
+                <a:rPr lang="en-US" dirty="0"/>
+                <a:t>Ln 2</a:t>
+              </a:r>
+            </a:p>
+          </p:txBody>
+        </p:sp>
+      </p:grpSp>
     </p:spTree>
     <p:extLst>
       <p:ext uri="{BB962C8B-B14F-4D97-AF65-F5344CB8AC3E}">
         <p14:creationId xmlns:p14="http://schemas.microsoft.com/office/powerpoint/2010/main" val="4045309264"/>
+      </p:ext>
+    </p:extLst>
+  </p:cSld>
+  <p:clrMapOvr>
+    <a:masterClrMapping/>
+  </p:clrMapOvr>
+</p:sld>
+</file>
+
+<file path=ppt/slides/slide13.xml><?xml version="1.0" encoding="utf-8"?>
+<p:sld xmlns:a="http://schemas.openxmlformats.org/drawingml/2006/main" xmlns:r="http://schemas.openxmlformats.org/officeDocument/2006/relationships" xmlns:p="http://schemas.openxmlformats.org/presentationml/2006/main">
+  <p:cSld>
+    <p:spTree>
+      <p:nvGrpSpPr>
+        <p:cNvPr id="1" name="">
+          <a:extLst>
+            <a:ext uri="{FF2B5EF4-FFF2-40B4-BE49-F238E27FC236}">
+              <a16:creationId xmlns:a16="http://schemas.microsoft.com/office/drawing/2014/main" id="{343E5875-45E6-41B1-6555-68839D5BF6FA}"/>
+            </a:ext>
+          </a:extLst>
+        </p:cNvPr>
+        <p:cNvGrpSpPr/>
+        <p:nvPr/>
+      </p:nvGrpSpPr>
+      <p:grpSpPr>
+        <a:xfrm>
+          <a:off x="0" y="0"/>
+          <a:ext cx="0" cy="0"/>
+          <a:chOff x="0" y="0"/>
+          <a:chExt cx="0" cy="0"/>
+        </a:xfrm>
+      </p:grpSpPr>
+      <p:sp>
+        <p:nvSpPr>
+          <p:cNvPr id="2" name="Título 1">
+            <a:extLst>
+              <a:ext uri="{FF2B5EF4-FFF2-40B4-BE49-F238E27FC236}">
+                <a16:creationId xmlns:a16="http://schemas.microsoft.com/office/drawing/2014/main" id="{5542DC75-D4A3-19E9-89A3-CBE6652769FF}"/>
+              </a:ext>
+            </a:extLst>
+          </p:cNvPr>
+          <p:cNvSpPr>
+            <a:spLocks noGrp="1"/>
+          </p:cNvSpPr>
+          <p:nvPr>
+            <p:ph type="title"/>
+          </p:nvPr>
+        </p:nvSpPr>
+        <p:spPr>
+          <a:xfrm>
+            <a:off x="129860" y="365125"/>
+            <a:ext cx="6866419" cy="1325563"/>
+          </a:xfrm>
+        </p:spPr>
+        <p:txBody>
+          <a:bodyPr/>
+          <a:lstStyle/>
+          <a:p>
+            <a:r>
+              <a:rPr lang="es-AR" b="1" dirty="0" err="1">
+                <a:latin typeface="Consolas" panose="020B0609020204030204" pitchFamily="49" charset="0"/>
+                <a:cs typeface="Cascadia Code SemiBold" panose="020B0609020000020004" pitchFamily="49" charset="0"/>
+              </a:rPr>
+              <a:t>For</a:t>
+            </a:r>
+            <a:r>
+              <a:rPr lang="es-AR" b="1" dirty="0">
+                <a:latin typeface="Consolas" panose="020B0609020204030204" pitchFamily="49" charset="0"/>
+                <a:cs typeface="Cascadia Code SemiBold" panose="020B0609020000020004" pitchFamily="49" charset="0"/>
+              </a:rPr>
+              <a:t> i in </a:t>
+            </a:r>
+            <a:r>
+              <a:rPr lang="es-AR" b="1" dirty="0" err="1">
+                <a:latin typeface="Consolas" panose="020B0609020204030204" pitchFamily="49" charset="0"/>
+                <a:cs typeface="Cascadia Code SemiBold" panose="020B0609020000020004" pitchFamily="49" charset="0"/>
+              </a:rPr>
+              <a:t>range</a:t>
+            </a:r>
+            <a:r>
+              <a:rPr lang="es-AR" b="1" dirty="0">
+                <a:latin typeface="Consolas" panose="020B0609020204030204" pitchFamily="49" charset="0"/>
+                <a:cs typeface="Cascadia Code SemiBold" panose="020B0609020000020004" pitchFamily="49" charset="0"/>
+              </a:rPr>
+              <a:t>(_, _)</a:t>
+            </a:r>
+            <a:br>
+              <a:rPr lang="es-AR" dirty="0"/>
+            </a:br>
+            <a:r>
+              <a:rPr lang="es-AR" i="1" dirty="0">
+                <a:solidFill>
+                  <a:schemeClr val="bg2">
+                    <a:lumMod val="50000"/>
+                  </a:schemeClr>
+                </a:solidFill>
+              </a:rPr>
+              <a:t>(</a:t>
+            </a:r>
+            <a:r>
+              <a:rPr lang="es-AR" i="1" dirty="0" err="1">
+                <a:solidFill>
+                  <a:schemeClr val="bg2">
+                    <a:lumMod val="50000"/>
+                  </a:schemeClr>
+                </a:solidFill>
+              </a:rPr>
+              <a:t>loop</a:t>
+            </a:r>
+            <a:r>
+              <a:rPr lang="es-AR" i="1" dirty="0">
+                <a:solidFill>
+                  <a:schemeClr val="bg2">
+                    <a:lumMod val="50000"/>
+                  </a:schemeClr>
+                </a:solidFill>
+              </a:rPr>
+              <a:t>)</a:t>
+            </a:r>
+            <a:r>
+              <a:rPr lang="es-AR" dirty="0"/>
+              <a:t> </a:t>
+            </a:r>
+            <a:endParaRPr lang="en-US" dirty="0"/>
+          </a:p>
+        </p:txBody>
+      </p:sp>
+      <p:pic>
+        <p:nvPicPr>
+          <p:cNvPr id="3" name="Imagen 2">
+            <a:extLst>
+              <a:ext uri="{FF2B5EF4-FFF2-40B4-BE49-F238E27FC236}">
+                <a16:creationId xmlns:a16="http://schemas.microsoft.com/office/drawing/2014/main" id="{C92307BD-E02F-DF58-1B3D-D4AFC4023267}"/>
+              </a:ext>
+            </a:extLst>
+          </p:cNvPr>
+          <p:cNvPicPr>
+            <a:picLocks noChangeAspect="1"/>
+          </p:cNvPicPr>
+          <p:nvPr/>
+        </p:nvPicPr>
+        <p:blipFill>
+          <a:blip r:embed="rId2">
+            <a:extLst>
+              <a:ext uri="{28A0092B-C50C-407E-A947-70E740481C1C}">
+                <a14:useLocalDpi xmlns:a14="http://schemas.microsoft.com/office/drawing/2010/main" val="0"/>
+              </a:ext>
+            </a:extLst>
+          </a:blip>
+          <a:stretch>
+            <a:fillRect/>
+          </a:stretch>
+        </p:blipFill>
+        <p:spPr>
+          <a:xfrm>
+            <a:off x="10765173" y="3428999"/>
+            <a:ext cx="1177254" cy="2261919"/>
+          </a:xfrm>
+          <a:prstGeom prst="rect">
+            <a:avLst/>
+          </a:prstGeom>
+        </p:spPr>
+      </p:pic>
+      <p:sp>
+        <p:nvSpPr>
+          <p:cNvPr id="7" name="CuadroTexto 6">
+            <a:extLst>
+              <a:ext uri="{FF2B5EF4-FFF2-40B4-BE49-F238E27FC236}">
+                <a16:creationId xmlns:a16="http://schemas.microsoft.com/office/drawing/2014/main" id="{C338EABA-F96A-CDD7-7D24-EDEAA2138DB5}"/>
+              </a:ext>
+            </a:extLst>
+          </p:cNvPr>
+          <p:cNvSpPr txBox="1"/>
+          <p:nvPr/>
+        </p:nvSpPr>
+        <p:spPr>
+          <a:xfrm>
+            <a:off x="7695075" y="5034795"/>
+            <a:ext cx="847164" cy="369332"/>
+          </a:xfrm>
+          <a:prstGeom prst="rect">
+            <a:avLst/>
+          </a:prstGeom>
+          <a:noFill/>
+        </p:spPr>
+        <p:txBody>
+          <a:bodyPr wrap="square" rtlCol="0">
+            <a:spAutoFit/>
+          </a:bodyPr>
+          <a:lstStyle/>
+          <a:p>
+            <a:r>
+              <a:rPr lang="en-US" dirty="0"/>
+              <a:t>Ln 5</a:t>
+            </a:r>
+          </a:p>
+        </p:txBody>
+      </p:sp>
+      <p:sp>
+        <p:nvSpPr>
+          <p:cNvPr id="8" name="Elipse 7">
+            <a:extLst>
+              <a:ext uri="{FF2B5EF4-FFF2-40B4-BE49-F238E27FC236}">
+                <a16:creationId xmlns:a16="http://schemas.microsoft.com/office/drawing/2014/main" id="{04D91BC4-D09B-C867-C553-847F1C63280E}"/>
+              </a:ext>
+            </a:extLst>
+          </p:cNvPr>
+          <p:cNvSpPr/>
+          <p:nvPr/>
+        </p:nvSpPr>
+        <p:spPr>
+          <a:xfrm>
+            <a:off x="7695075" y="5256864"/>
+            <a:ext cx="2743200" cy="958383"/>
+          </a:xfrm>
+          <a:prstGeom prst="ellipse">
+            <a:avLst/>
+          </a:prstGeom>
+          <a:solidFill>
+            <a:srgbClr val="CAD7EE"/>
+          </a:solidFill>
+          <a:ln w="38100"/>
+        </p:spPr>
+        <p:style>
+          <a:lnRef idx="2">
+            <a:schemeClr val="accent1">
+              <a:shade val="15000"/>
+            </a:schemeClr>
+          </a:lnRef>
+          <a:fillRef idx="1">
+            <a:schemeClr val="accent1"/>
+          </a:fillRef>
+          <a:effectRef idx="0">
+            <a:schemeClr val="accent1"/>
+          </a:effectRef>
+          <a:fontRef idx="minor">
+            <a:schemeClr val="lt1"/>
+          </a:fontRef>
+        </p:style>
+        <p:txBody>
+          <a:bodyPr rtlCol="0" anchor="ctr"/>
+          <a:lstStyle/>
+          <a:p>
+            <a:pPr algn="ctr"/>
+            <a:endParaRPr lang="en-US"/>
+          </a:p>
+        </p:txBody>
+      </p:sp>
+      <p:sp>
+        <p:nvSpPr>
+          <p:cNvPr id="9" name="CuadroTexto 8">
+            <a:extLst>
+              <a:ext uri="{FF2B5EF4-FFF2-40B4-BE49-F238E27FC236}">
+                <a16:creationId xmlns:a16="http://schemas.microsoft.com/office/drawing/2014/main" id="{256D7C43-3D48-0AC7-D7E6-79E9F1DA8556}"/>
+              </a:ext>
+            </a:extLst>
+          </p:cNvPr>
+          <p:cNvSpPr txBox="1"/>
+          <p:nvPr/>
+        </p:nvSpPr>
+        <p:spPr>
+          <a:xfrm>
+            <a:off x="7793088" y="5551389"/>
+            <a:ext cx="2743200" cy="369332"/>
+          </a:xfrm>
+          <a:prstGeom prst="rect">
+            <a:avLst/>
+          </a:prstGeom>
+          <a:noFill/>
+        </p:spPr>
+        <p:txBody>
+          <a:bodyPr wrap="square" rtlCol="0">
+            <a:spAutoFit/>
+          </a:bodyPr>
+          <a:lstStyle/>
+          <a:p>
+            <a:r>
+              <a:rPr lang="en-US" dirty="0"/>
+              <a:t>print(</a:t>
+            </a:r>
+            <a:r>
+              <a:rPr lang="en-US" dirty="0" err="1"/>
+              <a:t>full_names</a:t>
+            </a:r>
+            <a:r>
+              <a:rPr lang="en-US" dirty="0"/>
+              <a:t>)</a:t>
+            </a:r>
+          </a:p>
+        </p:txBody>
+      </p:sp>
+      <p:grpSp>
+        <p:nvGrpSpPr>
+          <p:cNvPr id="17" name="Grupo 16">
+            <a:extLst>
+              <a:ext uri="{FF2B5EF4-FFF2-40B4-BE49-F238E27FC236}">
+                <a16:creationId xmlns:a16="http://schemas.microsoft.com/office/drawing/2014/main" id="{9AAA08FD-C85A-62BA-96BB-CFD08F872AAF}"/>
+              </a:ext>
+            </a:extLst>
+          </p:cNvPr>
+          <p:cNvGrpSpPr/>
+          <p:nvPr/>
+        </p:nvGrpSpPr>
+        <p:grpSpPr>
+          <a:xfrm>
+            <a:off x="6996279" y="38921"/>
+            <a:ext cx="5298410" cy="1254083"/>
+            <a:chOff x="7661457" y="695741"/>
+            <a:chExt cx="4543293" cy="1254083"/>
+          </a:xfrm>
+        </p:grpSpPr>
+        <p:sp>
+          <p:nvSpPr>
+            <p:cNvPr id="5" name="Elipse 4">
+              <a:extLst>
+                <a:ext uri="{FF2B5EF4-FFF2-40B4-BE49-F238E27FC236}">
+                  <a16:creationId xmlns:a16="http://schemas.microsoft.com/office/drawing/2014/main" id="{6B849390-1EF5-CFD2-0821-D007DC9109AC}"/>
+                </a:ext>
+              </a:extLst>
+            </p:cNvPr>
+            <p:cNvSpPr/>
+            <p:nvPr/>
+          </p:nvSpPr>
+          <p:spPr>
+            <a:xfrm>
+              <a:off x="7661457" y="991441"/>
+              <a:ext cx="3984558" cy="958383"/>
+            </a:xfrm>
+            <a:prstGeom prst="ellipse">
+              <a:avLst/>
+            </a:prstGeom>
+            <a:solidFill>
+              <a:srgbClr val="CAD7EE"/>
+            </a:solidFill>
+            <a:ln w="38100"/>
+          </p:spPr>
+          <p:style>
+            <a:lnRef idx="2">
+              <a:schemeClr val="accent1">
+                <a:shade val="15000"/>
+              </a:schemeClr>
+            </a:lnRef>
+            <a:fillRef idx="1">
+              <a:schemeClr val="accent1"/>
+            </a:fillRef>
+            <a:effectRef idx="0">
+              <a:schemeClr val="accent1"/>
+            </a:effectRef>
+            <a:fontRef idx="minor">
+              <a:schemeClr val="lt1"/>
+            </a:fontRef>
+          </p:style>
+          <p:txBody>
+            <a:bodyPr rtlCol="0" anchor="ctr"/>
+            <a:lstStyle/>
+            <a:p>
+              <a:pPr algn="ctr"/>
+              <a:endParaRPr lang="en-US"/>
+            </a:p>
+          </p:txBody>
+        </p:sp>
+        <p:sp>
+          <p:nvSpPr>
+            <p:cNvPr id="6" name="CuadroTexto 5">
+              <a:extLst>
+                <a:ext uri="{FF2B5EF4-FFF2-40B4-BE49-F238E27FC236}">
+                  <a16:creationId xmlns:a16="http://schemas.microsoft.com/office/drawing/2014/main" id="{13FC5B7E-BC21-6676-3B11-A0FC475EB18C}"/>
+                </a:ext>
+              </a:extLst>
+            </p:cNvPr>
+            <p:cNvSpPr txBox="1"/>
+            <p:nvPr/>
+          </p:nvSpPr>
+          <p:spPr>
+            <a:xfrm>
+              <a:off x="7758234" y="1276957"/>
+              <a:ext cx="4446516" cy="369332"/>
+            </a:xfrm>
+            <a:prstGeom prst="rect">
+              <a:avLst/>
+            </a:prstGeom>
+            <a:noFill/>
+          </p:spPr>
+          <p:txBody>
+            <a:bodyPr wrap="square" rtlCol="0">
+              <a:spAutoFit/>
+            </a:bodyPr>
+            <a:lstStyle/>
+            <a:p>
+              <a:r>
+                <a:rPr lang="en-US" dirty="0"/>
+                <a:t>names = [“Lionel </a:t>
+              </a:r>
+              <a:r>
+                <a:rPr lang="es-AR" dirty="0"/>
+                <a:t>”</a:t>
+              </a:r>
+              <a:r>
+                <a:rPr lang="en-US" dirty="0"/>
+                <a:t>, “Juli</a:t>
+              </a:r>
+              <a:r>
+                <a:rPr lang="es-AR" dirty="0" err="1"/>
+                <a:t>án</a:t>
+              </a:r>
+              <a:r>
+                <a:rPr lang="es-AR" dirty="0"/>
+                <a:t> ”, “Ángel ”, “</a:t>
+              </a:r>
+              <a:r>
+                <a:rPr lang="es-AR" dirty="0" err="1"/>
+                <a:t>Dibu</a:t>
+              </a:r>
+              <a:r>
+                <a:rPr lang="es-AR" dirty="0"/>
+                <a:t> “</a:t>
+              </a:r>
+              <a:r>
+                <a:rPr lang="en-US" dirty="0"/>
+                <a:t>]</a:t>
+              </a:r>
+            </a:p>
+          </p:txBody>
+        </p:sp>
+        <p:sp>
+          <p:nvSpPr>
+            <p:cNvPr id="10" name="CuadroTexto 9">
+              <a:extLst>
+                <a:ext uri="{FF2B5EF4-FFF2-40B4-BE49-F238E27FC236}">
+                  <a16:creationId xmlns:a16="http://schemas.microsoft.com/office/drawing/2014/main" id="{5B48E52D-9EBA-7315-C8BE-F4E2085B269B}"/>
+                </a:ext>
+              </a:extLst>
+            </p:cNvPr>
+            <p:cNvSpPr txBox="1"/>
+            <p:nvPr/>
+          </p:nvSpPr>
+          <p:spPr>
+            <a:xfrm>
+              <a:off x="7896781" y="695741"/>
+              <a:ext cx="847164" cy="369332"/>
+            </a:xfrm>
+            <a:prstGeom prst="rect">
+              <a:avLst/>
+            </a:prstGeom>
+            <a:noFill/>
+          </p:spPr>
+          <p:txBody>
+            <a:bodyPr wrap="square" rtlCol="0">
+              <a:spAutoFit/>
+            </a:bodyPr>
+            <a:lstStyle/>
+            <a:p>
+              <a:r>
+                <a:rPr lang="en-US" dirty="0"/>
+                <a:t>Ln 1</a:t>
+              </a:r>
+            </a:p>
+          </p:txBody>
+        </p:sp>
+      </p:grpSp>
+      <p:grpSp>
+        <p:nvGrpSpPr>
+          <p:cNvPr id="11" name="Grupo 10">
+            <a:extLst>
+              <a:ext uri="{FF2B5EF4-FFF2-40B4-BE49-F238E27FC236}">
+                <a16:creationId xmlns:a16="http://schemas.microsoft.com/office/drawing/2014/main" id="{46A74406-B3C4-11E3-1839-46997C9D4CE2}"/>
+              </a:ext>
+            </a:extLst>
+          </p:cNvPr>
+          <p:cNvGrpSpPr/>
+          <p:nvPr/>
+        </p:nvGrpSpPr>
+        <p:grpSpPr>
+          <a:xfrm rot="1017173">
+            <a:off x="5372715" y="2382051"/>
+            <a:ext cx="2337358" cy="2087943"/>
+            <a:chOff x="4312494" y="1392221"/>
+            <a:chExt cx="2564824" cy="2291137"/>
+          </a:xfrm>
+        </p:grpSpPr>
+        <p:sp>
+          <p:nvSpPr>
+            <p:cNvPr id="12" name="Forma libre: forma 11">
+              <a:extLst>
+                <a:ext uri="{FF2B5EF4-FFF2-40B4-BE49-F238E27FC236}">
+                  <a16:creationId xmlns:a16="http://schemas.microsoft.com/office/drawing/2014/main" id="{F76333DC-E137-1DC4-2CFE-263016F51ECC}"/>
+                </a:ext>
+              </a:extLst>
+            </p:cNvPr>
+            <p:cNvSpPr/>
+            <p:nvPr/>
+          </p:nvSpPr>
+          <p:spPr>
+            <a:xfrm>
+              <a:off x="4312494" y="1532583"/>
+              <a:ext cx="2564824" cy="2150775"/>
+            </a:xfrm>
+            <a:custGeom>
+              <a:avLst/>
+              <a:gdLst>
+                <a:gd name="connsiteX0" fmla="*/ 2564824 w 2564824"/>
+                <a:gd name="connsiteY0" fmla="*/ 631068 h 2150775"/>
+                <a:gd name="connsiteX1" fmla="*/ 2126943 w 2564824"/>
+                <a:gd name="connsiteY1" fmla="*/ 1661378 h 2150775"/>
+                <a:gd name="connsiteX2" fmla="*/ 1882244 w 2564824"/>
+                <a:gd name="connsiteY2" fmla="*/ 1841682 h 2150775"/>
+                <a:gd name="connsiteX3" fmla="*/ 1624667 w 2564824"/>
+                <a:gd name="connsiteY3" fmla="*/ 1957592 h 2150775"/>
+                <a:gd name="connsiteX4" fmla="*/ 787540 w 2564824"/>
+                <a:gd name="connsiteY4" fmla="*/ 2150775 h 2150775"/>
+                <a:gd name="connsiteX5" fmla="*/ 607236 w 2564824"/>
+                <a:gd name="connsiteY5" fmla="*/ 2137896 h 2150775"/>
+                <a:gd name="connsiteX6" fmla="*/ 414052 w 2564824"/>
+                <a:gd name="connsiteY6" fmla="*/ 2021986 h 2150775"/>
+                <a:gd name="connsiteX7" fmla="*/ 27686 w 2564824"/>
+                <a:gd name="connsiteY7" fmla="*/ 1390921 h 2150775"/>
+                <a:gd name="connsiteX8" fmla="*/ 53444 w 2564824"/>
+                <a:gd name="connsiteY8" fmla="*/ 901524 h 2150775"/>
+                <a:gd name="connsiteX9" fmla="*/ 594357 w 2564824"/>
+                <a:gd name="connsiteY9" fmla="*/ 437885 h 2150775"/>
+                <a:gd name="connsiteX10" fmla="*/ 736024 w 2564824"/>
+                <a:gd name="connsiteY10" fmla="*/ 347732 h 2150775"/>
+                <a:gd name="connsiteX11" fmla="*/ 877692 w 2564824"/>
+                <a:gd name="connsiteY11" fmla="*/ 270459 h 2150775"/>
+                <a:gd name="connsiteX12" fmla="*/ 1238300 w 2564824"/>
+                <a:gd name="connsiteY12" fmla="*/ 128792 h 2150775"/>
+                <a:gd name="connsiteX13" fmla="*/ 1367089 w 2564824"/>
+                <a:gd name="connsiteY13" fmla="*/ 25761 h 2150775"/>
+                <a:gd name="connsiteX14" fmla="*/ 1444362 w 2564824"/>
+                <a:gd name="connsiteY14" fmla="*/ 12882 h 2150775"/>
+                <a:gd name="connsiteX15" fmla="*/ 1663303 w 2564824"/>
+                <a:gd name="connsiteY15" fmla="*/ 3 h 2150775"/>
+              </a:gdLst>
+              <a:ahLst/>
+              <a:cxnLst>
+                <a:cxn ang="0">
+                  <a:pos x="connsiteX0" y="connsiteY0"/>
+                </a:cxn>
+                <a:cxn ang="0">
+                  <a:pos x="connsiteX1" y="connsiteY1"/>
+                </a:cxn>
+                <a:cxn ang="0">
+                  <a:pos x="connsiteX2" y="connsiteY2"/>
+                </a:cxn>
+                <a:cxn ang="0">
+                  <a:pos x="connsiteX3" y="connsiteY3"/>
+                </a:cxn>
+                <a:cxn ang="0">
+                  <a:pos x="connsiteX4" y="connsiteY4"/>
+                </a:cxn>
+                <a:cxn ang="0">
+                  <a:pos x="connsiteX5" y="connsiteY5"/>
+                </a:cxn>
+                <a:cxn ang="0">
+                  <a:pos x="connsiteX6" y="connsiteY6"/>
+                </a:cxn>
+                <a:cxn ang="0">
+                  <a:pos x="connsiteX7" y="connsiteY7"/>
+                </a:cxn>
+                <a:cxn ang="0">
+                  <a:pos x="connsiteX8" y="connsiteY8"/>
+                </a:cxn>
+                <a:cxn ang="0">
+                  <a:pos x="connsiteX9" y="connsiteY9"/>
+                </a:cxn>
+                <a:cxn ang="0">
+                  <a:pos x="connsiteX10" y="connsiteY10"/>
+                </a:cxn>
+                <a:cxn ang="0">
+                  <a:pos x="connsiteX11" y="connsiteY11"/>
+                </a:cxn>
+                <a:cxn ang="0">
+                  <a:pos x="connsiteX12" y="connsiteY12"/>
+                </a:cxn>
+                <a:cxn ang="0">
+                  <a:pos x="connsiteX13" y="connsiteY13"/>
+                </a:cxn>
+                <a:cxn ang="0">
+                  <a:pos x="connsiteX14" y="connsiteY14"/>
+                </a:cxn>
+                <a:cxn ang="0">
+                  <a:pos x="connsiteX15" y="connsiteY15"/>
+                </a:cxn>
+              </a:cxnLst>
+              <a:rect l="l" t="t" r="r" b="b"/>
+              <a:pathLst>
+                <a:path w="2564824" h="2150775">
+                  <a:moveTo>
+                    <a:pt x="2564824" y="631068"/>
+                  </a:moveTo>
+                  <a:cubicBezTo>
+                    <a:pt x="2417431" y="1114191"/>
+                    <a:pt x="2443202" y="1345119"/>
+                    <a:pt x="2126943" y="1661378"/>
+                  </a:cubicBezTo>
+                  <a:cubicBezTo>
+                    <a:pt x="2055301" y="1733020"/>
+                    <a:pt x="1969515" y="1790214"/>
+                    <a:pt x="1882244" y="1841682"/>
+                  </a:cubicBezTo>
+                  <a:cubicBezTo>
+                    <a:pt x="1801145" y="1889510"/>
+                    <a:pt x="1715276" y="1932008"/>
+                    <a:pt x="1624667" y="1957592"/>
+                  </a:cubicBezTo>
+                  <a:cubicBezTo>
+                    <a:pt x="1349066" y="2035409"/>
+                    <a:pt x="787540" y="2150775"/>
+                    <a:pt x="787540" y="2150775"/>
+                  </a:cubicBezTo>
+                  <a:cubicBezTo>
+                    <a:pt x="727439" y="2146482"/>
+                    <a:pt x="664199" y="2157538"/>
+                    <a:pt x="607236" y="2137896"/>
+                  </a:cubicBezTo>
+                  <a:cubicBezTo>
+                    <a:pt x="536242" y="2113415"/>
+                    <a:pt x="466378" y="2075851"/>
+                    <a:pt x="414052" y="2021986"/>
+                  </a:cubicBezTo>
+                  <a:cubicBezTo>
+                    <a:pt x="203552" y="1805295"/>
+                    <a:pt x="150799" y="1648339"/>
+                    <a:pt x="27686" y="1390921"/>
+                  </a:cubicBezTo>
+                  <a:cubicBezTo>
+                    <a:pt x="11956" y="1257210"/>
+                    <a:pt x="-37734" y="1023895"/>
+                    <a:pt x="53444" y="901524"/>
+                  </a:cubicBezTo>
+                  <a:cubicBezTo>
+                    <a:pt x="77699" y="868972"/>
+                    <a:pt x="433922" y="547657"/>
+                    <a:pt x="594357" y="437885"/>
+                  </a:cubicBezTo>
+                  <a:cubicBezTo>
+                    <a:pt x="640552" y="406278"/>
+                    <a:pt x="687835" y="376207"/>
+                    <a:pt x="736024" y="347732"/>
+                  </a:cubicBezTo>
+                  <a:cubicBezTo>
+                    <a:pt x="782334" y="320367"/>
+                    <a:pt x="828382" y="291953"/>
+                    <a:pt x="877692" y="270459"/>
+                  </a:cubicBezTo>
+                  <a:cubicBezTo>
+                    <a:pt x="996079" y="218854"/>
+                    <a:pt x="1238300" y="128792"/>
+                    <a:pt x="1238300" y="128792"/>
+                  </a:cubicBezTo>
+                  <a:cubicBezTo>
+                    <a:pt x="1281230" y="94448"/>
+                    <a:pt x="1319173" y="52714"/>
+                    <a:pt x="1367089" y="25761"/>
+                  </a:cubicBezTo>
+                  <a:cubicBezTo>
+                    <a:pt x="1389848" y="12959"/>
+                    <a:pt x="1418367" y="15358"/>
+                    <a:pt x="1444362" y="12882"/>
+                  </a:cubicBezTo>
+                  <a:cubicBezTo>
+                    <a:pt x="1585587" y="-568"/>
+                    <a:pt x="1581060" y="3"/>
+                    <a:pt x="1663303" y="3"/>
+                  </a:cubicBezTo>
+                </a:path>
+              </a:pathLst>
+            </a:custGeom>
+            <a:noFill/>
+            <a:ln w="57150">
+              <a:solidFill>
+                <a:srgbClr val="791179"/>
+              </a:solidFill>
+            </a:ln>
+          </p:spPr>
+          <p:style>
+            <a:lnRef idx="2">
+              <a:schemeClr val="accent1">
+                <a:shade val="15000"/>
+              </a:schemeClr>
+            </a:lnRef>
+            <a:fillRef idx="1">
+              <a:schemeClr val="accent1"/>
+            </a:fillRef>
+            <a:effectRef idx="0">
+              <a:schemeClr val="accent1"/>
+            </a:effectRef>
+            <a:fontRef idx="minor">
+              <a:schemeClr val="lt1"/>
+            </a:fontRef>
+          </p:style>
+          <p:txBody>
+            <a:bodyPr rtlCol="0" anchor="ctr"/>
+            <a:lstStyle/>
+            <a:p>
+              <a:pPr algn="ctr"/>
+              <a:endParaRPr lang="en-US">
+                <a:solidFill>
+                  <a:srgbClr val="791179"/>
+                </a:solidFill>
+              </a:endParaRPr>
+            </a:p>
+          </p:txBody>
+        </p:sp>
+        <p:sp>
+          <p:nvSpPr>
+            <p:cNvPr id="13" name="Forma libre: forma 12">
+              <a:extLst>
+                <a:ext uri="{FF2B5EF4-FFF2-40B4-BE49-F238E27FC236}">
+                  <a16:creationId xmlns:a16="http://schemas.microsoft.com/office/drawing/2014/main" id="{3E13DC10-89F8-73E8-1AC8-19340731DCB1}"/>
+                </a:ext>
+              </a:extLst>
+            </p:cNvPr>
+            <p:cNvSpPr/>
+            <p:nvPr/>
+          </p:nvSpPr>
+          <p:spPr>
+            <a:xfrm rot="1067707">
+              <a:off x="5579942" y="1392221"/>
+              <a:ext cx="416126" cy="371948"/>
+            </a:xfrm>
+            <a:custGeom>
+              <a:avLst/>
+              <a:gdLst>
+                <a:gd name="connsiteX0" fmla="*/ 0 w 188119"/>
+                <a:gd name="connsiteY0" fmla="*/ 0 h 211932"/>
+                <a:gd name="connsiteX1" fmla="*/ 109537 w 188119"/>
+                <a:gd name="connsiteY1" fmla="*/ 26194 h 211932"/>
+                <a:gd name="connsiteX2" fmla="*/ 133350 w 188119"/>
+                <a:gd name="connsiteY2" fmla="*/ 38100 h 211932"/>
+                <a:gd name="connsiteX3" fmla="*/ 159544 w 188119"/>
+                <a:gd name="connsiteY3" fmla="*/ 50007 h 211932"/>
+                <a:gd name="connsiteX4" fmla="*/ 180975 w 188119"/>
+                <a:gd name="connsiteY4" fmla="*/ 54769 h 211932"/>
+                <a:gd name="connsiteX5" fmla="*/ 188119 w 188119"/>
+                <a:gd name="connsiteY5" fmla="*/ 57150 h 211932"/>
+                <a:gd name="connsiteX6" fmla="*/ 140494 w 188119"/>
+                <a:gd name="connsiteY6" fmla="*/ 121444 h 211932"/>
+                <a:gd name="connsiteX7" fmla="*/ 123825 w 188119"/>
+                <a:gd name="connsiteY7" fmla="*/ 140494 h 211932"/>
+                <a:gd name="connsiteX8" fmla="*/ 102394 w 188119"/>
+                <a:gd name="connsiteY8" fmla="*/ 150019 h 211932"/>
+                <a:gd name="connsiteX9" fmla="*/ 80962 w 188119"/>
+                <a:gd name="connsiteY9" fmla="*/ 173832 h 211932"/>
+                <a:gd name="connsiteX10" fmla="*/ 73819 w 188119"/>
+                <a:gd name="connsiteY10" fmla="*/ 180975 h 211932"/>
+                <a:gd name="connsiteX11" fmla="*/ 69056 w 188119"/>
+                <a:gd name="connsiteY11" fmla="*/ 190500 h 211932"/>
+                <a:gd name="connsiteX12" fmla="*/ 61912 w 188119"/>
+                <a:gd name="connsiteY12" fmla="*/ 202407 h 211932"/>
+                <a:gd name="connsiteX13" fmla="*/ 52387 w 188119"/>
+                <a:gd name="connsiteY13" fmla="*/ 211932 h 211932"/>
+              </a:gdLst>
+              <a:ahLst/>
+              <a:cxnLst>
+                <a:cxn ang="0">
+                  <a:pos x="connsiteX0" y="connsiteY0"/>
+                </a:cxn>
+                <a:cxn ang="0">
+                  <a:pos x="connsiteX1" y="connsiteY1"/>
+                </a:cxn>
+                <a:cxn ang="0">
+                  <a:pos x="connsiteX2" y="connsiteY2"/>
+                </a:cxn>
+                <a:cxn ang="0">
+                  <a:pos x="connsiteX3" y="connsiteY3"/>
+                </a:cxn>
+                <a:cxn ang="0">
+                  <a:pos x="connsiteX4" y="connsiteY4"/>
+                </a:cxn>
+                <a:cxn ang="0">
+                  <a:pos x="connsiteX5" y="connsiteY5"/>
+                </a:cxn>
+                <a:cxn ang="0">
+                  <a:pos x="connsiteX6" y="connsiteY6"/>
+                </a:cxn>
+                <a:cxn ang="0">
+                  <a:pos x="connsiteX7" y="connsiteY7"/>
+                </a:cxn>
+                <a:cxn ang="0">
+                  <a:pos x="connsiteX8" y="connsiteY8"/>
+                </a:cxn>
+                <a:cxn ang="0">
+                  <a:pos x="connsiteX9" y="connsiteY9"/>
+                </a:cxn>
+                <a:cxn ang="0">
+                  <a:pos x="connsiteX10" y="connsiteY10"/>
+                </a:cxn>
+                <a:cxn ang="0">
+                  <a:pos x="connsiteX11" y="connsiteY11"/>
+                </a:cxn>
+                <a:cxn ang="0">
+                  <a:pos x="connsiteX12" y="connsiteY12"/>
+                </a:cxn>
+                <a:cxn ang="0">
+                  <a:pos x="connsiteX13" y="connsiteY13"/>
+                </a:cxn>
+              </a:cxnLst>
+              <a:rect l="l" t="t" r="r" b="b"/>
+              <a:pathLst>
+                <a:path w="188119" h="211932">
+                  <a:moveTo>
+                    <a:pt x="0" y="0"/>
+                  </a:moveTo>
+                  <a:cubicBezTo>
+                    <a:pt x="59974" y="11996"/>
+                    <a:pt x="54255" y="9184"/>
+                    <a:pt x="109537" y="26194"/>
+                  </a:cubicBezTo>
+                  <a:cubicBezTo>
+                    <a:pt x="125437" y="31086"/>
+                    <a:pt x="118108" y="30479"/>
+                    <a:pt x="133350" y="38100"/>
+                  </a:cubicBezTo>
+                  <a:cubicBezTo>
+                    <a:pt x="141929" y="42389"/>
+                    <a:pt x="150639" y="46445"/>
+                    <a:pt x="159544" y="50007"/>
+                  </a:cubicBezTo>
+                  <a:cubicBezTo>
+                    <a:pt x="163616" y="51636"/>
+                    <a:pt x="177459" y="53890"/>
+                    <a:pt x="180975" y="54769"/>
+                  </a:cubicBezTo>
+                  <a:cubicBezTo>
+                    <a:pt x="183410" y="55378"/>
+                    <a:pt x="185738" y="56356"/>
+                    <a:pt x="188119" y="57150"/>
+                  </a:cubicBezTo>
+                  <a:cubicBezTo>
+                    <a:pt x="187294" y="58275"/>
+                    <a:pt x="144649" y="116696"/>
+                    <a:pt x="140494" y="121444"/>
+                  </a:cubicBezTo>
+                  <a:cubicBezTo>
+                    <a:pt x="134938" y="127794"/>
+                    <a:pt x="130575" y="135431"/>
+                    <a:pt x="123825" y="140494"/>
+                  </a:cubicBezTo>
+                  <a:cubicBezTo>
+                    <a:pt x="117571" y="145184"/>
+                    <a:pt x="109538" y="146844"/>
+                    <a:pt x="102394" y="150019"/>
+                  </a:cubicBezTo>
+                  <a:cubicBezTo>
+                    <a:pt x="76108" y="176303"/>
+                    <a:pt x="103760" y="147776"/>
+                    <a:pt x="80962" y="173832"/>
+                  </a:cubicBezTo>
+                  <a:cubicBezTo>
+                    <a:pt x="78745" y="176366"/>
+                    <a:pt x="75776" y="178235"/>
+                    <a:pt x="73819" y="180975"/>
+                  </a:cubicBezTo>
+                  <a:cubicBezTo>
+                    <a:pt x="71756" y="183864"/>
+                    <a:pt x="70780" y="187397"/>
+                    <a:pt x="69056" y="190500"/>
+                  </a:cubicBezTo>
+                  <a:cubicBezTo>
+                    <a:pt x="66808" y="194546"/>
+                    <a:pt x="64689" y="198704"/>
+                    <a:pt x="61912" y="202407"/>
+                  </a:cubicBezTo>
+                  <a:cubicBezTo>
+                    <a:pt x="59218" y="205999"/>
+                    <a:pt x="55562" y="208757"/>
+                    <a:pt x="52387" y="211932"/>
+                  </a:cubicBezTo>
+                </a:path>
+              </a:pathLst>
+            </a:custGeom>
+            <a:noFill/>
+            <a:ln w="57150">
+              <a:solidFill>
+                <a:srgbClr val="8A008A"/>
+              </a:solidFill>
+            </a:ln>
+          </p:spPr>
+          <p:style>
+            <a:lnRef idx="2">
+              <a:schemeClr val="accent1">
+                <a:shade val="15000"/>
+              </a:schemeClr>
+            </a:lnRef>
+            <a:fillRef idx="1">
+              <a:schemeClr val="accent1"/>
+            </a:fillRef>
+            <a:effectRef idx="0">
+              <a:schemeClr val="accent1"/>
+            </a:effectRef>
+            <a:fontRef idx="minor">
+              <a:schemeClr val="lt1"/>
+            </a:fontRef>
+          </p:style>
+          <p:txBody>
+            <a:bodyPr rtlCol="0" anchor="ctr"/>
+            <a:lstStyle/>
+            <a:p>
+              <a:pPr algn="ctr"/>
+              <a:endParaRPr lang="en-US">
+                <a:solidFill>
+                  <a:srgbClr val="791179"/>
+                </a:solidFill>
+              </a:endParaRPr>
+            </a:p>
+          </p:txBody>
+        </p:sp>
+      </p:grpSp>
+      <p:sp>
+        <p:nvSpPr>
+          <p:cNvPr id="14" name="CuadroTexto 13">
+            <a:extLst>
+              <a:ext uri="{FF2B5EF4-FFF2-40B4-BE49-F238E27FC236}">
+                <a16:creationId xmlns:a16="http://schemas.microsoft.com/office/drawing/2014/main" id="{1FC248E7-5A5E-40AB-BEF6-6F7DE9304C68}"/>
+              </a:ext>
+            </a:extLst>
+          </p:cNvPr>
+          <p:cNvSpPr txBox="1"/>
+          <p:nvPr/>
+        </p:nvSpPr>
+        <p:spPr>
+          <a:xfrm>
+            <a:off x="6983290" y="4105348"/>
+            <a:ext cx="361682" cy="769441"/>
+          </a:xfrm>
+          <a:prstGeom prst="rect">
+            <a:avLst/>
+          </a:prstGeom>
+          <a:noFill/>
+        </p:spPr>
+        <p:txBody>
+          <a:bodyPr wrap="square" rtlCol="0">
+            <a:spAutoFit/>
+          </a:bodyPr>
+          <a:lstStyle/>
+          <a:p>
+            <a:r>
+              <a:rPr lang="en-US" sz="4400" b="1" dirty="0">
+                <a:solidFill>
+                  <a:srgbClr val="00B050"/>
+                </a:solidFill>
+              </a:rPr>
+              <a:t>T</a:t>
+            </a:r>
+          </a:p>
+        </p:txBody>
+      </p:sp>
+      <p:sp>
+        <p:nvSpPr>
+          <p:cNvPr id="15" name="CuadroTexto 14">
+            <a:extLst>
+              <a:ext uri="{FF2B5EF4-FFF2-40B4-BE49-F238E27FC236}">
+                <a16:creationId xmlns:a16="http://schemas.microsoft.com/office/drawing/2014/main" id="{67A7B805-1F1F-2E13-F832-8CE5ECAA77BB}"/>
+              </a:ext>
+            </a:extLst>
+          </p:cNvPr>
+          <p:cNvSpPr txBox="1"/>
+          <p:nvPr/>
+        </p:nvSpPr>
+        <p:spPr>
+          <a:xfrm>
+            <a:off x="11199788" y="3877657"/>
+            <a:ext cx="583841" cy="769441"/>
+          </a:xfrm>
+          <a:prstGeom prst="rect">
+            <a:avLst/>
+          </a:prstGeom>
+          <a:noFill/>
+        </p:spPr>
+        <p:txBody>
+          <a:bodyPr wrap="square" rtlCol="0">
+            <a:spAutoFit/>
+          </a:bodyPr>
+          <a:lstStyle/>
+          <a:p>
+            <a:r>
+              <a:rPr lang="en-US" sz="4400" b="1" dirty="0">
+                <a:solidFill>
+                  <a:srgbClr val="FF0000"/>
+                </a:solidFill>
+              </a:rPr>
+              <a:t>F</a:t>
+            </a:r>
+          </a:p>
+        </p:txBody>
+      </p:sp>
+      <p:grpSp>
+        <p:nvGrpSpPr>
+          <p:cNvPr id="18" name="Grupo 17">
+            <a:extLst>
+              <a:ext uri="{FF2B5EF4-FFF2-40B4-BE49-F238E27FC236}">
+                <a16:creationId xmlns:a16="http://schemas.microsoft.com/office/drawing/2014/main" id="{20C722A5-476B-C954-EE7A-100E0535FF67}"/>
+              </a:ext>
+            </a:extLst>
+          </p:cNvPr>
+          <p:cNvGrpSpPr/>
+          <p:nvPr/>
+        </p:nvGrpSpPr>
+        <p:grpSpPr>
+          <a:xfrm>
+            <a:off x="6983290" y="2512539"/>
+            <a:ext cx="4791515" cy="1254083"/>
+            <a:chOff x="7661457" y="695741"/>
+            <a:chExt cx="4112709" cy="1254083"/>
+          </a:xfrm>
+        </p:grpSpPr>
+        <p:sp>
+          <p:nvSpPr>
+            <p:cNvPr id="19" name="Elipse 18">
+              <a:extLst>
+                <a:ext uri="{FF2B5EF4-FFF2-40B4-BE49-F238E27FC236}">
+                  <a16:creationId xmlns:a16="http://schemas.microsoft.com/office/drawing/2014/main" id="{714651A1-FBB2-B973-888A-3CDD77D8DFCD}"/>
+                </a:ext>
+              </a:extLst>
+            </p:cNvPr>
+            <p:cNvSpPr/>
+            <p:nvPr/>
+          </p:nvSpPr>
+          <p:spPr>
+            <a:xfrm>
+              <a:off x="7661457" y="991441"/>
+              <a:ext cx="3984558" cy="958383"/>
+            </a:xfrm>
+            <a:prstGeom prst="ellipse">
+              <a:avLst/>
+            </a:prstGeom>
+            <a:solidFill>
+              <a:srgbClr val="CAD7EE"/>
+            </a:solidFill>
+            <a:ln w="38100"/>
+          </p:spPr>
+          <p:style>
+            <a:lnRef idx="2">
+              <a:schemeClr val="accent1">
+                <a:shade val="15000"/>
+              </a:schemeClr>
+            </a:lnRef>
+            <a:fillRef idx="1">
+              <a:schemeClr val="accent1"/>
+            </a:fillRef>
+            <a:effectRef idx="0">
+              <a:schemeClr val="accent1"/>
+            </a:effectRef>
+            <a:fontRef idx="minor">
+              <a:schemeClr val="lt1"/>
+            </a:fontRef>
+          </p:style>
+          <p:txBody>
+            <a:bodyPr rtlCol="0" anchor="ctr"/>
+            <a:lstStyle/>
+            <a:p>
+              <a:pPr algn="ctr"/>
+              <a:endParaRPr lang="en-US"/>
+            </a:p>
+          </p:txBody>
+        </p:sp>
+        <p:sp>
+          <p:nvSpPr>
+            <p:cNvPr id="20" name="CuadroTexto 19">
+              <a:extLst>
+                <a:ext uri="{FF2B5EF4-FFF2-40B4-BE49-F238E27FC236}">
+                  <a16:creationId xmlns:a16="http://schemas.microsoft.com/office/drawing/2014/main" id="{66C4F28E-38F5-24CE-6C8C-4C0E080FCF63}"/>
+                </a:ext>
+              </a:extLst>
+            </p:cNvPr>
+            <p:cNvSpPr txBox="1"/>
+            <p:nvPr/>
+          </p:nvSpPr>
+          <p:spPr>
+            <a:xfrm>
+              <a:off x="7772002" y="1276957"/>
+              <a:ext cx="4002164" cy="369332"/>
+            </a:xfrm>
+            <a:prstGeom prst="rect">
+              <a:avLst/>
+            </a:prstGeom>
+            <a:noFill/>
+          </p:spPr>
+          <p:txBody>
+            <a:bodyPr wrap="square" rtlCol="0">
+              <a:spAutoFit/>
+            </a:bodyPr>
+            <a:lstStyle/>
+            <a:p>
+              <a:r>
+                <a:rPr lang="en-US" dirty="0"/>
+                <a:t>surnames = [“Messi”, “Juli</a:t>
+              </a:r>
+              <a:r>
+                <a:rPr lang="es-AR" dirty="0" err="1"/>
+                <a:t>án</a:t>
+              </a:r>
+              <a:r>
+                <a:rPr lang="es-AR" dirty="0"/>
+                <a:t>”, “Ángel”, “</a:t>
+              </a:r>
+              <a:r>
+                <a:rPr lang="es-AR" dirty="0" err="1"/>
+                <a:t>Dibu</a:t>
+              </a:r>
+              <a:r>
+                <a:rPr lang="es-AR" dirty="0"/>
+                <a:t>”</a:t>
+              </a:r>
+              <a:r>
+                <a:rPr lang="en-US" dirty="0"/>
+                <a:t>]</a:t>
+              </a:r>
+            </a:p>
+          </p:txBody>
+        </p:sp>
+        <p:sp>
+          <p:nvSpPr>
+            <p:cNvPr id="21" name="CuadroTexto 20">
+              <a:extLst>
+                <a:ext uri="{FF2B5EF4-FFF2-40B4-BE49-F238E27FC236}">
+                  <a16:creationId xmlns:a16="http://schemas.microsoft.com/office/drawing/2014/main" id="{2297C3B6-0BED-B466-A712-0BEB0F65EAFB}"/>
+                </a:ext>
+              </a:extLst>
+            </p:cNvPr>
+            <p:cNvSpPr txBox="1"/>
+            <p:nvPr/>
+          </p:nvSpPr>
+          <p:spPr>
+            <a:xfrm>
+              <a:off x="7896781" y="695741"/>
+              <a:ext cx="847164" cy="369332"/>
+            </a:xfrm>
+            <a:prstGeom prst="rect">
+              <a:avLst/>
+            </a:prstGeom>
+            <a:noFill/>
+          </p:spPr>
+          <p:txBody>
+            <a:bodyPr wrap="square" rtlCol="0">
+              <a:spAutoFit/>
+            </a:bodyPr>
+            <a:lstStyle/>
+            <a:p>
+              <a:r>
+                <a:rPr lang="en-US" dirty="0"/>
+                <a:t>Ln 2</a:t>
+              </a:r>
+            </a:p>
+          </p:txBody>
+        </p:sp>
+      </p:grpSp>
+      <p:sp>
+        <p:nvSpPr>
+          <p:cNvPr id="16" name="Forma libre: forma 15">
+            <a:extLst>
+              <a:ext uri="{FF2B5EF4-FFF2-40B4-BE49-F238E27FC236}">
+                <a16:creationId xmlns:a16="http://schemas.microsoft.com/office/drawing/2014/main" id="{1304784F-B88B-E77F-7EEF-645BD56285B1}"/>
+              </a:ext>
+            </a:extLst>
+          </p:cNvPr>
+          <p:cNvSpPr/>
+          <p:nvPr/>
+        </p:nvSpPr>
+        <p:spPr>
+          <a:xfrm>
+            <a:off x="319303" y="1826482"/>
+            <a:ext cx="891890" cy="2110778"/>
+          </a:xfrm>
+          <a:custGeom>
+            <a:avLst/>
+            <a:gdLst>
+              <a:gd name="connsiteX0" fmla="*/ 1268696 w 1907325"/>
+              <a:gd name="connsiteY0" fmla="*/ 0 h 4513942"/>
+              <a:gd name="connsiteX1" fmla="*/ 1544467 w 1907325"/>
+              <a:gd name="connsiteY1" fmla="*/ 348342 h 4513942"/>
+              <a:gd name="connsiteX2" fmla="*/ 1762181 w 1907325"/>
+              <a:gd name="connsiteY2" fmla="*/ 914400 h 4513942"/>
+              <a:gd name="connsiteX3" fmla="*/ 1776696 w 1907325"/>
+              <a:gd name="connsiteY3" fmla="*/ 1524000 h 4513942"/>
+              <a:gd name="connsiteX4" fmla="*/ 1500924 w 1907325"/>
+              <a:gd name="connsiteY4" fmla="*/ 2206171 h 4513942"/>
+              <a:gd name="connsiteX5" fmla="*/ 1297724 w 1907325"/>
+              <a:gd name="connsiteY5" fmla="*/ 2496457 h 4513942"/>
+              <a:gd name="connsiteX6" fmla="*/ 572010 w 1907325"/>
+              <a:gd name="connsiteY6" fmla="*/ 2772228 h 4513942"/>
+              <a:gd name="connsiteX7" fmla="*/ 281724 w 1907325"/>
+              <a:gd name="connsiteY7" fmla="*/ 2714171 h 4513942"/>
+              <a:gd name="connsiteX8" fmla="*/ 5953 w 1907325"/>
+              <a:gd name="connsiteY8" fmla="*/ 2119085 h 4513942"/>
+              <a:gd name="connsiteX9" fmla="*/ 20467 w 1907325"/>
+              <a:gd name="connsiteY9" fmla="*/ 1640114 h 4513942"/>
+              <a:gd name="connsiteX10" fmla="*/ 194638 w 1907325"/>
+              <a:gd name="connsiteY10" fmla="*/ 1364342 h 4513942"/>
+              <a:gd name="connsiteX11" fmla="*/ 891324 w 1907325"/>
+              <a:gd name="connsiteY11" fmla="*/ 1088571 h 4513942"/>
+              <a:gd name="connsiteX12" fmla="*/ 1181610 w 1907325"/>
+              <a:gd name="connsiteY12" fmla="*/ 1059542 h 4513942"/>
+              <a:gd name="connsiteX13" fmla="*/ 1370296 w 1907325"/>
+              <a:gd name="connsiteY13" fmla="*/ 1103085 h 4513942"/>
+              <a:gd name="connsiteX14" fmla="*/ 1646067 w 1907325"/>
+              <a:gd name="connsiteY14" fmla="*/ 1320800 h 4513942"/>
+              <a:gd name="connsiteX15" fmla="*/ 1747667 w 1907325"/>
+              <a:gd name="connsiteY15" fmla="*/ 1640114 h 4513942"/>
+              <a:gd name="connsiteX16" fmla="*/ 1892810 w 1907325"/>
+              <a:gd name="connsiteY16" fmla="*/ 2249714 h 4513942"/>
+              <a:gd name="connsiteX17" fmla="*/ 1805724 w 1907325"/>
+              <a:gd name="connsiteY17" fmla="*/ 3135085 h 4513942"/>
+              <a:gd name="connsiteX18" fmla="*/ 1660581 w 1907325"/>
+              <a:gd name="connsiteY18" fmla="*/ 3614057 h 4513942"/>
+              <a:gd name="connsiteX19" fmla="*/ 1399324 w 1907325"/>
+              <a:gd name="connsiteY19" fmla="*/ 3947885 h 4513942"/>
+              <a:gd name="connsiteX20" fmla="*/ 1283210 w 1907325"/>
+              <a:gd name="connsiteY20" fmla="*/ 4122057 h 4513942"/>
+              <a:gd name="connsiteX21" fmla="*/ 1196124 w 1907325"/>
+              <a:gd name="connsiteY21" fmla="*/ 4397828 h 4513942"/>
+              <a:gd name="connsiteX22" fmla="*/ 1152581 w 1907325"/>
+              <a:gd name="connsiteY22" fmla="*/ 4513942 h 4513942"/>
+            </a:gdLst>
+            <a:ahLst/>
+            <a:cxnLst>
+              <a:cxn ang="0">
+                <a:pos x="connsiteX0" y="connsiteY0"/>
+              </a:cxn>
+              <a:cxn ang="0">
+                <a:pos x="connsiteX1" y="connsiteY1"/>
+              </a:cxn>
+              <a:cxn ang="0">
+                <a:pos x="connsiteX2" y="connsiteY2"/>
+              </a:cxn>
+              <a:cxn ang="0">
+                <a:pos x="connsiteX3" y="connsiteY3"/>
+              </a:cxn>
+              <a:cxn ang="0">
+                <a:pos x="connsiteX4" y="connsiteY4"/>
+              </a:cxn>
+              <a:cxn ang="0">
+                <a:pos x="connsiteX5" y="connsiteY5"/>
+              </a:cxn>
+              <a:cxn ang="0">
+                <a:pos x="connsiteX6" y="connsiteY6"/>
+              </a:cxn>
+              <a:cxn ang="0">
+                <a:pos x="connsiteX7" y="connsiteY7"/>
+              </a:cxn>
+              <a:cxn ang="0">
+                <a:pos x="connsiteX8" y="connsiteY8"/>
+              </a:cxn>
+              <a:cxn ang="0">
+                <a:pos x="connsiteX9" y="connsiteY9"/>
+              </a:cxn>
+              <a:cxn ang="0">
+                <a:pos x="connsiteX10" y="connsiteY10"/>
+              </a:cxn>
+              <a:cxn ang="0">
+                <a:pos x="connsiteX11" y="connsiteY11"/>
+              </a:cxn>
+              <a:cxn ang="0">
+                <a:pos x="connsiteX12" y="connsiteY12"/>
+              </a:cxn>
+              <a:cxn ang="0">
+                <a:pos x="connsiteX13" y="connsiteY13"/>
+              </a:cxn>
+              <a:cxn ang="0">
+                <a:pos x="connsiteX14" y="connsiteY14"/>
+              </a:cxn>
+              <a:cxn ang="0">
+                <a:pos x="connsiteX15" y="connsiteY15"/>
+              </a:cxn>
+              <a:cxn ang="0">
+                <a:pos x="connsiteX16" y="connsiteY16"/>
+              </a:cxn>
+              <a:cxn ang="0">
+                <a:pos x="connsiteX17" y="connsiteY17"/>
+              </a:cxn>
+              <a:cxn ang="0">
+                <a:pos x="connsiteX18" y="connsiteY18"/>
+              </a:cxn>
+              <a:cxn ang="0">
+                <a:pos x="connsiteX19" y="connsiteY19"/>
+              </a:cxn>
+              <a:cxn ang="0">
+                <a:pos x="connsiteX20" y="connsiteY20"/>
+              </a:cxn>
+              <a:cxn ang="0">
+                <a:pos x="connsiteX21" y="connsiteY21"/>
+              </a:cxn>
+              <a:cxn ang="0">
+                <a:pos x="connsiteX22" y="connsiteY22"/>
+              </a:cxn>
+            </a:cxnLst>
+            <a:rect l="l" t="t" r="r" b="b"/>
+            <a:pathLst>
+              <a:path w="1907325" h="4513942">
+                <a:moveTo>
+                  <a:pt x="1268696" y="0"/>
+                </a:moveTo>
+                <a:cubicBezTo>
+                  <a:pt x="1442773" y="124340"/>
+                  <a:pt x="1389854" y="67227"/>
+                  <a:pt x="1544467" y="348342"/>
+                </a:cubicBezTo>
+                <a:cubicBezTo>
+                  <a:pt x="1699367" y="629979"/>
+                  <a:pt x="1682866" y="628863"/>
+                  <a:pt x="1762181" y="914400"/>
+                </a:cubicBezTo>
+                <a:cubicBezTo>
+                  <a:pt x="1776471" y="1078734"/>
+                  <a:pt x="1815799" y="1351947"/>
+                  <a:pt x="1776696" y="1524000"/>
+                </a:cubicBezTo>
+                <a:cubicBezTo>
+                  <a:pt x="1747705" y="1651561"/>
+                  <a:pt x="1570804" y="2083882"/>
+                  <a:pt x="1500924" y="2206171"/>
+                </a:cubicBezTo>
+                <a:cubicBezTo>
+                  <a:pt x="1442324" y="2308722"/>
+                  <a:pt x="1384895" y="2416758"/>
+                  <a:pt x="1297724" y="2496457"/>
+                </a:cubicBezTo>
+                <a:cubicBezTo>
+                  <a:pt x="1086760" y="2689339"/>
+                  <a:pt x="836364" y="2708418"/>
+                  <a:pt x="572010" y="2772228"/>
+                </a:cubicBezTo>
+                <a:cubicBezTo>
+                  <a:pt x="475248" y="2752876"/>
+                  <a:pt x="368793" y="2760608"/>
+                  <a:pt x="281724" y="2714171"/>
+                </a:cubicBezTo>
+                <a:cubicBezTo>
+                  <a:pt x="101836" y="2618231"/>
+                  <a:pt x="43703" y="2240724"/>
+                  <a:pt x="5953" y="2119085"/>
+                </a:cubicBezTo>
+                <a:cubicBezTo>
+                  <a:pt x="10791" y="1959428"/>
+                  <a:pt x="-18273" y="1795075"/>
+                  <a:pt x="20467" y="1640114"/>
+                </a:cubicBezTo>
+                <a:cubicBezTo>
+                  <a:pt x="46836" y="1534637"/>
+                  <a:pt x="119120" y="1442557"/>
+                  <a:pt x="194638" y="1364342"/>
+                </a:cubicBezTo>
+                <a:cubicBezTo>
+                  <a:pt x="353037" y="1200286"/>
+                  <a:pt x="709339" y="1127068"/>
+                  <a:pt x="891324" y="1088571"/>
+                </a:cubicBezTo>
+                <a:cubicBezTo>
+                  <a:pt x="986463" y="1068445"/>
+                  <a:pt x="1084848" y="1069218"/>
+                  <a:pt x="1181610" y="1059542"/>
+                </a:cubicBezTo>
+                <a:cubicBezTo>
+                  <a:pt x="1244505" y="1074056"/>
+                  <a:pt x="1310554" y="1078645"/>
+                  <a:pt x="1370296" y="1103085"/>
+                </a:cubicBezTo>
+                <a:cubicBezTo>
+                  <a:pt x="1458125" y="1139015"/>
+                  <a:pt x="1582620" y="1263698"/>
+                  <a:pt x="1646067" y="1320800"/>
+                </a:cubicBezTo>
+                <a:cubicBezTo>
+                  <a:pt x="1679934" y="1427238"/>
+                  <a:pt x="1718992" y="1532161"/>
+                  <a:pt x="1747667" y="1640114"/>
+                </a:cubicBezTo>
+                <a:cubicBezTo>
+                  <a:pt x="1801291" y="1841994"/>
+                  <a:pt x="1892810" y="2249714"/>
+                  <a:pt x="1892810" y="2249714"/>
+                </a:cubicBezTo>
+                <a:cubicBezTo>
+                  <a:pt x="1912101" y="2693420"/>
+                  <a:pt x="1933113" y="2603050"/>
+                  <a:pt x="1805724" y="3135085"/>
+                </a:cubicBezTo>
+                <a:cubicBezTo>
+                  <a:pt x="1766878" y="3297326"/>
+                  <a:pt x="1735188" y="3464843"/>
+                  <a:pt x="1660581" y="3614057"/>
+                </a:cubicBezTo>
+                <a:cubicBezTo>
+                  <a:pt x="1597389" y="3740441"/>
+                  <a:pt x="1483586" y="3834456"/>
+                  <a:pt x="1399324" y="3947885"/>
+                </a:cubicBezTo>
+                <a:cubicBezTo>
+                  <a:pt x="1357715" y="4003897"/>
+                  <a:pt x="1321915" y="4064000"/>
+                  <a:pt x="1283210" y="4122057"/>
+                </a:cubicBezTo>
+                <a:cubicBezTo>
+                  <a:pt x="1254181" y="4213981"/>
+                  <a:pt x="1226608" y="4306377"/>
+                  <a:pt x="1196124" y="4397828"/>
+                </a:cubicBezTo>
+                <a:cubicBezTo>
+                  <a:pt x="1183052" y="4437043"/>
+                  <a:pt x="1152581" y="4513942"/>
+                  <a:pt x="1152581" y="4513942"/>
+                </a:cubicBezTo>
+              </a:path>
+            </a:pathLst>
+          </a:custGeom>
+          <a:noFill/>
+          <a:ln w="76200"/>
+        </p:spPr>
+        <p:style>
+          <a:lnRef idx="2">
+            <a:schemeClr val="accent1">
+              <a:shade val="15000"/>
+            </a:schemeClr>
+          </a:lnRef>
+          <a:fillRef idx="1">
+            <a:schemeClr val="accent1"/>
+          </a:fillRef>
+          <a:effectRef idx="0">
+            <a:schemeClr val="accent1"/>
+          </a:effectRef>
+          <a:fontRef idx="minor">
+            <a:schemeClr val="lt1"/>
+          </a:fontRef>
+        </p:style>
+        <p:txBody>
+          <a:bodyPr rtlCol="0" anchor="ctr"/>
+          <a:lstStyle/>
+          <a:p>
+            <a:pPr algn="ctr"/>
+            <a:endParaRPr lang="en-US"/>
+          </a:p>
+        </p:txBody>
+      </p:sp>
+    </p:spTree>
+    <p:extLst>
+      <p:ext uri="{BB962C8B-B14F-4D97-AF65-F5344CB8AC3E}">
+        <p14:creationId xmlns:p14="http://schemas.microsoft.com/office/powerpoint/2010/main" val="2669852479"/>
       </p:ext>
     </p:extLst>
   </p:cSld>
@@ -5711,7 +8373,7 @@
           <p:nvPr/>
         </p:nvPicPr>
         <p:blipFill>
-          <a:blip r:embed="rId2"/>
+          <a:blip/>
           <a:stretch>
             <a:fillRect/>
           </a:stretch>
@@ -6788,7 +9450,7 @@
           <p:nvPr/>
         </p:nvPicPr>
         <p:blipFill>
-          <a:blip r:embed="rId2">
+          <a:blip>
             <a:extLst>
               <a:ext uri="{28A0092B-C50C-407E-A947-70E740481C1C}">
                 <a14:useLocalDpi xmlns:a14="http://schemas.microsoft.com/office/drawing/2010/main" val="0"/>
@@ -6860,7 +9522,7 @@
           <p:nvPr/>
         </p:nvPicPr>
         <p:blipFill>
-          <a:blip r:embed="rId2"/>
+          <a:blip/>
           <a:stretch>
             <a:fillRect/>
           </a:stretch>
@@ -6885,13 +9547,13 @@
   <p:clrMapOvr>
     <a:masterClrMapping/>
   </p:clrMapOvr>
-  <mc:AlternateContent xmlns:mc="http://schemas.openxmlformats.org/markup-compatibility/2006">
-    <mc:Choice xmlns:p14="http://schemas.microsoft.com/office/powerpoint/2010/main" Requires="p14">
+  <mc:AlternateContent xmlns:mc="http://schemas.openxmlformats.org/markup-compatibility/2006" xmlns:p14="http://schemas.microsoft.com/office/powerpoint/2010/main">
+    <mc:Choice Requires="p14">
       <p:transition spd="med" p14:dur="700">
         <p:fade/>
       </p:transition>
     </mc:Choice>
-    <mc:Fallback>
+    <mc:Fallback xmlns="">
       <p:transition spd="med">
         <p:fade/>
       </p:transition>
@@ -7000,13 +9662,13 @@
   <p:clrMapOvr>
     <a:masterClrMapping/>
   </p:clrMapOvr>
-  <mc:AlternateContent xmlns:mc="http://schemas.openxmlformats.org/markup-compatibility/2006">
-    <mc:Choice xmlns:p159="http://schemas.microsoft.com/office/powerpoint/2015/09/main" Requires="p159">
+  <mc:AlternateContent xmlns:mc="http://schemas.openxmlformats.org/markup-compatibility/2006" xmlns:p159="http://schemas.microsoft.com/office/powerpoint/2015/09/main">
+    <mc:Choice Requires="p159">
       <p:transition xmlns:p14="http://schemas.microsoft.com/office/powerpoint/2010/main" spd="slow" p14:dur="2000">
         <p159:morph option="byObject"/>
       </p:transition>
     </mc:Choice>
-    <mc:Fallback>
+    <mc:Fallback xmlns="">
       <p:transition spd="slow">
         <p:fade/>
       </p:transition>
@@ -7887,7 +10549,7 @@
           <p:nvPr/>
         </p:nvPicPr>
         <p:blipFill>
-          <a:blip r:embed="rId2"/>
+          <a:blip/>
           <a:stretch>
             <a:fillRect/>
           </a:stretch>
@@ -7997,7 +10659,7 @@
           <p:nvPr/>
         </p:nvPicPr>
         <p:blipFill>
-          <a:blip r:embed="rId2">
+          <a:blip>
             <a:extLst>
               <a:ext uri="{28A0092B-C50C-407E-A947-70E740481C1C}">
                 <a14:useLocalDpi xmlns:a14="http://schemas.microsoft.com/office/drawing/2010/main" val="0"/>
@@ -8033,7 +10695,7 @@
           <p:nvPr/>
         </p:nvPicPr>
         <p:blipFill>
-          <a:blip r:embed="rId3"/>
+          <a:blip/>
           <a:stretch>
             <a:fillRect/>
           </a:stretch>

</xml_diff>

<commit_message>
fixes broken powerpoint (hellscape)
</commit_message>
<xml_diff>
--- a/Python/CONTROL FLOW STRUCTURES (lessons #7 - )/Lesson +#7 - Making decisions (CFGs).pptx
+++ b/Python/CONTROL FLOW STRUCTURES (lessons #7 - )/Lesson +#7 - Making decisions (CFGs).pptx
@@ -15,9 +15,9 @@
     <p:sldId id="262" r:id="rId9"/>
     <p:sldId id="265" r:id="rId10"/>
     <p:sldId id="266" r:id="rId11"/>
-    <p:sldId id="260" r:id="rId12"/>
-    <p:sldId id="261" r:id="rId13"/>
-    <p:sldId id="270" r:id="rId14"/>
+    <p:sldId id="270" r:id="rId12"/>
+    <p:sldId id="273" r:id="rId13"/>
+    <p:sldId id="271" r:id="rId14"/>
   </p:sldIdLst>
   <p:sldSz cx="12192000" cy="6858000"/>
   <p:notesSz cx="6858000" cy="9144000"/>
@@ -273,7 +273,7 @@
           <a:p>
             <a:fld id="{E87FDB18-98E6-4A2B-A3F6-0B25054C7CB3}" type="datetimeFigureOut">
               <a:rPr lang="en-US" smtClean="0"/>
-              <a:t>4/20/2026</a:t>
+              <a:t>4/21/2026</a:t>
             </a:fld>
             <a:endParaRPr lang="en-US"/>
           </a:p>
@@ -473,7 +473,7 @@
           <a:p>
             <a:fld id="{E87FDB18-98E6-4A2B-A3F6-0B25054C7CB3}" type="datetimeFigureOut">
               <a:rPr lang="en-US" smtClean="0"/>
-              <a:t>4/20/2026</a:t>
+              <a:t>4/21/2026</a:t>
             </a:fld>
             <a:endParaRPr lang="en-US"/>
           </a:p>
@@ -683,7 +683,7 @@
           <a:p>
             <a:fld id="{E87FDB18-98E6-4A2B-A3F6-0B25054C7CB3}" type="datetimeFigureOut">
               <a:rPr lang="en-US" smtClean="0"/>
-              <a:t>4/20/2026</a:t>
+              <a:t>4/21/2026</a:t>
             </a:fld>
             <a:endParaRPr lang="en-US"/>
           </a:p>
@@ -883,7 +883,7 @@
           <a:p>
             <a:fld id="{E87FDB18-98E6-4A2B-A3F6-0B25054C7CB3}" type="datetimeFigureOut">
               <a:rPr lang="en-US" smtClean="0"/>
-              <a:t>4/20/2026</a:t>
+              <a:t>4/21/2026</a:t>
             </a:fld>
             <a:endParaRPr lang="en-US"/>
           </a:p>
@@ -1159,7 +1159,7 @@
           <a:p>
             <a:fld id="{E87FDB18-98E6-4A2B-A3F6-0B25054C7CB3}" type="datetimeFigureOut">
               <a:rPr lang="en-US" smtClean="0"/>
-              <a:t>4/20/2026</a:t>
+              <a:t>4/21/2026</a:t>
             </a:fld>
             <a:endParaRPr lang="en-US"/>
           </a:p>
@@ -1427,7 +1427,7 @@
           <a:p>
             <a:fld id="{E87FDB18-98E6-4A2B-A3F6-0B25054C7CB3}" type="datetimeFigureOut">
               <a:rPr lang="en-US" smtClean="0"/>
-              <a:t>4/20/2026</a:t>
+              <a:t>4/21/2026</a:t>
             </a:fld>
             <a:endParaRPr lang="en-US"/>
           </a:p>
@@ -1842,7 +1842,7 @@
           <a:p>
             <a:fld id="{E87FDB18-98E6-4A2B-A3F6-0B25054C7CB3}" type="datetimeFigureOut">
               <a:rPr lang="en-US" smtClean="0"/>
-              <a:t>4/20/2026</a:t>
+              <a:t>4/21/2026</a:t>
             </a:fld>
             <a:endParaRPr lang="en-US"/>
           </a:p>
@@ -1984,7 +1984,7 @@
           <a:p>
             <a:fld id="{E87FDB18-98E6-4A2B-A3F6-0B25054C7CB3}" type="datetimeFigureOut">
               <a:rPr lang="en-US" smtClean="0"/>
-              <a:t>4/20/2026</a:t>
+              <a:t>4/21/2026</a:t>
             </a:fld>
             <a:endParaRPr lang="en-US"/>
           </a:p>
@@ -2097,7 +2097,7 @@
           <a:p>
             <a:fld id="{E87FDB18-98E6-4A2B-A3F6-0B25054C7CB3}" type="datetimeFigureOut">
               <a:rPr lang="en-US" smtClean="0"/>
-              <a:t>4/20/2026</a:t>
+              <a:t>4/21/2026</a:t>
             </a:fld>
             <a:endParaRPr lang="en-US"/>
           </a:p>
@@ -2410,7 +2410,7 @@
           <a:p>
             <a:fld id="{E87FDB18-98E6-4A2B-A3F6-0B25054C7CB3}" type="datetimeFigureOut">
               <a:rPr lang="en-US" smtClean="0"/>
-              <a:t>4/20/2026</a:t>
+              <a:t>4/21/2026</a:t>
             </a:fld>
             <a:endParaRPr lang="en-US"/>
           </a:p>
@@ -2699,7 +2699,7 @@
           <a:p>
             <a:fld id="{E87FDB18-98E6-4A2B-A3F6-0B25054C7CB3}" type="datetimeFigureOut">
               <a:rPr lang="en-US" smtClean="0"/>
-              <a:t>4/20/2026</a:t>
+              <a:t>4/21/2026</a:t>
             </a:fld>
             <a:endParaRPr lang="en-US"/>
           </a:p>
@@ -2942,7 +2942,7 @@
           <a:p>
             <a:fld id="{E87FDB18-98E6-4A2B-A3F6-0B25054C7CB3}" type="datetimeFigureOut">
               <a:rPr lang="en-US" smtClean="0"/>
-              <a:t>4/20/2026</a:t>
+              <a:t>4/21/2026</a:t>
             </a:fld>
             <a:endParaRPr lang="en-US"/>
           </a:p>
@@ -5025,7 +5025,7 @@
     </p:spTree>
     <p:extLst>
       <p:ext uri="{BB962C8B-B14F-4D97-AF65-F5344CB8AC3E}">
-        <p14:creationId xmlns:p14="http://schemas.microsoft.com/office/powerpoint/2010/main" val="1858723434"/>
+        <p14:creationId xmlns:p14="http://schemas.microsoft.com/office/powerpoint/2010/main" val="2498668199"/>
       </p:ext>
     </p:extLst>
   </p:cSld>
@@ -6422,7 +6422,7 @@
     </p:spTree>
     <p:extLst>
       <p:ext uri="{BB962C8B-B14F-4D97-AF65-F5344CB8AC3E}">
-        <p14:creationId xmlns:p14="http://schemas.microsoft.com/office/powerpoint/2010/main" val="4045309264"/>
+        <p14:creationId xmlns:p14="http://schemas.microsoft.com/office/powerpoint/2010/main" val="1217666731"/>
       </p:ext>
     </p:extLst>
   </p:cSld>
@@ -7860,7 +7860,7 @@
     </p:spTree>
     <p:extLst>
       <p:ext uri="{BB962C8B-B14F-4D97-AF65-F5344CB8AC3E}">
-        <p14:creationId xmlns:p14="http://schemas.microsoft.com/office/powerpoint/2010/main" val="2669852479"/>
+        <p14:creationId xmlns:p14="http://schemas.microsoft.com/office/powerpoint/2010/main" val="4133559477"/>
       </p:ext>
     </p:extLst>
   </p:cSld>
@@ -8373,7 +8373,7 @@
           <p:nvPr/>
         </p:nvPicPr>
         <p:blipFill>
-          <a:blip/>
+          <a:blip r:embed="rId2"/>
           <a:stretch>
             <a:fillRect/>
           </a:stretch>
@@ -9450,7 +9450,7 @@
           <p:nvPr/>
         </p:nvPicPr>
         <p:blipFill>
-          <a:blip>
+          <a:blip r:embed="rId2">
             <a:extLst>
               <a:ext uri="{28A0092B-C50C-407E-A947-70E740481C1C}">
                 <a14:useLocalDpi xmlns:a14="http://schemas.microsoft.com/office/drawing/2010/main" val="0"/>
@@ -9522,7 +9522,7 @@
           <p:nvPr/>
         </p:nvPicPr>
         <p:blipFill>
-          <a:blip/>
+          <a:blip r:embed="rId2"/>
           <a:stretch>
             <a:fillRect/>
           </a:stretch>
@@ -10549,7 +10549,7 @@
           <p:nvPr/>
         </p:nvPicPr>
         <p:blipFill>
-          <a:blip/>
+          <a:blip r:embed="rId2"/>
           <a:stretch>
             <a:fillRect/>
           </a:stretch>
@@ -10659,7 +10659,7 @@
           <p:nvPr/>
         </p:nvPicPr>
         <p:blipFill>
-          <a:blip>
+          <a:blip r:embed="rId2">
             <a:extLst>
               <a:ext uri="{28A0092B-C50C-407E-A947-70E740481C1C}">
                 <a14:useLocalDpi xmlns:a14="http://schemas.microsoft.com/office/drawing/2010/main" val="0"/>
@@ -10695,7 +10695,7 @@
           <p:nvPr/>
         </p:nvPicPr>
         <p:blipFill>
-          <a:blip/>
+          <a:blip r:embed="rId3"/>
           <a:stretch>
             <a:fillRect/>
           </a:stretch>

</xml_diff>